<commit_message>
Cierre de caso para docente
</commit_message>
<xml_diff>
--- a/public/dist/img/update/Presentación1.pptx
+++ b/public/dist/img/update/Presentación1.pptx
@@ -5,8 +5,9 @@
     <p:sldMasterId id="2147483720" r:id="rId1"/>
   </p:sldMasterIdLst>
   <p:sldIdLst>
-    <p:sldId id="256" r:id="rId2"/>
-    <p:sldId id="258" r:id="rId3"/>
+    <p:sldId id="259" r:id="rId2"/>
+    <p:sldId id="256" r:id="rId3"/>
+    <p:sldId id="258" r:id="rId4"/>
   </p:sldIdLst>
   <p:sldSz cx="12192000" cy="6858000"/>
   <p:notesSz cx="6858000" cy="9144000"/>
@@ -105,6 +106,11 @@
       </a:defRPr>
     </a:lvl9pPr>
   </p:defaultTextStyle>
+  <p:extLst>
+    <p:ext uri="{EFAFB233-063F-42B5-8137-9DF3F51BA10A}">
+      <p15:sldGuideLst xmlns:p15="http://schemas.microsoft.com/office/powerpoint/2012/main"/>
+    </p:ext>
+  </p:extLst>
 </p:presentation>
 </file>
 
@@ -257,7 +263,7 @@
           <a:p>
             <a:fld id="{F7EB7AD6-F7F4-4A3B-9140-B8481AFC5E85}" type="datetimeFigureOut">
               <a:rPr lang="es-CO" smtClean="0"/>
-              <a:t>24/04/2023</a:t>
+              <a:t>23/05/2023</a:t>
             </a:fld>
             <a:endParaRPr lang="es-CO"/>
           </a:p>
@@ -457,7 +463,7 @@
           <a:p>
             <a:fld id="{F7EB7AD6-F7F4-4A3B-9140-B8481AFC5E85}" type="datetimeFigureOut">
               <a:rPr lang="es-CO" smtClean="0"/>
-              <a:t>24/04/2023</a:t>
+              <a:t>23/05/2023</a:t>
             </a:fld>
             <a:endParaRPr lang="es-CO"/>
           </a:p>
@@ -667,7 +673,7 @@
           <a:p>
             <a:fld id="{F7EB7AD6-F7F4-4A3B-9140-B8481AFC5E85}" type="datetimeFigureOut">
               <a:rPr lang="es-CO" smtClean="0"/>
-              <a:t>24/04/2023</a:t>
+              <a:t>23/05/2023</a:t>
             </a:fld>
             <a:endParaRPr lang="es-CO"/>
           </a:p>
@@ -867,7 +873,7 @@
           <a:p>
             <a:fld id="{F7EB7AD6-F7F4-4A3B-9140-B8481AFC5E85}" type="datetimeFigureOut">
               <a:rPr lang="es-CO" smtClean="0"/>
-              <a:t>24/04/2023</a:t>
+              <a:t>23/05/2023</a:t>
             </a:fld>
             <a:endParaRPr lang="es-CO"/>
           </a:p>
@@ -1143,7 +1149,7 @@
           <a:p>
             <a:fld id="{F7EB7AD6-F7F4-4A3B-9140-B8481AFC5E85}" type="datetimeFigureOut">
               <a:rPr lang="es-CO" smtClean="0"/>
-              <a:t>24/04/2023</a:t>
+              <a:t>23/05/2023</a:t>
             </a:fld>
             <a:endParaRPr lang="es-CO"/>
           </a:p>
@@ -1411,7 +1417,7 @@
           <a:p>
             <a:fld id="{F7EB7AD6-F7F4-4A3B-9140-B8481AFC5E85}" type="datetimeFigureOut">
               <a:rPr lang="es-CO" smtClean="0"/>
-              <a:t>24/04/2023</a:t>
+              <a:t>23/05/2023</a:t>
             </a:fld>
             <a:endParaRPr lang="es-CO"/>
           </a:p>
@@ -1826,7 +1832,7 @@
           <a:p>
             <a:fld id="{F7EB7AD6-F7F4-4A3B-9140-B8481AFC5E85}" type="datetimeFigureOut">
               <a:rPr lang="es-CO" smtClean="0"/>
-              <a:t>24/04/2023</a:t>
+              <a:t>23/05/2023</a:t>
             </a:fld>
             <a:endParaRPr lang="es-CO"/>
           </a:p>
@@ -1968,7 +1974,7 @@
           <a:p>
             <a:fld id="{F7EB7AD6-F7F4-4A3B-9140-B8481AFC5E85}" type="datetimeFigureOut">
               <a:rPr lang="es-CO" smtClean="0"/>
-              <a:t>24/04/2023</a:t>
+              <a:t>23/05/2023</a:t>
             </a:fld>
             <a:endParaRPr lang="es-CO"/>
           </a:p>
@@ -2081,7 +2087,7 @@
           <a:p>
             <a:fld id="{F7EB7AD6-F7F4-4A3B-9140-B8481AFC5E85}" type="datetimeFigureOut">
               <a:rPr lang="es-CO" smtClean="0"/>
-              <a:t>24/04/2023</a:t>
+              <a:t>23/05/2023</a:t>
             </a:fld>
             <a:endParaRPr lang="es-CO"/>
           </a:p>
@@ -2394,7 +2400,7 @@
           <a:p>
             <a:fld id="{F7EB7AD6-F7F4-4A3B-9140-B8481AFC5E85}" type="datetimeFigureOut">
               <a:rPr lang="es-CO" smtClean="0"/>
-              <a:t>24/04/2023</a:t>
+              <a:t>23/05/2023</a:t>
             </a:fld>
             <a:endParaRPr lang="es-CO"/>
           </a:p>
@@ -2683,7 +2689,7 @@
           <a:p>
             <a:fld id="{F7EB7AD6-F7F4-4A3B-9140-B8481AFC5E85}" type="datetimeFigureOut">
               <a:rPr lang="es-CO" smtClean="0"/>
-              <a:t>24/04/2023</a:t>
+              <a:t>23/05/2023</a:t>
             </a:fld>
             <a:endParaRPr lang="es-CO"/>
           </a:p>
@@ -2926,7 +2932,7 @@
           <a:p>
             <a:fld id="{F7EB7AD6-F7F4-4A3B-9140-B8481AFC5E85}" type="datetimeFigureOut">
               <a:rPr lang="es-CO" smtClean="0"/>
-              <a:t>24/04/2023</a:t>
+              <a:t>23/05/2023</a:t>
             </a:fld>
             <a:endParaRPr lang="es-CO"/>
           </a:p>
@@ -3332,9 +3338,8 @@
     <p:bg>
       <p:bgPr>
         <a:solidFill>
-          <a:schemeClr val="tx1">
-            <a:lumMod val="65000"/>
-            <a:lumOff val="35000"/>
+          <a:schemeClr val="bg1">
+            <a:alpha val="40000"/>
           </a:schemeClr>
         </a:solidFill>
         <a:effectLst/>
@@ -3411,8 +3416,8 @@
             <a:avLst/>
           </a:prstGeom>
           <a:solidFill>
-            <a:srgbClr val="1AA513">
-              <a:alpha val="31765"/>
+            <a:srgbClr val="FF0066">
+              <a:alpha val="38000"/>
             </a:srgbClr>
           </a:solidFill>
           <a:ln>
@@ -3459,7 +3464,7 @@
         <p:spPr>
           <a:xfrm>
             <a:off x="269496" y="1005125"/>
-            <a:ext cx="5205500" cy="4847749"/>
+            <a:ext cx="5205500" cy="1771293"/>
           </a:xfrm>
           <a:prstGeom prst="round2SameRect">
             <a:avLst>
@@ -3489,7 +3494,7 @@
             </a:pPr>
             <a:r>
               <a:rPr lang="es-CO" b="1" dirty="0"/>
-              <a:t>Al cerrar el corte se aplicaran notas a aquellos casos de seguimiento que después de 30 días de asignado NO tienen actuaciones (o anexos). También a aquellos que tienen entre una actuación y otra mas de 30 días. </a:t>
+              <a:t>Al cerrar el corte se aplicaran notas a aquellos casos que después de asignado tenga mas de 5 días en redactar los datos del caso o respuesta del estudiante. </a:t>
             </a:r>
           </a:p>
           <a:p>
@@ -3497,38 +3502,7 @@
               <a:buFont typeface="Wingdings" panose="05000000000000000000" pitchFamily="2" charset="2"/>
               <a:buChar char="Ø"/>
             </a:pPr>
-            <a:r>
-              <a:rPr lang="es-CO" b="1" dirty="0"/>
-              <a:t>En el reporte de notas usted podrá ver de manera detallada el motivo de la nota. Si la nota se aplicó por lo expresado en el </a:t>
-            </a:r>
-            <a:r>
-              <a:rPr lang="es-CO" b="1" dirty="0" err="1"/>
-              <a:t>item</a:t>
-            </a:r>
-            <a:r>
-              <a:rPr lang="es-CO" b="1" dirty="0"/>
-              <a:t> anterior el sistema le indica el periodo evaluado.</a:t>
-            </a:r>
-          </a:p>
-          <a:p>
-            <a:pPr marL="285750" indent="-285750" algn="just">
-              <a:buFont typeface="Wingdings" panose="05000000000000000000" pitchFamily="2" charset="2"/>
-              <a:buChar char="Ø"/>
-            </a:pPr>
-            <a:r>
-              <a:rPr lang="es-CO" b="1" dirty="0"/>
-              <a:t>Para verificar el periodo ingrese al caso y en la pestaña de actuaciones, en el listado puede ver la fecha de creación. </a:t>
-            </a:r>
-          </a:p>
-          <a:p>
-            <a:pPr marL="285750" indent="-285750" algn="just">
-              <a:buFont typeface="Wingdings" panose="05000000000000000000" pitchFamily="2" charset="2"/>
-              <a:buChar char="Ø"/>
-            </a:pPr>
-            <a:r>
-              <a:rPr lang="es-CO" b="1" dirty="0"/>
-              <a:t>Recuerde que solo se tendrán en cuenta aquellas actuaciones creadas por el estudiante, mas no las creadas por el docente asesor y aquellos anexos que no estén anulados.</a:t>
-            </a:r>
+            <a:endParaRPr lang="es-CO" b="1" dirty="0"/>
           </a:p>
         </p:txBody>
       </p:sp>
@@ -3638,53 +3612,12 @@
           </a:p>
         </p:txBody>
       </p:sp>
-      <p:pic>
-        <p:nvPicPr>
-          <p:cNvPr id="19" name="Imagen 18">
-            <a:extLst>
-              <a:ext uri="{FF2B5EF4-FFF2-40B4-BE49-F238E27FC236}">
-                <a16:creationId xmlns:a16="http://schemas.microsoft.com/office/drawing/2014/main" id="{9A4DA2B7-9B4A-5FD1-E61F-594084326029}"/>
-              </a:ext>
-            </a:extLst>
-          </p:cNvPr>
-          <p:cNvPicPr>
-            <a:picLocks noChangeAspect="1"/>
-          </p:cNvPicPr>
-          <p:nvPr/>
-        </p:nvPicPr>
-        <p:blipFill>
-          <a:blip r:embed="rId3"/>
-          <a:stretch>
-            <a:fillRect/>
-          </a:stretch>
-        </p:blipFill>
-        <p:spPr>
-          <a:xfrm>
-            <a:off x="5734464" y="301672"/>
-            <a:ext cx="6340732" cy="2900430"/>
-          </a:xfrm>
-          <a:prstGeom prst="roundRect">
-            <a:avLst>
-              <a:gd name="adj" fmla="val 8594"/>
-            </a:avLst>
-          </a:prstGeom>
-          <a:solidFill>
-            <a:srgbClr val="FFFFFF">
-              <a:shade val="85000"/>
-            </a:srgbClr>
-          </a:solidFill>
-          <a:ln>
-            <a:noFill/>
-          </a:ln>
-          <a:effectLst/>
-        </p:spPr>
-      </p:pic>
-      <p:sp>
-        <p:nvSpPr>
-          <p:cNvPr id="20" name="Flecha: arriba y abajo 19">
-            <a:extLst>
-              <a:ext uri="{FF2B5EF4-FFF2-40B4-BE49-F238E27FC236}">
-                <a16:creationId xmlns:a16="http://schemas.microsoft.com/office/drawing/2014/main" id="{B0CFC603-9496-72A3-0EA0-40CAF706B026}"/>
+      <p:sp>
+        <p:nvSpPr>
+          <p:cNvPr id="37" name="Rectángulo: esquinas redondeadas 36">
+            <a:extLst>
+              <a:ext uri="{FF2B5EF4-FFF2-40B4-BE49-F238E27FC236}">
+                <a16:creationId xmlns:a16="http://schemas.microsoft.com/office/drawing/2014/main" id="{0F8C11D3-3C42-C4A7-61A0-5C4948094B3E}"/>
               </a:ext>
             </a:extLst>
           </p:cNvPr>
@@ -3693,14 +3626,14 @@
         </p:nvSpPr>
         <p:spPr>
           <a:xfrm>
-            <a:off x="11264649" y="2162229"/>
-            <a:ext cx="177299" cy="436099"/>
-          </a:xfrm>
-          <a:prstGeom prst="upDownArrow">
+            <a:off x="8374930" y="2742526"/>
+            <a:ext cx="1407114" cy="216977"/>
+          </a:xfrm>
+          <a:prstGeom prst="roundRect">
             <a:avLst/>
           </a:prstGeom>
           <a:solidFill>
-            <a:srgbClr val="00B050"/>
+            <a:schemeClr val="bg1"/>
           </a:solidFill>
           <a:ln>
             <a:noFill/>
@@ -3727,16 +3660,23 @@
           <a:lstStyle/>
           <a:p>
             <a:pPr algn="ctr"/>
-            <a:endParaRPr lang="es-CO"/>
-          </a:p>
-        </p:txBody>
-      </p:sp>
-      <p:sp>
-        <p:nvSpPr>
-          <p:cNvPr id="22" name="Flecha: arriba y abajo 21">
-            <a:extLst>
-              <a:ext uri="{FF2B5EF4-FFF2-40B4-BE49-F238E27FC236}">
-                <a16:creationId xmlns:a16="http://schemas.microsoft.com/office/drawing/2014/main" id="{25A4025E-8E2E-F8EE-A06B-9A4274F7904D}"/>
+            <a:r>
+              <a:rPr lang="es-CO" sz="1600" dirty="0">
+                <a:solidFill>
+                  <a:schemeClr val="tx1"/>
+                </a:solidFill>
+              </a:rPr>
+              <a:t>Conocimiento</a:t>
+            </a:r>
+          </a:p>
+        </p:txBody>
+      </p:sp>
+      <p:sp>
+        <p:nvSpPr>
+          <p:cNvPr id="39" name="Rectángulo: esquinas redondeadas 38">
+            <a:extLst>
+              <a:ext uri="{FF2B5EF4-FFF2-40B4-BE49-F238E27FC236}">
+                <a16:creationId xmlns:a16="http://schemas.microsoft.com/office/drawing/2014/main" id="{ABCBF60F-DDBE-BF0C-0635-73DD99A347C2}"/>
               </a:ext>
             </a:extLst>
           </p:cNvPr>
@@ -3745,14 +3685,14 @@
         </p:nvSpPr>
         <p:spPr>
           <a:xfrm>
-            <a:off x="11264649" y="1328385"/>
-            <a:ext cx="177299" cy="436099"/>
-          </a:xfrm>
-          <a:prstGeom prst="upDownArrow">
+            <a:off x="8374930" y="3096916"/>
+            <a:ext cx="1407114" cy="216977"/>
+          </a:xfrm>
+          <a:prstGeom prst="roundRect">
             <a:avLst/>
           </a:prstGeom>
           <a:solidFill>
-            <a:srgbClr val="00B050"/>
+            <a:schemeClr val="bg1"/>
           </a:solidFill>
           <a:ln>
             <a:noFill/>
@@ -3779,16 +3719,23 @@
           <a:lstStyle/>
           <a:p>
             <a:pPr algn="ctr"/>
-            <a:endParaRPr lang="es-CO" dirty="0"/>
-          </a:p>
-        </p:txBody>
-      </p:sp>
-      <p:sp>
-        <p:nvSpPr>
-          <p:cNvPr id="23" name="Rectángulo: esquinas redondeadas 22">
-            <a:extLst>
-              <a:ext uri="{FF2B5EF4-FFF2-40B4-BE49-F238E27FC236}">
-                <a16:creationId xmlns:a16="http://schemas.microsoft.com/office/drawing/2014/main" id="{9C3D4B20-63DD-3680-857C-38710B747EF8}"/>
+            <a:r>
+              <a:rPr lang="es-CO" sz="1600" dirty="0">
+                <a:solidFill>
+                  <a:schemeClr val="tx1"/>
+                </a:solidFill>
+              </a:rPr>
+              <a:t>Aplicación</a:t>
+            </a:r>
+          </a:p>
+        </p:txBody>
+      </p:sp>
+      <p:sp>
+        <p:nvSpPr>
+          <p:cNvPr id="40" name="Rectángulo: esquinas redondeadas 39">
+            <a:extLst>
+              <a:ext uri="{FF2B5EF4-FFF2-40B4-BE49-F238E27FC236}">
+                <a16:creationId xmlns:a16="http://schemas.microsoft.com/office/drawing/2014/main" id="{554B48CA-F605-55A2-1EF5-77444550B7F6}"/>
               </a:ext>
             </a:extLst>
           </p:cNvPr>
@@ -3797,8 +3744,8 @@
         </p:nvSpPr>
         <p:spPr>
           <a:xfrm>
-            <a:off x="5786412" y="907158"/>
-            <a:ext cx="4810109" cy="705974"/>
+            <a:off x="8374930" y="3447163"/>
+            <a:ext cx="1407114" cy="216977"/>
           </a:xfrm>
           <a:prstGeom prst="roundRect">
             <a:avLst/>
@@ -3832,22 +3779,22 @@
           <a:p>
             <a:pPr algn="ctr"/>
             <a:r>
-              <a:rPr lang="es-CO" dirty="0">
+              <a:rPr lang="es-CO" sz="1600" dirty="0">
                 <a:solidFill>
                   <a:schemeClr val="tx1"/>
                 </a:solidFill>
               </a:rPr>
-              <a:t>ACTUACIÓN 3</a:t>
-            </a:r>
-          </a:p>
-        </p:txBody>
-      </p:sp>
-      <p:sp>
-        <p:nvSpPr>
-          <p:cNvPr id="24" name="Rectángulo: esquinas redondeadas 23">
-            <a:extLst>
-              <a:ext uri="{FF2B5EF4-FFF2-40B4-BE49-F238E27FC236}">
-                <a16:creationId xmlns:a16="http://schemas.microsoft.com/office/drawing/2014/main" id="{31BF783D-3BDF-57A3-102B-B03418B30E08}"/>
+              <a:t>Ética</a:t>
+            </a:r>
+          </a:p>
+        </p:txBody>
+      </p:sp>
+      <p:sp>
+        <p:nvSpPr>
+          <p:cNvPr id="41" name="Rectángulo: esquinas redondeadas 40">
+            <a:extLst>
+              <a:ext uri="{FF2B5EF4-FFF2-40B4-BE49-F238E27FC236}">
+                <a16:creationId xmlns:a16="http://schemas.microsoft.com/office/drawing/2014/main" id="{FB23FACC-0927-6527-8210-9E07CFE76CE3}"/>
               </a:ext>
             </a:extLst>
           </p:cNvPr>
@@ -3856,8 +3803,8 @@
         </p:nvSpPr>
         <p:spPr>
           <a:xfrm>
-            <a:off x="5786412" y="1679484"/>
-            <a:ext cx="4810109" cy="711200"/>
+            <a:off x="8249939" y="3819802"/>
+            <a:ext cx="1407114" cy="216977"/>
           </a:xfrm>
           <a:prstGeom prst="roundRect">
             <a:avLst/>
@@ -3891,296 +3838,51 @@
           <a:p>
             <a:pPr algn="ctr"/>
             <a:r>
-              <a:rPr lang="es-CO" dirty="0">
+              <a:rPr lang="es-CO" sz="1600" dirty="0">
                 <a:solidFill>
                   <a:schemeClr val="tx1"/>
                 </a:solidFill>
               </a:rPr>
-              <a:t>ACTUACIÓN 2</a:t>
-            </a:r>
-          </a:p>
-        </p:txBody>
-      </p:sp>
-      <p:sp>
-        <p:nvSpPr>
-          <p:cNvPr id="25" name="Rectángulo: esquinas redondeadas 24">
-            <a:extLst>
-              <a:ext uri="{FF2B5EF4-FFF2-40B4-BE49-F238E27FC236}">
-                <a16:creationId xmlns:a16="http://schemas.microsoft.com/office/drawing/2014/main" id="{60382C07-4DC0-C195-ADC4-E8177385D3F6}"/>
-              </a:ext>
-            </a:extLst>
-          </p:cNvPr>
-          <p:cNvSpPr/>
+              <a:t>Concepto</a:t>
+            </a:r>
+          </a:p>
+        </p:txBody>
+      </p:sp>
+      <p:pic>
+        <p:nvPicPr>
+          <p:cNvPr id="3" name="Imagen 2">
+            <a:extLst>
+              <a:ext uri="{FF2B5EF4-FFF2-40B4-BE49-F238E27FC236}">
+                <a16:creationId xmlns:a16="http://schemas.microsoft.com/office/drawing/2014/main" id="{995671C8-3B28-B2CD-FF83-79ACF9D3783E}"/>
+              </a:ext>
+            </a:extLst>
+          </p:cNvPr>
+          <p:cNvPicPr>
+            <a:picLocks noChangeAspect="1"/>
+          </p:cNvPicPr>
           <p:nvPr/>
-        </p:nvSpPr>
-        <p:spPr>
-          <a:xfrm>
-            <a:off x="5786412" y="2440103"/>
-            <a:ext cx="4810109" cy="711200"/>
-          </a:xfrm>
-          <a:prstGeom prst="roundRect">
+        </p:nvPicPr>
+        <p:blipFill rotWithShape="1">
+          <a:blip r:embed="rId3"/>
+          <a:srcRect r="36561"/>
+          <a:stretch/>
+        </p:blipFill>
+        <p:spPr>
+          <a:xfrm>
+            <a:off x="5617660" y="1265356"/>
+            <a:ext cx="6574340" cy="4645114"/>
+          </a:xfrm>
+          <a:prstGeom prst="rect">
             <a:avLst/>
           </a:prstGeom>
-          <a:solidFill>
-            <a:schemeClr val="bg1"/>
-          </a:solidFill>
-          <a:ln>
-            <a:noFill/>
-          </a:ln>
-        </p:spPr>
-        <p:style>
-          <a:lnRef idx="2">
-            <a:schemeClr val="accent1">
-              <a:shade val="50000"/>
-            </a:schemeClr>
-          </a:lnRef>
-          <a:fillRef idx="1">
-            <a:schemeClr val="accent1"/>
-          </a:fillRef>
-          <a:effectRef idx="0">
-            <a:schemeClr val="accent1"/>
-          </a:effectRef>
-          <a:fontRef idx="minor">
-            <a:schemeClr val="lt1"/>
-          </a:fontRef>
-        </p:style>
-        <p:txBody>
-          <a:bodyPr rtlCol="0" anchor="ctr"/>
-          <a:lstStyle/>
-          <a:p>
-            <a:pPr algn="ctr"/>
-            <a:r>
-              <a:rPr lang="es-CO" dirty="0">
-                <a:solidFill>
-                  <a:schemeClr val="tx1"/>
-                </a:solidFill>
-              </a:rPr>
-              <a:t>ACTUACIÓN 1</a:t>
-            </a:r>
-          </a:p>
-        </p:txBody>
-      </p:sp>
-      <p:sp>
-        <p:nvSpPr>
-          <p:cNvPr id="31" name="Rectángulo: esquinas redondeadas 30">
-            <a:extLst>
-              <a:ext uri="{FF2B5EF4-FFF2-40B4-BE49-F238E27FC236}">
-                <a16:creationId xmlns:a16="http://schemas.microsoft.com/office/drawing/2014/main" id="{D65F22FE-C3CC-98BC-033F-7D0B73AC22F0}"/>
-              </a:ext>
-            </a:extLst>
-          </p:cNvPr>
-          <p:cNvSpPr/>
-          <p:nvPr/>
-        </p:nvSpPr>
-        <p:spPr>
-          <a:xfrm>
-            <a:off x="10735059" y="907158"/>
-            <a:ext cx="1201598" cy="291065"/>
-          </a:xfrm>
-          <a:prstGeom prst="roundRect">
-            <a:avLst/>
-          </a:prstGeom>
-          <a:solidFill>
-            <a:schemeClr val="accent3">
-              <a:lumMod val="75000"/>
-            </a:schemeClr>
-          </a:solidFill>
-          <a:ln>
-            <a:noFill/>
-          </a:ln>
-        </p:spPr>
-        <p:style>
-          <a:lnRef idx="2">
-            <a:schemeClr val="accent1">
-              <a:shade val="50000"/>
-            </a:schemeClr>
-          </a:lnRef>
-          <a:fillRef idx="1">
-            <a:schemeClr val="accent1"/>
-          </a:fillRef>
-          <a:effectRef idx="0">
-            <a:schemeClr val="accent1"/>
-          </a:effectRef>
-          <a:fontRef idx="minor">
-            <a:schemeClr val="lt1"/>
-          </a:fontRef>
-        </p:style>
-        <p:txBody>
-          <a:bodyPr rtlCol="0" anchor="ctr"/>
-          <a:lstStyle/>
-          <a:p>
-            <a:pPr algn="ctr"/>
-            <a:r>
-              <a:rPr lang="es-CO" sz="1600" dirty="0"/>
-              <a:t>04-17-2023</a:t>
-            </a:r>
-          </a:p>
-        </p:txBody>
-      </p:sp>
-      <p:sp>
-        <p:nvSpPr>
-          <p:cNvPr id="32" name="Rectángulo: esquinas redondeadas 31">
-            <a:extLst>
-              <a:ext uri="{FF2B5EF4-FFF2-40B4-BE49-F238E27FC236}">
-                <a16:creationId xmlns:a16="http://schemas.microsoft.com/office/drawing/2014/main" id="{2E38185E-328B-9863-B21B-04C76E33B7C5}"/>
-              </a:ext>
-            </a:extLst>
-          </p:cNvPr>
-          <p:cNvSpPr/>
-          <p:nvPr/>
-        </p:nvSpPr>
-        <p:spPr>
-          <a:xfrm>
-            <a:off x="10719802" y="1815283"/>
-            <a:ext cx="1201598" cy="291065"/>
-          </a:xfrm>
-          <a:prstGeom prst="roundRect">
-            <a:avLst/>
-          </a:prstGeom>
-          <a:solidFill>
-            <a:schemeClr val="accent3">
-              <a:lumMod val="75000"/>
-            </a:schemeClr>
-          </a:solidFill>
-          <a:ln>
-            <a:noFill/>
-          </a:ln>
-        </p:spPr>
-        <p:style>
-          <a:lnRef idx="2">
-            <a:schemeClr val="accent1">
-              <a:shade val="50000"/>
-            </a:schemeClr>
-          </a:lnRef>
-          <a:fillRef idx="1">
-            <a:schemeClr val="accent1"/>
-          </a:fillRef>
-          <a:effectRef idx="0">
-            <a:schemeClr val="accent1"/>
-          </a:effectRef>
-          <a:fontRef idx="minor">
-            <a:schemeClr val="lt1"/>
-          </a:fontRef>
-        </p:style>
-        <p:txBody>
-          <a:bodyPr rtlCol="0" anchor="ctr"/>
-          <a:lstStyle/>
-          <a:p>
-            <a:pPr algn="ctr"/>
-            <a:r>
-              <a:rPr lang="es-CO" sz="1600" dirty="0"/>
-              <a:t>03-23-2023</a:t>
-            </a:r>
-          </a:p>
-        </p:txBody>
-      </p:sp>
-      <p:sp>
-        <p:nvSpPr>
-          <p:cNvPr id="33" name="Rectángulo: esquinas redondeadas 32">
-            <a:extLst>
-              <a:ext uri="{FF2B5EF4-FFF2-40B4-BE49-F238E27FC236}">
-                <a16:creationId xmlns:a16="http://schemas.microsoft.com/office/drawing/2014/main" id="{0A3A0831-102F-E364-A31A-5287AA2245D6}"/>
-              </a:ext>
-            </a:extLst>
-          </p:cNvPr>
-          <p:cNvSpPr/>
-          <p:nvPr/>
-        </p:nvSpPr>
-        <p:spPr>
-          <a:xfrm>
-            <a:off x="10719802" y="2623728"/>
-            <a:ext cx="1201598" cy="291065"/>
-          </a:xfrm>
-          <a:prstGeom prst="roundRect">
-            <a:avLst/>
-          </a:prstGeom>
-          <a:solidFill>
-            <a:schemeClr val="accent3">
-              <a:lumMod val="75000"/>
-            </a:schemeClr>
-          </a:solidFill>
-          <a:ln>
-            <a:noFill/>
-          </a:ln>
-        </p:spPr>
-        <p:style>
-          <a:lnRef idx="2">
-            <a:schemeClr val="accent1">
-              <a:shade val="50000"/>
-            </a:schemeClr>
-          </a:lnRef>
-          <a:fillRef idx="1">
-            <a:schemeClr val="accent1"/>
-          </a:fillRef>
-          <a:effectRef idx="0">
-            <a:schemeClr val="accent1"/>
-          </a:effectRef>
-          <a:fontRef idx="minor">
-            <a:schemeClr val="lt1"/>
-          </a:fontRef>
-        </p:style>
-        <p:txBody>
-          <a:bodyPr rtlCol="0" anchor="ctr"/>
-          <a:lstStyle/>
-          <a:p>
-            <a:pPr algn="ctr"/>
-            <a:r>
-              <a:rPr lang="es-CO" sz="1600" dirty="0"/>
-              <a:t>02-10-2023</a:t>
-            </a:r>
-          </a:p>
-        </p:txBody>
-      </p:sp>
-      <p:sp>
-        <p:nvSpPr>
-          <p:cNvPr id="34" name="CuadroTexto 33">
-            <a:extLst>
-              <a:ext uri="{FF2B5EF4-FFF2-40B4-BE49-F238E27FC236}">
-                <a16:creationId xmlns:a16="http://schemas.microsoft.com/office/drawing/2014/main" id="{97B49A1F-CE3C-01F0-779D-C75766075C77}"/>
-              </a:ext>
-            </a:extLst>
-          </p:cNvPr>
-          <p:cNvSpPr txBox="1"/>
-          <p:nvPr/>
-        </p:nvSpPr>
-        <p:spPr>
-          <a:xfrm>
-            <a:off x="269496" y="5699064"/>
-            <a:ext cx="5205500" cy="1021556"/>
-          </a:xfrm>
-          <a:prstGeom prst="roundRect">
-            <a:avLst/>
-          </a:prstGeom>
-          <a:solidFill>
-            <a:schemeClr val="bg1">
-              <a:alpha val="90000"/>
-            </a:schemeClr>
-          </a:solidFill>
-        </p:spPr>
-        <p:txBody>
-          <a:bodyPr wrap="square" rtlCol="0">
-            <a:spAutoFit/>
-          </a:bodyPr>
-          <a:lstStyle>
-            <a:defPPr>
-              <a:defRPr lang="es-CO"/>
-            </a:defPPr>
-            <a:lvl1pPr algn="just"/>
-          </a:lstStyle>
-          <a:p>
-            <a:r>
-              <a:rPr lang="es-CO" dirty="0"/>
-              <a:t>Si después de revisar evidencia que el sistema le puso una nota por fuera de los parámetros establecidos comuníquese al 3106038006</a:t>
-            </a:r>
-          </a:p>
-        </p:txBody>
-      </p:sp>
+        </p:spPr>
+      </p:pic>
       <p:pic>
         <p:nvPicPr>
-          <p:cNvPr id="36" name="Imagen 35">
-            <a:extLst>
-              <a:ext uri="{FF2B5EF4-FFF2-40B4-BE49-F238E27FC236}">
-                <a16:creationId xmlns:a16="http://schemas.microsoft.com/office/drawing/2014/main" id="{D5853CEA-810C-67E6-860C-D713A3A1C1C3}"/>
+          <p:cNvPr id="6" name="Imagen 5">
+            <a:extLst>
+              <a:ext uri="{FF2B5EF4-FFF2-40B4-BE49-F238E27FC236}">
+                <a16:creationId xmlns:a16="http://schemas.microsoft.com/office/drawing/2014/main" id="{1C154C18-F086-4C83-BB0B-1F851677755A}"/>
               </a:ext>
             </a:extLst>
           </p:cNvPr>
@@ -4197,267 +3899,20 @@
         </p:blipFill>
         <p:spPr>
           <a:xfrm>
-            <a:off x="5734464" y="3282517"/>
-            <a:ext cx="6340732" cy="3114675"/>
-          </a:xfrm>
-          <a:prstGeom prst="roundRect">
-            <a:avLst>
-              <a:gd name="adj" fmla="val 8594"/>
-            </a:avLst>
-          </a:prstGeom>
-          <a:solidFill>
-            <a:srgbClr val="FFFFFF">
-              <a:shade val="85000"/>
-            </a:srgbClr>
-          </a:solidFill>
-          <a:ln>
-            <a:noFill/>
-          </a:ln>
-          <a:effectLst/>
-        </p:spPr>
-      </p:pic>
-      <p:sp>
-        <p:nvSpPr>
-          <p:cNvPr id="37" name="Rectángulo: esquinas redondeadas 36">
-            <a:extLst>
-              <a:ext uri="{FF2B5EF4-FFF2-40B4-BE49-F238E27FC236}">
-                <a16:creationId xmlns:a16="http://schemas.microsoft.com/office/drawing/2014/main" id="{0F8C11D3-3C42-C4A7-61A0-5C4948094B3E}"/>
-              </a:ext>
-            </a:extLst>
-          </p:cNvPr>
-          <p:cNvSpPr/>
-          <p:nvPr/>
-        </p:nvSpPr>
-        <p:spPr>
-          <a:xfrm>
-            <a:off x="8364902" y="4293030"/>
-            <a:ext cx="1407114" cy="216977"/>
-          </a:xfrm>
-          <a:prstGeom prst="roundRect">
+            <a:off x="6471138" y="1426853"/>
+            <a:ext cx="5206655" cy="930849"/>
+          </a:xfrm>
+          <a:prstGeom prst="rect">
             <a:avLst/>
           </a:prstGeom>
-          <a:solidFill>
-            <a:schemeClr val="bg1"/>
-          </a:solidFill>
-          <a:ln>
-            <a:noFill/>
-          </a:ln>
-        </p:spPr>
-        <p:style>
-          <a:lnRef idx="2">
-            <a:schemeClr val="accent1">
-              <a:shade val="50000"/>
-            </a:schemeClr>
-          </a:lnRef>
-          <a:fillRef idx="1">
-            <a:schemeClr val="accent1"/>
-          </a:fillRef>
-          <a:effectRef idx="0">
-            <a:schemeClr val="accent1"/>
-          </a:effectRef>
-          <a:fontRef idx="minor">
-            <a:schemeClr val="lt1"/>
-          </a:fontRef>
-        </p:style>
-        <p:txBody>
-          <a:bodyPr rtlCol="0" anchor="ctr"/>
-          <a:lstStyle/>
-          <a:p>
-            <a:pPr algn="ctr"/>
-            <a:r>
-              <a:rPr lang="es-CO" sz="1600" dirty="0">
-                <a:solidFill>
-                  <a:schemeClr val="tx1"/>
-                </a:solidFill>
-              </a:rPr>
-              <a:t>Conocimiento</a:t>
-            </a:r>
-          </a:p>
-        </p:txBody>
-      </p:sp>
-      <p:sp>
-        <p:nvSpPr>
-          <p:cNvPr id="39" name="Rectángulo: esquinas redondeadas 38">
-            <a:extLst>
-              <a:ext uri="{FF2B5EF4-FFF2-40B4-BE49-F238E27FC236}">
-                <a16:creationId xmlns:a16="http://schemas.microsoft.com/office/drawing/2014/main" id="{ABCBF60F-DDBE-BF0C-0635-73DD99A347C2}"/>
-              </a:ext>
-            </a:extLst>
-          </p:cNvPr>
-          <p:cNvSpPr/>
-          <p:nvPr/>
-        </p:nvSpPr>
-        <p:spPr>
-          <a:xfrm>
-            <a:off x="8364902" y="4647420"/>
-            <a:ext cx="1407114" cy="216977"/>
-          </a:xfrm>
-          <a:prstGeom prst="roundRect">
-            <a:avLst/>
-          </a:prstGeom>
-          <a:solidFill>
-            <a:schemeClr val="bg1"/>
-          </a:solidFill>
-          <a:ln>
-            <a:noFill/>
-          </a:ln>
-        </p:spPr>
-        <p:style>
-          <a:lnRef idx="2">
-            <a:schemeClr val="accent1">
-              <a:shade val="50000"/>
-            </a:schemeClr>
-          </a:lnRef>
-          <a:fillRef idx="1">
-            <a:schemeClr val="accent1"/>
-          </a:fillRef>
-          <a:effectRef idx="0">
-            <a:schemeClr val="accent1"/>
-          </a:effectRef>
-          <a:fontRef idx="minor">
-            <a:schemeClr val="lt1"/>
-          </a:fontRef>
-        </p:style>
-        <p:txBody>
-          <a:bodyPr rtlCol="0" anchor="ctr"/>
-          <a:lstStyle/>
-          <a:p>
-            <a:pPr algn="ctr"/>
-            <a:r>
-              <a:rPr lang="es-CO" sz="1600" dirty="0">
-                <a:solidFill>
-                  <a:schemeClr val="tx1"/>
-                </a:solidFill>
-              </a:rPr>
-              <a:t>Aplicación</a:t>
-            </a:r>
-          </a:p>
-        </p:txBody>
-      </p:sp>
-      <p:sp>
-        <p:nvSpPr>
-          <p:cNvPr id="40" name="Rectángulo: esquinas redondeadas 39">
-            <a:extLst>
-              <a:ext uri="{FF2B5EF4-FFF2-40B4-BE49-F238E27FC236}">
-                <a16:creationId xmlns:a16="http://schemas.microsoft.com/office/drawing/2014/main" id="{554B48CA-F605-55A2-1EF5-77444550B7F6}"/>
-              </a:ext>
-            </a:extLst>
-          </p:cNvPr>
-          <p:cNvSpPr/>
-          <p:nvPr/>
-        </p:nvSpPr>
-        <p:spPr>
-          <a:xfrm>
-            <a:off x="8364902" y="4997667"/>
-            <a:ext cx="1407114" cy="216977"/>
-          </a:xfrm>
-          <a:prstGeom prst="roundRect">
-            <a:avLst/>
-          </a:prstGeom>
-          <a:solidFill>
-            <a:schemeClr val="bg1"/>
-          </a:solidFill>
-          <a:ln>
-            <a:noFill/>
-          </a:ln>
-        </p:spPr>
-        <p:style>
-          <a:lnRef idx="2">
-            <a:schemeClr val="accent1">
-              <a:shade val="50000"/>
-            </a:schemeClr>
-          </a:lnRef>
-          <a:fillRef idx="1">
-            <a:schemeClr val="accent1"/>
-          </a:fillRef>
-          <a:effectRef idx="0">
-            <a:schemeClr val="accent1"/>
-          </a:effectRef>
-          <a:fontRef idx="minor">
-            <a:schemeClr val="lt1"/>
-          </a:fontRef>
-        </p:style>
-        <p:txBody>
-          <a:bodyPr rtlCol="0" anchor="ctr"/>
-          <a:lstStyle/>
-          <a:p>
-            <a:pPr algn="ctr"/>
-            <a:r>
-              <a:rPr lang="es-CO" sz="1600" dirty="0">
-                <a:solidFill>
-                  <a:schemeClr val="tx1"/>
-                </a:solidFill>
-              </a:rPr>
-              <a:t>Ética</a:t>
-            </a:r>
-          </a:p>
-        </p:txBody>
-      </p:sp>
-      <p:sp>
-        <p:nvSpPr>
-          <p:cNvPr id="41" name="Rectángulo: esquinas redondeadas 40">
-            <a:extLst>
-              <a:ext uri="{FF2B5EF4-FFF2-40B4-BE49-F238E27FC236}">
-                <a16:creationId xmlns:a16="http://schemas.microsoft.com/office/drawing/2014/main" id="{FB23FACC-0927-6527-8210-9E07CFE76CE3}"/>
-              </a:ext>
-            </a:extLst>
-          </p:cNvPr>
-          <p:cNvSpPr/>
-          <p:nvPr/>
-        </p:nvSpPr>
-        <p:spPr>
-          <a:xfrm>
-            <a:off x="8239911" y="5370306"/>
-            <a:ext cx="1407114" cy="216977"/>
-          </a:xfrm>
-          <a:prstGeom prst="roundRect">
-            <a:avLst/>
-          </a:prstGeom>
-          <a:solidFill>
-            <a:schemeClr val="bg1"/>
-          </a:solidFill>
-          <a:ln>
-            <a:noFill/>
-          </a:ln>
-        </p:spPr>
-        <p:style>
-          <a:lnRef idx="2">
-            <a:schemeClr val="accent1">
-              <a:shade val="50000"/>
-            </a:schemeClr>
-          </a:lnRef>
-          <a:fillRef idx="1">
-            <a:schemeClr val="accent1"/>
-          </a:fillRef>
-          <a:effectRef idx="0">
-            <a:schemeClr val="accent1"/>
-          </a:effectRef>
-          <a:fontRef idx="minor">
-            <a:schemeClr val="lt1"/>
-          </a:fontRef>
-        </p:style>
-        <p:txBody>
-          <a:bodyPr rtlCol="0" anchor="ctr"/>
-          <a:lstStyle/>
-          <a:p>
-            <a:pPr algn="ctr"/>
-            <a:r>
-              <a:rPr lang="es-CO" sz="1600" dirty="0">
-                <a:solidFill>
-                  <a:schemeClr val="tx1"/>
-                </a:solidFill>
-              </a:rPr>
-              <a:t>Concepto</a:t>
-            </a:r>
-          </a:p>
-        </p:txBody>
-      </p:sp>
+        </p:spPr>
+      </p:pic>
       <p:pic>
         <p:nvPicPr>
-          <p:cNvPr id="43" name="Imagen 42">
-            <a:extLst>
-              <a:ext uri="{FF2B5EF4-FFF2-40B4-BE49-F238E27FC236}">
-                <a16:creationId xmlns:a16="http://schemas.microsoft.com/office/drawing/2014/main" id="{CFBF11B3-35EA-96C3-2C34-8CA8D1FE4098}"/>
+          <p:cNvPr id="45" name="Gráfico 44" descr="Lupa">
+            <a:extLst>
+              <a:ext uri="{FF2B5EF4-FFF2-40B4-BE49-F238E27FC236}">
+                <a16:creationId xmlns:a16="http://schemas.microsoft.com/office/drawing/2014/main" id="{F69B865E-9B16-5794-6A67-0567EA8D5C79}"/>
               </a:ext>
             </a:extLst>
           </p:cNvPr>
@@ -4466,16 +3921,24 @@
           </p:cNvPicPr>
           <p:nvPr/>
         </p:nvPicPr>
-        <p:blipFill>
-          <a:blip r:embed="rId5"/>
-          <a:stretch>
-            <a:fillRect/>
-          </a:stretch>
+        <p:blipFill rotWithShape="1">
+          <a:blip r:embed="rId5">
+            <a:extLst>
+              <a:ext uri="{28A0092B-C50C-407E-A947-70E740481C1C}">
+                <a14:useLocalDpi xmlns:a14="http://schemas.microsoft.com/office/drawing/2010/main" val="0"/>
+              </a:ext>
+              <a:ext uri="{96DAC541-7B7A-43D3-8B79-37D633B846F1}">
+                <asvg:svgBlip xmlns:asvg="http://schemas.microsoft.com/office/drawing/2016/SVG/main" r:embed="rId6"/>
+              </a:ext>
+            </a:extLst>
+          </a:blip>
+          <a:srcRect l="7681" t="8073" b="8034"/>
+          <a:stretch/>
         </p:blipFill>
         <p:spPr>
-          <a:xfrm>
-            <a:off x="9585033" y="4920926"/>
-            <a:ext cx="2250314" cy="1274618"/>
+          <a:xfrm rot="6564120">
+            <a:off x="7828760" y="404965"/>
+            <a:ext cx="4447765" cy="4066781"/>
           </a:xfrm>
           <a:prstGeom prst="rect">
             <a:avLst/>
@@ -4484,99 +3947,56 @@
       </p:pic>
       <p:sp>
         <p:nvSpPr>
-          <p:cNvPr id="46" name="Rectángulo 45">
-            <a:extLst>
-              <a:ext uri="{FF2B5EF4-FFF2-40B4-BE49-F238E27FC236}">
-                <a16:creationId xmlns:a16="http://schemas.microsoft.com/office/drawing/2014/main" id="{E36FE3F4-9027-D2B2-0CA0-775BBDEE594D}"/>
-              </a:ext>
-            </a:extLst>
-          </p:cNvPr>
-          <p:cNvSpPr/>
+          <p:cNvPr id="34" name="CuadroTexto 33">
+            <a:extLst>
+              <a:ext uri="{FF2B5EF4-FFF2-40B4-BE49-F238E27FC236}">
+                <a16:creationId xmlns:a16="http://schemas.microsoft.com/office/drawing/2014/main" id="{97B49A1F-CE3C-01F0-779D-C75766075C77}"/>
+              </a:ext>
+            </a:extLst>
+          </p:cNvPr>
+          <p:cNvSpPr txBox="1"/>
           <p:nvPr/>
         </p:nvSpPr>
         <p:spPr>
           <a:xfrm>
-            <a:off x="9170815" y="6195544"/>
-            <a:ext cx="2250314" cy="133270"/>
-          </a:xfrm>
-          <a:prstGeom prst="rect">
+            <a:off x="196753" y="3096916"/>
+            <a:ext cx="5295344" cy="1328023"/>
+          </a:xfrm>
+          <a:prstGeom prst="roundRect">
             <a:avLst/>
           </a:prstGeom>
           <a:solidFill>
-            <a:schemeClr val="bg1"/>
+            <a:schemeClr val="bg1">
+              <a:alpha val="90000"/>
+            </a:schemeClr>
           </a:solidFill>
-          <a:ln>
-            <a:noFill/>
-          </a:ln>
-        </p:spPr>
-        <p:style>
-          <a:lnRef idx="2">
-            <a:schemeClr val="accent1">
-              <a:shade val="50000"/>
-            </a:schemeClr>
-          </a:lnRef>
-          <a:fillRef idx="1">
-            <a:schemeClr val="accent1"/>
-          </a:fillRef>
-          <a:effectRef idx="0">
-            <a:schemeClr val="accent1"/>
-          </a:effectRef>
-          <a:fontRef idx="minor">
-            <a:schemeClr val="lt1"/>
-          </a:fontRef>
-        </p:style>
-        <p:txBody>
-          <a:bodyPr rtlCol="0" anchor="ctr"/>
-          <a:lstStyle/>
-          <a:p>
-            <a:pPr algn="ctr"/>
-            <a:endParaRPr lang="es-CO"/>
-          </a:p>
-        </p:txBody>
-      </p:sp>
-      <p:pic>
-        <p:nvPicPr>
-          <p:cNvPr id="45" name="Gráfico 44" descr="Lupa">
-            <a:extLst>
-              <a:ext uri="{FF2B5EF4-FFF2-40B4-BE49-F238E27FC236}">
-                <a16:creationId xmlns:a16="http://schemas.microsoft.com/office/drawing/2014/main" id="{F69B865E-9B16-5794-6A67-0567EA8D5C79}"/>
-              </a:ext>
-            </a:extLst>
-          </p:cNvPr>
-          <p:cNvPicPr>
-            <a:picLocks noChangeAspect="1"/>
-          </p:cNvPicPr>
-          <p:nvPr/>
-        </p:nvPicPr>
-        <p:blipFill>
-          <a:blip r:embed="rId6">
-            <a:extLst>
-              <a:ext uri="{28A0092B-C50C-407E-A947-70E740481C1C}">
-                <a14:useLocalDpi xmlns:a14="http://schemas.microsoft.com/office/drawing/2010/main" val="0"/>
-              </a:ext>
-              <a:ext uri="{96DAC541-7B7A-43D3-8B79-37D633B846F1}">
-                <asvg:svgBlip xmlns:asvg="http://schemas.microsoft.com/office/drawing/2016/SVG/main" r:embed="rId7"/>
-              </a:ext>
-            </a:extLst>
-          </a:blip>
-          <a:stretch>
-            <a:fillRect/>
-          </a:stretch>
-        </p:blipFill>
-        <p:spPr>
-          <a:xfrm rot="10800000">
-            <a:off x="7818335" y="2883760"/>
-            <a:ext cx="4735291" cy="4367636"/>
-          </a:xfrm>
-          <a:prstGeom prst="rect">
-            <a:avLst/>
-          </a:prstGeom>
-        </p:spPr>
-      </p:pic>
+        </p:spPr>
+        <p:txBody>
+          <a:bodyPr wrap="square" rtlCol="0">
+            <a:spAutoFit/>
+          </a:bodyPr>
+          <a:lstStyle>
+            <a:defPPr>
+              <a:defRPr lang="es-CO"/>
+            </a:defPPr>
+            <a:lvl1pPr algn="just"/>
+          </a:lstStyle>
+          <a:p>
+            <a:r>
+              <a:rPr lang="es-CO" b="1" dirty="0"/>
+              <a:t>Nota</a:t>
+            </a:r>
+            <a:r>
+              <a:rPr lang="es-CO" dirty="0"/>
+              <a:t>: Si el caso es reasignado no lo exime del ítem anterior, ya que es deber del estudiante comunicarse con la usuaria o usuario y redactar nuevamente según su entendimiento.</a:t>
+            </a:r>
+          </a:p>
+        </p:txBody>
+      </p:sp>
     </p:spTree>
     <p:extLst>
       <p:ext uri="{BB962C8B-B14F-4D97-AF65-F5344CB8AC3E}">
-        <p14:creationId xmlns:p14="http://schemas.microsoft.com/office/powerpoint/2010/main" val="2222916504"/>
+        <p14:creationId xmlns:p14="http://schemas.microsoft.com/office/powerpoint/2010/main" val="1776731106"/>
       </p:ext>
     </p:extLst>
   </p:cSld>
@@ -4595,6 +4015,7 @@
           <a:schemeClr val="tx1">
             <a:lumMod val="65000"/>
             <a:lumOff val="35000"/>
+            <a:alpha val="72000"/>
           </a:schemeClr>
         </a:solidFill>
         <a:effectLst/>
@@ -4672,7 +4093,7 @@
           </a:prstGeom>
           <a:solidFill>
             <a:srgbClr val="1AA513">
-              <a:alpha val="44000"/>
+              <a:alpha val="31765"/>
             </a:srgbClr>
           </a:solidFill>
           <a:ln>
@@ -4706,6 +4127,1269 @@
       </p:sp>
       <p:sp>
         <p:nvSpPr>
+          <p:cNvPr id="4" name="CuadroTexto 3">
+            <a:extLst>
+              <a:ext uri="{FF2B5EF4-FFF2-40B4-BE49-F238E27FC236}">
+                <a16:creationId xmlns:a16="http://schemas.microsoft.com/office/drawing/2014/main" id="{17E1BAEB-D355-DE0F-EF5A-E4CC5574A2A8}"/>
+              </a:ext>
+            </a:extLst>
+          </p:cNvPr>
+          <p:cNvSpPr txBox="1"/>
+          <p:nvPr/>
+        </p:nvSpPr>
+        <p:spPr>
+          <a:xfrm>
+            <a:off x="269496" y="1005125"/>
+            <a:ext cx="5205500" cy="4847749"/>
+          </a:xfrm>
+          <a:prstGeom prst="round2SameRect">
+            <a:avLst>
+              <a:gd name="adj1" fmla="val 3841"/>
+              <a:gd name="adj2" fmla="val 0"/>
+            </a:avLst>
+          </a:prstGeom>
+          <a:solidFill>
+            <a:schemeClr val="bg1">
+              <a:alpha val="90000"/>
+            </a:schemeClr>
+          </a:solidFill>
+        </p:spPr>
+        <p:txBody>
+          <a:bodyPr wrap="square" rtlCol="0">
+            <a:spAutoFit/>
+          </a:bodyPr>
+          <a:lstStyle/>
+          <a:p>
+            <a:pPr algn="just"/>
+            <a:endParaRPr lang="es-CO" dirty="0"/>
+          </a:p>
+          <a:p>
+            <a:pPr marL="285750" indent="-285750" algn="just">
+              <a:buFont typeface="Wingdings" panose="05000000000000000000" pitchFamily="2" charset="2"/>
+              <a:buChar char="Ø"/>
+            </a:pPr>
+            <a:r>
+              <a:rPr lang="es-CO" b="1" dirty="0"/>
+              <a:t>Al cerrar el corte se aplicaran notas a aquellos casos de seguimiento que después de 30 días de asignado NO tienen actuaciones (o anexos). También a aquellos que tienen entre una actuación y otra mas de 30 días. </a:t>
+            </a:r>
+          </a:p>
+          <a:p>
+            <a:pPr marL="285750" indent="-285750" algn="just">
+              <a:buFont typeface="Wingdings" panose="05000000000000000000" pitchFamily="2" charset="2"/>
+              <a:buChar char="Ø"/>
+            </a:pPr>
+            <a:r>
+              <a:rPr lang="es-CO" b="1" dirty="0"/>
+              <a:t>En el reporte de notas usted podrá ver de manera detallada el motivo de la nota. Si la nota se aplicó por lo expresado en el </a:t>
+            </a:r>
+            <a:r>
+              <a:rPr lang="es-CO" b="1" dirty="0" err="1"/>
+              <a:t>item</a:t>
+            </a:r>
+            <a:r>
+              <a:rPr lang="es-CO" b="1" dirty="0"/>
+              <a:t> anterior el sistema le indica el periodo evaluado.</a:t>
+            </a:r>
+          </a:p>
+          <a:p>
+            <a:pPr marL="285750" indent="-285750" algn="just">
+              <a:buFont typeface="Wingdings" panose="05000000000000000000" pitchFamily="2" charset="2"/>
+              <a:buChar char="Ø"/>
+            </a:pPr>
+            <a:r>
+              <a:rPr lang="es-CO" b="1" dirty="0"/>
+              <a:t>Para verificar el periodo ingrese al caso y en la pestaña de actuaciones, en el listado puede ver la fecha de creación. </a:t>
+            </a:r>
+          </a:p>
+          <a:p>
+            <a:pPr marL="285750" indent="-285750" algn="just">
+              <a:buFont typeface="Wingdings" panose="05000000000000000000" pitchFamily="2" charset="2"/>
+              <a:buChar char="Ø"/>
+            </a:pPr>
+            <a:r>
+              <a:rPr lang="es-CO" b="1" dirty="0"/>
+              <a:t>Recuerde que solo se tendrán en cuenta aquellas actuaciones creadas por el estudiante, mas no las creadas por el docente asesor y aquellos anexos que no estén anulados.</a:t>
+            </a:r>
+          </a:p>
+        </p:txBody>
+      </p:sp>
+      <p:sp>
+        <p:nvSpPr>
+          <p:cNvPr id="8" name="CuadroTexto 7">
+            <a:extLst>
+              <a:ext uri="{FF2B5EF4-FFF2-40B4-BE49-F238E27FC236}">
+                <a16:creationId xmlns:a16="http://schemas.microsoft.com/office/drawing/2014/main" id="{30609EE1-495E-A80D-AD8C-B0A890710151}"/>
+              </a:ext>
+            </a:extLst>
+          </p:cNvPr>
+          <p:cNvSpPr txBox="1"/>
+          <p:nvPr/>
+        </p:nvSpPr>
+        <p:spPr>
+          <a:xfrm>
+            <a:off x="71191" y="507048"/>
+            <a:ext cx="5546469" cy="408623"/>
+          </a:xfrm>
+          <a:prstGeom prst="roundRect">
+            <a:avLst/>
+          </a:prstGeom>
+          <a:solidFill>
+            <a:schemeClr val="bg1">
+              <a:alpha val="90000"/>
+            </a:schemeClr>
+          </a:solidFill>
+        </p:spPr>
+        <p:txBody>
+          <a:bodyPr wrap="square" rtlCol="0">
+            <a:spAutoFit/>
+          </a:bodyPr>
+          <a:lstStyle>
+            <a:defPPr>
+              <a:defRPr lang="es-CO"/>
+            </a:defPPr>
+            <a:lvl1pPr algn="just">
+              <a:defRPr>
+                <a:solidFill>
+                  <a:schemeClr val="tx1"/>
+                </a:solidFill>
+              </a:defRPr>
+            </a:lvl1pPr>
+            <a:lvl2pPr>
+              <a:defRPr>
+                <a:solidFill>
+                  <a:schemeClr val="tx1"/>
+                </a:solidFill>
+              </a:defRPr>
+            </a:lvl2pPr>
+            <a:lvl3pPr>
+              <a:defRPr>
+                <a:solidFill>
+                  <a:schemeClr val="tx1"/>
+                </a:solidFill>
+              </a:defRPr>
+            </a:lvl3pPr>
+            <a:lvl4pPr>
+              <a:defRPr>
+                <a:solidFill>
+                  <a:schemeClr val="tx1"/>
+                </a:solidFill>
+              </a:defRPr>
+            </a:lvl4pPr>
+            <a:lvl5pPr>
+              <a:defRPr>
+                <a:solidFill>
+                  <a:schemeClr val="tx1"/>
+                </a:solidFill>
+              </a:defRPr>
+            </a:lvl5pPr>
+            <a:lvl6pPr>
+              <a:defRPr>
+                <a:solidFill>
+                  <a:schemeClr val="tx1"/>
+                </a:solidFill>
+              </a:defRPr>
+            </a:lvl6pPr>
+            <a:lvl7pPr>
+              <a:defRPr>
+                <a:solidFill>
+                  <a:schemeClr val="tx1"/>
+                </a:solidFill>
+              </a:defRPr>
+            </a:lvl7pPr>
+            <a:lvl8pPr>
+              <a:defRPr>
+                <a:solidFill>
+                  <a:schemeClr val="tx1"/>
+                </a:solidFill>
+              </a:defRPr>
+            </a:lvl8pPr>
+            <a:lvl9pPr>
+              <a:defRPr>
+                <a:solidFill>
+                  <a:schemeClr val="tx1"/>
+                </a:solidFill>
+              </a:defRPr>
+            </a:lvl9pPr>
+          </a:lstStyle>
+          <a:p>
+            <a:r>
+              <a:rPr lang="es-CO" dirty="0"/>
+              <a:t>Estimado estudiante tenga en cuenta lo siguiente:</a:t>
+            </a:r>
+          </a:p>
+        </p:txBody>
+      </p:sp>
+      <p:pic>
+        <p:nvPicPr>
+          <p:cNvPr id="19" name="Imagen 18">
+            <a:extLst>
+              <a:ext uri="{FF2B5EF4-FFF2-40B4-BE49-F238E27FC236}">
+                <a16:creationId xmlns:a16="http://schemas.microsoft.com/office/drawing/2014/main" id="{9A4DA2B7-9B4A-5FD1-E61F-594084326029}"/>
+              </a:ext>
+            </a:extLst>
+          </p:cNvPr>
+          <p:cNvPicPr>
+            <a:picLocks noChangeAspect="1"/>
+          </p:cNvPicPr>
+          <p:nvPr/>
+        </p:nvPicPr>
+        <p:blipFill>
+          <a:blip r:embed="rId3"/>
+          <a:stretch>
+            <a:fillRect/>
+          </a:stretch>
+        </p:blipFill>
+        <p:spPr>
+          <a:xfrm>
+            <a:off x="5734464" y="301672"/>
+            <a:ext cx="6340732" cy="2900430"/>
+          </a:xfrm>
+          <a:prstGeom prst="roundRect">
+            <a:avLst>
+              <a:gd name="adj" fmla="val 8594"/>
+            </a:avLst>
+          </a:prstGeom>
+          <a:solidFill>
+            <a:srgbClr val="FFFFFF">
+              <a:shade val="85000"/>
+            </a:srgbClr>
+          </a:solidFill>
+          <a:ln>
+            <a:noFill/>
+          </a:ln>
+          <a:effectLst/>
+        </p:spPr>
+      </p:pic>
+      <p:sp>
+        <p:nvSpPr>
+          <p:cNvPr id="20" name="Flecha: arriba y abajo 19">
+            <a:extLst>
+              <a:ext uri="{FF2B5EF4-FFF2-40B4-BE49-F238E27FC236}">
+                <a16:creationId xmlns:a16="http://schemas.microsoft.com/office/drawing/2014/main" id="{B0CFC603-9496-72A3-0EA0-40CAF706B026}"/>
+              </a:ext>
+            </a:extLst>
+          </p:cNvPr>
+          <p:cNvSpPr/>
+          <p:nvPr/>
+        </p:nvSpPr>
+        <p:spPr>
+          <a:xfrm>
+            <a:off x="11264649" y="2162229"/>
+            <a:ext cx="177299" cy="436099"/>
+          </a:xfrm>
+          <a:prstGeom prst="upDownArrow">
+            <a:avLst/>
+          </a:prstGeom>
+          <a:solidFill>
+            <a:srgbClr val="00B050"/>
+          </a:solidFill>
+          <a:ln>
+            <a:noFill/>
+          </a:ln>
+        </p:spPr>
+        <p:style>
+          <a:lnRef idx="2">
+            <a:schemeClr val="accent1">
+              <a:shade val="50000"/>
+            </a:schemeClr>
+          </a:lnRef>
+          <a:fillRef idx="1">
+            <a:schemeClr val="accent1"/>
+          </a:fillRef>
+          <a:effectRef idx="0">
+            <a:schemeClr val="accent1"/>
+          </a:effectRef>
+          <a:fontRef idx="minor">
+            <a:schemeClr val="lt1"/>
+          </a:fontRef>
+        </p:style>
+        <p:txBody>
+          <a:bodyPr rtlCol="0" anchor="ctr"/>
+          <a:lstStyle/>
+          <a:p>
+            <a:pPr algn="ctr"/>
+            <a:endParaRPr lang="es-CO"/>
+          </a:p>
+        </p:txBody>
+      </p:sp>
+      <p:sp>
+        <p:nvSpPr>
+          <p:cNvPr id="22" name="Flecha: arriba y abajo 21">
+            <a:extLst>
+              <a:ext uri="{FF2B5EF4-FFF2-40B4-BE49-F238E27FC236}">
+                <a16:creationId xmlns:a16="http://schemas.microsoft.com/office/drawing/2014/main" id="{25A4025E-8E2E-F8EE-A06B-9A4274F7904D}"/>
+              </a:ext>
+            </a:extLst>
+          </p:cNvPr>
+          <p:cNvSpPr/>
+          <p:nvPr/>
+        </p:nvSpPr>
+        <p:spPr>
+          <a:xfrm>
+            <a:off x="11264649" y="1328385"/>
+            <a:ext cx="177299" cy="436099"/>
+          </a:xfrm>
+          <a:prstGeom prst="upDownArrow">
+            <a:avLst/>
+          </a:prstGeom>
+          <a:solidFill>
+            <a:srgbClr val="00B050"/>
+          </a:solidFill>
+          <a:ln>
+            <a:noFill/>
+          </a:ln>
+        </p:spPr>
+        <p:style>
+          <a:lnRef idx="2">
+            <a:schemeClr val="accent1">
+              <a:shade val="50000"/>
+            </a:schemeClr>
+          </a:lnRef>
+          <a:fillRef idx="1">
+            <a:schemeClr val="accent1"/>
+          </a:fillRef>
+          <a:effectRef idx="0">
+            <a:schemeClr val="accent1"/>
+          </a:effectRef>
+          <a:fontRef idx="minor">
+            <a:schemeClr val="lt1"/>
+          </a:fontRef>
+        </p:style>
+        <p:txBody>
+          <a:bodyPr rtlCol="0" anchor="ctr"/>
+          <a:lstStyle/>
+          <a:p>
+            <a:pPr algn="ctr"/>
+            <a:endParaRPr lang="es-CO" dirty="0"/>
+          </a:p>
+        </p:txBody>
+      </p:sp>
+      <p:sp>
+        <p:nvSpPr>
+          <p:cNvPr id="23" name="Rectángulo: esquinas redondeadas 22">
+            <a:extLst>
+              <a:ext uri="{FF2B5EF4-FFF2-40B4-BE49-F238E27FC236}">
+                <a16:creationId xmlns:a16="http://schemas.microsoft.com/office/drawing/2014/main" id="{9C3D4B20-63DD-3680-857C-38710B747EF8}"/>
+              </a:ext>
+            </a:extLst>
+          </p:cNvPr>
+          <p:cNvSpPr/>
+          <p:nvPr/>
+        </p:nvSpPr>
+        <p:spPr>
+          <a:xfrm>
+            <a:off x="5786412" y="907158"/>
+            <a:ext cx="4810109" cy="705974"/>
+          </a:xfrm>
+          <a:prstGeom prst="roundRect">
+            <a:avLst/>
+          </a:prstGeom>
+          <a:solidFill>
+            <a:schemeClr val="bg1"/>
+          </a:solidFill>
+          <a:ln>
+            <a:noFill/>
+          </a:ln>
+        </p:spPr>
+        <p:style>
+          <a:lnRef idx="2">
+            <a:schemeClr val="accent1">
+              <a:shade val="50000"/>
+            </a:schemeClr>
+          </a:lnRef>
+          <a:fillRef idx="1">
+            <a:schemeClr val="accent1"/>
+          </a:fillRef>
+          <a:effectRef idx="0">
+            <a:schemeClr val="accent1"/>
+          </a:effectRef>
+          <a:fontRef idx="minor">
+            <a:schemeClr val="lt1"/>
+          </a:fontRef>
+        </p:style>
+        <p:txBody>
+          <a:bodyPr rtlCol="0" anchor="ctr"/>
+          <a:lstStyle/>
+          <a:p>
+            <a:pPr algn="ctr"/>
+            <a:r>
+              <a:rPr lang="es-CO" dirty="0">
+                <a:solidFill>
+                  <a:schemeClr val="tx1"/>
+                </a:solidFill>
+              </a:rPr>
+              <a:t>ACTUACIÓN 3</a:t>
+            </a:r>
+          </a:p>
+        </p:txBody>
+      </p:sp>
+      <p:sp>
+        <p:nvSpPr>
+          <p:cNvPr id="24" name="Rectángulo: esquinas redondeadas 23">
+            <a:extLst>
+              <a:ext uri="{FF2B5EF4-FFF2-40B4-BE49-F238E27FC236}">
+                <a16:creationId xmlns:a16="http://schemas.microsoft.com/office/drawing/2014/main" id="{31BF783D-3BDF-57A3-102B-B03418B30E08}"/>
+              </a:ext>
+            </a:extLst>
+          </p:cNvPr>
+          <p:cNvSpPr/>
+          <p:nvPr/>
+        </p:nvSpPr>
+        <p:spPr>
+          <a:xfrm>
+            <a:off x="5786412" y="1679484"/>
+            <a:ext cx="4810109" cy="711200"/>
+          </a:xfrm>
+          <a:prstGeom prst="roundRect">
+            <a:avLst/>
+          </a:prstGeom>
+          <a:solidFill>
+            <a:schemeClr val="bg1"/>
+          </a:solidFill>
+          <a:ln>
+            <a:noFill/>
+          </a:ln>
+        </p:spPr>
+        <p:style>
+          <a:lnRef idx="2">
+            <a:schemeClr val="accent1">
+              <a:shade val="50000"/>
+            </a:schemeClr>
+          </a:lnRef>
+          <a:fillRef idx="1">
+            <a:schemeClr val="accent1"/>
+          </a:fillRef>
+          <a:effectRef idx="0">
+            <a:schemeClr val="accent1"/>
+          </a:effectRef>
+          <a:fontRef idx="minor">
+            <a:schemeClr val="lt1"/>
+          </a:fontRef>
+        </p:style>
+        <p:txBody>
+          <a:bodyPr rtlCol="0" anchor="ctr"/>
+          <a:lstStyle/>
+          <a:p>
+            <a:pPr algn="ctr"/>
+            <a:r>
+              <a:rPr lang="es-CO" dirty="0">
+                <a:solidFill>
+                  <a:schemeClr val="tx1"/>
+                </a:solidFill>
+              </a:rPr>
+              <a:t>ACTUACIÓN 2</a:t>
+            </a:r>
+          </a:p>
+        </p:txBody>
+      </p:sp>
+      <p:sp>
+        <p:nvSpPr>
+          <p:cNvPr id="25" name="Rectángulo: esquinas redondeadas 24">
+            <a:extLst>
+              <a:ext uri="{FF2B5EF4-FFF2-40B4-BE49-F238E27FC236}">
+                <a16:creationId xmlns:a16="http://schemas.microsoft.com/office/drawing/2014/main" id="{60382C07-4DC0-C195-ADC4-E8177385D3F6}"/>
+              </a:ext>
+            </a:extLst>
+          </p:cNvPr>
+          <p:cNvSpPr/>
+          <p:nvPr/>
+        </p:nvSpPr>
+        <p:spPr>
+          <a:xfrm>
+            <a:off x="5786412" y="2440103"/>
+            <a:ext cx="4810109" cy="711200"/>
+          </a:xfrm>
+          <a:prstGeom prst="roundRect">
+            <a:avLst/>
+          </a:prstGeom>
+          <a:solidFill>
+            <a:schemeClr val="bg1"/>
+          </a:solidFill>
+          <a:ln>
+            <a:noFill/>
+          </a:ln>
+        </p:spPr>
+        <p:style>
+          <a:lnRef idx="2">
+            <a:schemeClr val="accent1">
+              <a:shade val="50000"/>
+            </a:schemeClr>
+          </a:lnRef>
+          <a:fillRef idx="1">
+            <a:schemeClr val="accent1"/>
+          </a:fillRef>
+          <a:effectRef idx="0">
+            <a:schemeClr val="accent1"/>
+          </a:effectRef>
+          <a:fontRef idx="minor">
+            <a:schemeClr val="lt1"/>
+          </a:fontRef>
+        </p:style>
+        <p:txBody>
+          <a:bodyPr rtlCol="0" anchor="ctr"/>
+          <a:lstStyle/>
+          <a:p>
+            <a:pPr algn="ctr"/>
+            <a:r>
+              <a:rPr lang="es-CO" dirty="0">
+                <a:solidFill>
+                  <a:schemeClr val="tx1"/>
+                </a:solidFill>
+              </a:rPr>
+              <a:t>ACTUACIÓN 1</a:t>
+            </a:r>
+          </a:p>
+        </p:txBody>
+      </p:sp>
+      <p:sp>
+        <p:nvSpPr>
+          <p:cNvPr id="31" name="Rectángulo: esquinas redondeadas 30">
+            <a:extLst>
+              <a:ext uri="{FF2B5EF4-FFF2-40B4-BE49-F238E27FC236}">
+                <a16:creationId xmlns:a16="http://schemas.microsoft.com/office/drawing/2014/main" id="{D65F22FE-C3CC-98BC-033F-7D0B73AC22F0}"/>
+              </a:ext>
+            </a:extLst>
+          </p:cNvPr>
+          <p:cNvSpPr/>
+          <p:nvPr/>
+        </p:nvSpPr>
+        <p:spPr>
+          <a:xfrm>
+            <a:off x="10735059" y="907158"/>
+            <a:ext cx="1201598" cy="291065"/>
+          </a:xfrm>
+          <a:prstGeom prst="roundRect">
+            <a:avLst/>
+          </a:prstGeom>
+          <a:solidFill>
+            <a:schemeClr val="accent3">
+              <a:lumMod val="75000"/>
+            </a:schemeClr>
+          </a:solidFill>
+          <a:ln>
+            <a:noFill/>
+          </a:ln>
+        </p:spPr>
+        <p:style>
+          <a:lnRef idx="2">
+            <a:schemeClr val="accent1">
+              <a:shade val="50000"/>
+            </a:schemeClr>
+          </a:lnRef>
+          <a:fillRef idx="1">
+            <a:schemeClr val="accent1"/>
+          </a:fillRef>
+          <a:effectRef idx="0">
+            <a:schemeClr val="accent1"/>
+          </a:effectRef>
+          <a:fontRef idx="minor">
+            <a:schemeClr val="lt1"/>
+          </a:fontRef>
+        </p:style>
+        <p:txBody>
+          <a:bodyPr rtlCol="0" anchor="ctr"/>
+          <a:lstStyle/>
+          <a:p>
+            <a:pPr algn="ctr"/>
+            <a:r>
+              <a:rPr lang="es-CO" sz="1600" dirty="0"/>
+              <a:t>04-17-2023</a:t>
+            </a:r>
+          </a:p>
+        </p:txBody>
+      </p:sp>
+      <p:sp>
+        <p:nvSpPr>
+          <p:cNvPr id="32" name="Rectángulo: esquinas redondeadas 31">
+            <a:extLst>
+              <a:ext uri="{FF2B5EF4-FFF2-40B4-BE49-F238E27FC236}">
+                <a16:creationId xmlns:a16="http://schemas.microsoft.com/office/drawing/2014/main" id="{2E38185E-328B-9863-B21B-04C76E33B7C5}"/>
+              </a:ext>
+            </a:extLst>
+          </p:cNvPr>
+          <p:cNvSpPr/>
+          <p:nvPr/>
+        </p:nvSpPr>
+        <p:spPr>
+          <a:xfrm>
+            <a:off x="10719802" y="1815283"/>
+            <a:ext cx="1201598" cy="291065"/>
+          </a:xfrm>
+          <a:prstGeom prst="roundRect">
+            <a:avLst/>
+          </a:prstGeom>
+          <a:solidFill>
+            <a:schemeClr val="accent3">
+              <a:lumMod val="75000"/>
+            </a:schemeClr>
+          </a:solidFill>
+          <a:ln>
+            <a:noFill/>
+          </a:ln>
+        </p:spPr>
+        <p:style>
+          <a:lnRef idx="2">
+            <a:schemeClr val="accent1">
+              <a:shade val="50000"/>
+            </a:schemeClr>
+          </a:lnRef>
+          <a:fillRef idx="1">
+            <a:schemeClr val="accent1"/>
+          </a:fillRef>
+          <a:effectRef idx="0">
+            <a:schemeClr val="accent1"/>
+          </a:effectRef>
+          <a:fontRef idx="minor">
+            <a:schemeClr val="lt1"/>
+          </a:fontRef>
+        </p:style>
+        <p:txBody>
+          <a:bodyPr rtlCol="0" anchor="ctr"/>
+          <a:lstStyle/>
+          <a:p>
+            <a:pPr algn="ctr"/>
+            <a:r>
+              <a:rPr lang="es-CO" sz="1600" dirty="0"/>
+              <a:t>03-23-2023</a:t>
+            </a:r>
+          </a:p>
+        </p:txBody>
+      </p:sp>
+      <p:sp>
+        <p:nvSpPr>
+          <p:cNvPr id="33" name="Rectángulo: esquinas redondeadas 32">
+            <a:extLst>
+              <a:ext uri="{FF2B5EF4-FFF2-40B4-BE49-F238E27FC236}">
+                <a16:creationId xmlns:a16="http://schemas.microsoft.com/office/drawing/2014/main" id="{0A3A0831-102F-E364-A31A-5287AA2245D6}"/>
+              </a:ext>
+            </a:extLst>
+          </p:cNvPr>
+          <p:cNvSpPr/>
+          <p:nvPr/>
+        </p:nvSpPr>
+        <p:spPr>
+          <a:xfrm>
+            <a:off x="10719802" y="2623728"/>
+            <a:ext cx="1201598" cy="291065"/>
+          </a:xfrm>
+          <a:prstGeom prst="roundRect">
+            <a:avLst/>
+          </a:prstGeom>
+          <a:solidFill>
+            <a:schemeClr val="accent3">
+              <a:lumMod val="75000"/>
+            </a:schemeClr>
+          </a:solidFill>
+          <a:ln>
+            <a:noFill/>
+          </a:ln>
+        </p:spPr>
+        <p:style>
+          <a:lnRef idx="2">
+            <a:schemeClr val="accent1">
+              <a:shade val="50000"/>
+            </a:schemeClr>
+          </a:lnRef>
+          <a:fillRef idx="1">
+            <a:schemeClr val="accent1"/>
+          </a:fillRef>
+          <a:effectRef idx="0">
+            <a:schemeClr val="accent1"/>
+          </a:effectRef>
+          <a:fontRef idx="minor">
+            <a:schemeClr val="lt1"/>
+          </a:fontRef>
+        </p:style>
+        <p:txBody>
+          <a:bodyPr rtlCol="0" anchor="ctr"/>
+          <a:lstStyle/>
+          <a:p>
+            <a:pPr algn="ctr"/>
+            <a:r>
+              <a:rPr lang="es-CO" sz="1600" dirty="0"/>
+              <a:t>02-10-2023</a:t>
+            </a:r>
+          </a:p>
+        </p:txBody>
+      </p:sp>
+      <p:sp>
+        <p:nvSpPr>
+          <p:cNvPr id="34" name="CuadroTexto 33">
+            <a:extLst>
+              <a:ext uri="{FF2B5EF4-FFF2-40B4-BE49-F238E27FC236}">
+                <a16:creationId xmlns:a16="http://schemas.microsoft.com/office/drawing/2014/main" id="{97B49A1F-CE3C-01F0-779D-C75766075C77}"/>
+              </a:ext>
+            </a:extLst>
+          </p:cNvPr>
+          <p:cNvSpPr txBox="1"/>
+          <p:nvPr/>
+        </p:nvSpPr>
+        <p:spPr>
+          <a:xfrm>
+            <a:off x="269496" y="5699064"/>
+            <a:ext cx="5205500" cy="1021556"/>
+          </a:xfrm>
+          <a:prstGeom prst="roundRect">
+            <a:avLst/>
+          </a:prstGeom>
+          <a:solidFill>
+            <a:schemeClr val="bg1">
+              <a:alpha val="90000"/>
+            </a:schemeClr>
+          </a:solidFill>
+        </p:spPr>
+        <p:txBody>
+          <a:bodyPr wrap="square" rtlCol="0">
+            <a:spAutoFit/>
+          </a:bodyPr>
+          <a:lstStyle>
+            <a:defPPr>
+              <a:defRPr lang="es-CO"/>
+            </a:defPPr>
+            <a:lvl1pPr algn="just"/>
+          </a:lstStyle>
+          <a:p>
+            <a:r>
+              <a:rPr lang="es-CO" dirty="0"/>
+              <a:t>Si después de revisar evidencia que el sistema le puso una nota por fuera de los parámetros establecidos comuníquese al 3106038006</a:t>
+            </a:r>
+          </a:p>
+        </p:txBody>
+      </p:sp>
+      <p:pic>
+        <p:nvPicPr>
+          <p:cNvPr id="36" name="Imagen 35">
+            <a:extLst>
+              <a:ext uri="{FF2B5EF4-FFF2-40B4-BE49-F238E27FC236}">
+                <a16:creationId xmlns:a16="http://schemas.microsoft.com/office/drawing/2014/main" id="{D5853CEA-810C-67E6-860C-D713A3A1C1C3}"/>
+              </a:ext>
+            </a:extLst>
+          </p:cNvPr>
+          <p:cNvPicPr>
+            <a:picLocks noChangeAspect="1"/>
+          </p:cNvPicPr>
+          <p:nvPr/>
+        </p:nvPicPr>
+        <p:blipFill>
+          <a:blip r:embed="rId4"/>
+          <a:stretch>
+            <a:fillRect/>
+          </a:stretch>
+        </p:blipFill>
+        <p:spPr>
+          <a:xfrm>
+            <a:off x="5734464" y="3282517"/>
+            <a:ext cx="6340732" cy="3114675"/>
+          </a:xfrm>
+          <a:prstGeom prst="roundRect">
+            <a:avLst>
+              <a:gd name="adj" fmla="val 8594"/>
+            </a:avLst>
+          </a:prstGeom>
+          <a:solidFill>
+            <a:srgbClr val="FFFFFF">
+              <a:shade val="85000"/>
+            </a:srgbClr>
+          </a:solidFill>
+          <a:ln>
+            <a:noFill/>
+          </a:ln>
+          <a:effectLst/>
+        </p:spPr>
+      </p:pic>
+      <p:sp>
+        <p:nvSpPr>
+          <p:cNvPr id="37" name="Rectángulo: esquinas redondeadas 36">
+            <a:extLst>
+              <a:ext uri="{FF2B5EF4-FFF2-40B4-BE49-F238E27FC236}">
+                <a16:creationId xmlns:a16="http://schemas.microsoft.com/office/drawing/2014/main" id="{0F8C11D3-3C42-C4A7-61A0-5C4948094B3E}"/>
+              </a:ext>
+            </a:extLst>
+          </p:cNvPr>
+          <p:cNvSpPr/>
+          <p:nvPr/>
+        </p:nvSpPr>
+        <p:spPr>
+          <a:xfrm>
+            <a:off x="8364902" y="4293030"/>
+            <a:ext cx="1407114" cy="216977"/>
+          </a:xfrm>
+          <a:prstGeom prst="roundRect">
+            <a:avLst/>
+          </a:prstGeom>
+          <a:solidFill>
+            <a:schemeClr val="bg1"/>
+          </a:solidFill>
+          <a:ln>
+            <a:noFill/>
+          </a:ln>
+        </p:spPr>
+        <p:style>
+          <a:lnRef idx="2">
+            <a:schemeClr val="accent1">
+              <a:shade val="50000"/>
+            </a:schemeClr>
+          </a:lnRef>
+          <a:fillRef idx="1">
+            <a:schemeClr val="accent1"/>
+          </a:fillRef>
+          <a:effectRef idx="0">
+            <a:schemeClr val="accent1"/>
+          </a:effectRef>
+          <a:fontRef idx="minor">
+            <a:schemeClr val="lt1"/>
+          </a:fontRef>
+        </p:style>
+        <p:txBody>
+          <a:bodyPr rtlCol="0" anchor="ctr"/>
+          <a:lstStyle/>
+          <a:p>
+            <a:pPr algn="ctr"/>
+            <a:r>
+              <a:rPr lang="es-CO" sz="1600" dirty="0">
+                <a:solidFill>
+                  <a:schemeClr val="tx1"/>
+                </a:solidFill>
+              </a:rPr>
+              <a:t>Conocimiento</a:t>
+            </a:r>
+          </a:p>
+        </p:txBody>
+      </p:sp>
+      <p:sp>
+        <p:nvSpPr>
+          <p:cNvPr id="39" name="Rectángulo: esquinas redondeadas 38">
+            <a:extLst>
+              <a:ext uri="{FF2B5EF4-FFF2-40B4-BE49-F238E27FC236}">
+                <a16:creationId xmlns:a16="http://schemas.microsoft.com/office/drawing/2014/main" id="{ABCBF60F-DDBE-BF0C-0635-73DD99A347C2}"/>
+              </a:ext>
+            </a:extLst>
+          </p:cNvPr>
+          <p:cNvSpPr/>
+          <p:nvPr/>
+        </p:nvSpPr>
+        <p:spPr>
+          <a:xfrm>
+            <a:off x="8364902" y="4647420"/>
+            <a:ext cx="1407114" cy="216977"/>
+          </a:xfrm>
+          <a:prstGeom prst="roundRect">
+            <a:avLst/>
+          </a:prstGeom>
+          <a:solidFill>
+            <a:schemeClr val="bg1"/>
+          </a:solidFill>
+          <a:ln>
+            <a:noFill/>
+          </a:ln>
+        </p:spPr>
+        <p:style>
+          <a:lnRef idx="2">
+            <a:schemeClr val="accent1">
+              <a:shade val="50000"/>
+            </a:schemeClr>
+          </a:lnRef>
+          <a:fillRef idx="1">
+            <a:schemeClr val="accent1"/>
+          </a:fillRef>
+          <a:effectRef idx="0">
+            <a:schemeClr val="accent1"/>
+          </a:effectRef>
+          <a:fontRef idx="minor">
+            <a:schemeClr val="lt1"/>
+          </a:fontRef>
+        </p:style>
+        <p:txBody>
+          <a:bodyPr rtlCol="0" anchor="ctr"/>
+          <a:lstStyle/>
+          <a:p>
+            <a:pPr algn="ctr"/>
+            <a:r>
+              <a:rPr lang="es-CO" sz="1600" dirty="0">
+                <a:solidFill>
+                  <a:schemeClr val="tx1"/>
+                </a:solidFill>
+              </a:rPr>
+              <a:t>Aplicación</a:t>
+            </a:r>
+          </a:p>
+        </p:txBody>
+      </p:sp>
+      <p:sp>
+        <p:nvSpPr>
+          <p:cNvPr id="40" name="Rectángulo: esquinas redondeadas 39">
+            <a:extLst>
+              <a:ext uri="{FF2B5EF4-FFF2-40B4-BE49-F238E27FC236}">
+                <a16:creationId xmlns:a16="http://schemas.microsoft.com/office/drawing/2014/main" id="{554B48CA-F605-55A2-1EF5-77444550B7F6}"/>
+              </a:ext>
+            </a:extLst>
+          </p:cNvPr>
+          <p:cNvSpPr/>
+          <p:nvPr/>
+        </p:nvSpPr>
+        <p:spPr>
+          <a:xfrm>
+            <a:off x="8364902" y="4997667"/>
+            <a:ext cx="1407114" cy="216977"/>
+          </a:xfrm>
+          <a:prstGeom prst="roundRect">
+            <a:avLst/>
+          </a:prstGeom>
+          <a:solidFill>
+            <a:schemeClr val="bg1"/>
+          </a:solidFill>
+          <a:ln>
+            <a:noFill/>
+          </a:ln>
+        </p:spPr>
+        <p:style>
+          <a:lnRef idx="2">
+            <a:schemeClr val="accent1">
+              <a:shade val="50000"/>
+            </a:schemeClr>
+          </a:lnRef>
+          <a:fillRef idx="1">
+            <a:schemeClr val="accent1"/>
+          </a:fillRef>
+          <a:effectRef idx="0">
+            <a:schemeClr val="accent1"/>
+          </a:effectRef>
+          <a:fontRef idx="minor">
+            <a:schemeClr val="lt1"/>
+          </a:fontRef>
+        </p:style>
+        <p:txBody>
+          <a:bodyPr rtlCol="0" anchor="ctr"/>
+          <a:lstStyle/>
+          <a:p>
+            <a:pPr algn="ctr"/>
+            <a:r>
+              <a:rPr lang="es-CO" sz="1600" dirty="0">
+                <a:solidFill>
+                  <a:schemeClr val="tx1"/>
+                </a:solidFill>
+              </a:rPr>
+              <a:t>Ética</a:t>
+            </a:r>
+          </a:p>
+        </p:txBody>
+      </p:sp>
+      <p:sp>
+        <p:nvSpPr>
+          <p:cNvPr id="41" name="Rectángulo: esquinas redondeadas 40">
+            <a:extLst>
+              <a:ext uri="{FF2B5EF4-FFF2-40B4-BE49-F238E27FC236}">
+                <a16:creationId xmlns:a16="http://schemas.microsoft.com/office/drawing/2014/main" id="{FB23FACC-0927-6527-8210-9E07CFE76CE3}"/>
+              </a:ext>
+            </a:extLst>
+          </p:cNvPr>
+          <p:cNvSpPr/>
+          <p:nvPr/>
+        </p:nvSpPr>
+        <p:spPr>
+          <a:xfrm>
+            <a:off x="8239911" y="5370306"/>
+            <a:ext cx="1407114" cy="216977"/>
+          </a:xfrm>
+          <a:prstGeom prst="roundRect">
+            <a:avLst/>
+          </a:prstGeom>
+          <a:solidFill>
+            <a:schemeClr val="bg1"/>
+          </a:solidFill>
+          <a:ln>
+            <a:noFill/>
+          </a:ln>
+        </p:spPr>
+        <p:style>
+          <a:lnRef idx="2">
+            <a:schemeClr val="accent1">
+              <a:shade val="50000"/>
+            </a:schemeClr>
+          </a:lnRef>
+          <a:fillRef idx="1">
+            <a:schemeClr val="accent1"/>
+          </a:fillRef>
+          <a:effectRef idx="0">
+            <a:schemeClr val="accent1"/>
+          </a:effectRef>
+          <a:fontRef idx="minor">
+            <a:schemeClr val="lt1"/>
+          </a:fontRef>
+        </p:style>
+        <p:txBody>
+          <a:bodyPr rtlCol="0" anchor="ctr"/>
+          <a:lstStyle/>
+          <a:p>
+            <a:pPr algn="ctr"/>
+            <a:r>
+              <a:rPr lang="es-CO" sz="1600" dirty="0">
+                <a:solidFill>
+                  <a:schemeClr val="tx1"/>
+                </a:solidFill>
+              </a:rPr>
+              <a:t>Concepto</a:t>
+            </a:r>
+          </a:p>
+        </p:txBody>
+      </p:sp>
+      <p:pic>
+        <p:nvPicPr>
+          <p:cNvPr id="43" name="Imagen 42">
+            <a:extLst>
+              <a:ext uri="{FF2B5EF4-FFF2-40B4-BE49-F238E27FC236}">
+                <a16:creationId xmlns:a16="http://schemas.microsoft.com/office/drawing/2014/main" id="{CFBF11B3-35EA-96C3-2C34-8CA8D1FE4098}"/>
+              </a:ext>
+            </a:extLst>
+          </p:cNvPr>
+          <p:cNvPicPr>
+            <a:picLocks noChangeAspect="1"/>
+          </p:cNvPicPr>
+          <p:nvPr/>
+        </p:nvPicPr>
+        <p:blipFill>
+          <a:blip r:embed="rId5"/>
+          <a:stretch>
+            <a:fillRect/>
+          </a:stretch>
+        </p:blipFill>
+        <p:spPr>
+          <a:xfrm>
+            <a:off x="9585033" y="4920926"/>
+            <a:ext cx="2250314" cy="1274618"/>
+          </a:xfrm>
+          <a:prstGeom prst="rect">
+            <a:avLst/>
+          </a:prstGeom>
+        </p:spPr>
+      </p:pic>
+      <p:sp>
+        <p:nvSpPr>
+          <p:cNvPr id="46" name="Rectángulo 45">
+            <a:extLst>
+              <a:ext uri="{FF2B5EF4-FFF2-40B4-BE49-F238E27FC236}">
+                <a16:creationId xmlns:a16="http://schemas.microsoft.com/office/drawing/2014/main" id="{E36FE3F4-9027-D2B2-0CA0-775BBDEE594D}"/>
+              </a:ext>
+            </a:extLst>
+          </p:cNvPr>
+          <p:cNvSpPr/>
+          <p:nvPr/>
+        </p:nvSpPr>
+        <p:spPr>
+          <a:xfrm>
+            <a:off x="9170815" y="6195544"/>
+            <a:ext cx="2250314" cy="133270"/>
+          </a:xfrm>
+          <a:prstGeom prst="rect">
+            <a:avLst/>
+          </a:prstGeom>
+          <a:solidFill>
+            <a:schemeClr val="bg1"/>
+          </a:solidFill>
+          <a:ln>
+            <a:noFill/>
+          </a:ln>
+        </p:spPr>
+        <p:style>
+          <a:lnRef idx="2">
+            <a:schemeClr val="accent1">
+              <a:shade val="50000"/>
+            </a:schemeClr>
+          </a:lnRef>
+          <a:fillRef idx="1">
+            <a:schemeClr val="accent1"/>
+          </a:fillRef>
+          <a:effectRef idx="0">
+            <a:schemeClr val="accent1"/>
+          </a:effectRef>
+          <a:fontRef idx="minor">
+            <a:schemeClr val="lt1"/>
+          </a:fontRef>
+        </p:style>
+        <p:txBody>
+          <a:bodyPr rtlCol="0" anchor="ctr"/>
+          <a:lstStyle/>
+          <a:p>
+            <a:pPr algn="ctr"/>
+            <a:endParaRPr lang="es-CO"/>
+          </a:p>
+        </p:txBody>
+      </p:sp>
+      <p:pic>
+        <p:nvPicPr>
+          <p:cNvPr id="45" name="Gráfico 44" descr="Lupa">
+            <a:extLst>
+              <a:ext uri="{FF2B5EF4-FFF2-40B4-BE49-F238E27FC236}">
+                <a16:creationId xmlns:a16="http://schemas.microsoft.com/office/drawing/2014/main" id="{F69B865E-9B16-5794-6A67-0567EA8D5C79}"/>
+              </a:ext>
+            </a:extLst>
+          </p:cNvPr>
+          <p:cNvPicPr>
+            <a:picLocks noChangeAspect="1"/>
+          </p:cNvPicPr>
+          <p:nvPr/>
+        </p:nvPicPr>
+        <p:blipFill>
+          <a:blip r:embed="rId6">
+            <a:extLst>
+              <a:ext uri="{28A0092B-C50C-407E-A947-70E740481C1C}">
+                <a14:useLocalDpi xmlns:a14="http://schemas.microsoft.com/office/drawing/2010/main" val="0"/>
+              </a:ext>
+              <a:ext uri="{96DAC541-7B7A-43D3-8B79-37D633B846F1}">
+                <asvg:svgBlip xmlns:asvg="http://schemas.microsoft.com/office/drawing/2016/SVG/main" r:embed="rId7"/>
+              </a:ext>
+            </a:extLst>
+          </a:blip>
+          <a:stretch>
+            <a:fillRect/>
+          </a:stretch>
+        </p:blipFill>
+        <p:spPr>
+          <a:xfrm rot="10800000">
+            <a:off x="7818335" y="2883760"/>
+            <a:ext cx="4735291" cy="4367636"/>
+          </a:xfrm>
+          <a:prstGeom prst="rect">
+            <a:avLst/>
+          </a:prstGeom>
+        </p:spPr>
+      </p:pic>
+    </p:spTree>
+    <p:extLst>
+      <p:ext uri="{BB962C8B-B14F-4D97-AF65-F5344CB8AC3E}">
+        <p14:creationId xmlns:p14="http://schemas.microsoft.com/office/powerpoint/2010/main" val="2222916504"/>
+      </p:ext>
+    </p:extLst>
+  </p:cSld>
+  <p:clrMapOvr>
+    <a:masterClrMapping/>
+  </p:clrMapOvr>
+</p:sld>
+</file>
+
+<file path=ppt/slides/slide3.xml><?xml version="1.0" encoding="utf-8"?>
+<p:sld xmlns:a="http://schemas.openxmlformats.org/drawingml/2006/main" xmlns:r="http://schemas.openxmlformats.org/officeDocument/2006/relationships" xmlns:p="http://schemas.openxmlformats.org/presentationml/2006/main">
+  <p:cSld>
+    <p:bg>
+      <p:bgPr>
+        <a:solidFill>
+          <a:schemeClr val="tx1">
+            <a:lumMod val="65000"/>
+            <a:lumOff val="35000"/>
+            <a:alpha val="84000"/>
+          </a:schemeClr>
+        </a:solidFill>
+        <a:effectLst/>
+      </p:bgPr>
+    </p:bg>
+    <p:spTree>
+      <p:nvGrpSpPr>
+        <p:cNvPr id="1" name=""/>
+        <p:cNvGrpSpPr/>
+        <p:nvPr/>
+      </p:nvGrpSpPr>
+      <p:grpSpPr>
+        <a:xfrm>
+          <a:off x="0" y="0"/>
+          <a:ext cx="0" cy="0"/>
+          <a:chOff x="0" y="0"/>
+          <a:chExt cx="0" cy="0"/>
+        </a:xfrm>
+      </p:grpSpPr>
+      <p:pic>
+        <p:nvPicPr>
+          <p:cNvPr id="16" name="Imagen 15">
+            <a:extLst>
+              <a:ext uri="{FF2B5EF4-FFF2-40B4-BE49-F238E27FC236}">
+                <a16:creationId xmlns:a16="http://schemas.microsoft.com/office/drawing/2014/main" id="{99184DDC-17B3-336F-0A3C-3250807BB2B1}"/>
+              </a:ext>
+            </a:extLst>
+          </p:cNvPr>
+          <p:cNvPicPr>
+            <a:picLocks noChangeAspect="1"/>
+          </p:cNvPicPr>
+          <p:nvPr/>
+        </p:nvPicPr>
+        <p:blipFill>
+          <a:blip r:embed="rId2">
+            <a:extLst>
+              <a:ext uri="{28A0092B-C50C-407E-A947-70E740481C1C}">
+                <a14:useLocalDpi xmlns:a14="http://schemas.microsoft.com/office/drawing/2010/main" val="0"/>
+              </a:ext>
+            </a:extLst>
+          </a:blip>
+          <a:stretch>
+            <a:fillRect/>
+          </a:stretch>
+        </p:blipFill>
+        <p:spPr>
+          <a:xfrm>
+            <a:off x="1683025" y="250873"/>
+            <a:ext cx="6096000" cy="6180498"/>
+          </a:xfrm>
+          <a:prstGeom prst="rect">
+            <a:avLst/>
+          </a:prstGeom>
+        </p:spPr>
+      </p:pic>
+      <p:sp>
+        <p:nvSpPr>
+          <p:cNvPr id="17" name="Rectángulo 16">
+            <a:extLst>
+              <a:ext uri="{FF2B5EF4-FFF2-40B4-BE49-F238E27FC236}">
+                <a16:creationId xmlns:a16="http://schemas.microsoft.com/office/drawing/2014/main" id="{A8B8087A-F01D-7BF2-7B9B-803D42A31868}"/>
+              </a:ext>
+            </a:extLst>
+          </p:cNvPr>
+          <p:cNvSpPr/>
+          <p:nvPr/>
+        </p:nvSpPr>
+        <p:spPr>
+          <a:xfrm>
+            <a:off x="0" y="0"/>
+            <a:ext cx="12192000" cy="6858000"/>
+          </a:xfrm>
+          <a:prstGeom prst="rect">
+            <a:avLst/>
+          </a:prstGeom>
+          <a:solidFill>
+            <a:schemeClr val="accent4">
+              <a:lumMod val="60000"/>
+              <a:lumOff val="40000"/>
+              <a:alpha val="44000"/>
+            </a:schemeClr>
+          </a:solidFill>
+          <a:ln>
+            <a:noFill/>
+          </a:ln>
+        </p:spPr>
+        <p:style>
+          <a:lnRef idx="2">
+            <a:schemeClr val="accent1">
+              <a:shade val="50000"/>
+            </a:schemeClr>
+          </a:lnRef>
+          <a:fillRef idx="1">
+            <a:schemeClr val="accent1"/>
+          </a:fillRef>
+          <a:effectRef idx="0">
+            <a:schemeClr val="accent1"/>
+          </a:effectRef>
+          <a:fontRef idx="minor">
+            <a:schemeClr val="lt1"/>
+          </a:fontRef>
+        </p:style>
+        <p:txBody>
+          <a:bodyPr rtlCol="0" anchor="ctr"/>
+          <a:lstStyle/>
+          <a:p>
+            <a:pPr algn="ctr"/>
+            <a:endParaRPr lang="es-CO"/>
+          </a:p>
+        </p:txBody>
+      </p:sp>
+      <p:sp>
+        <p:nvSpPr>
           <p:cNvPr id="8" name="CuadroTexto 7">
             <a:extLst>
               <a:ext uri="{FF2B5EF4-FFF2-40B4-BE49-F238E27FC236}">
@@ -4755,7 +5439,7 @@
                   <a:schemeClr val="tx1"/>
                 </a:solidFill>
               </a:rPr>
-              <a:t>Ahora podrá ver los días transcurridos desde la última actuación creada por el estudiante. </a:t>
+              <a:t>Podrá ver los días transcurridos desde la última actuación creada por el estudiante. </a:t>
             </a:r>
           </a:p>
         </p:txBody>

</xml_diff>

<commit_message>
evaluar casos de asesoria
</commit_message>
<xml_diff>
--- a/public/dist/img/update/Presentación1.pptx
+++ b/public/dist/img/update/Presentación1.pptx
@@ -6,16 +6,19 @@
   </p:sldMasterIdLst>
   <p:sldIdLst>
     <p:sldId id="260" r:id="rId2"/>
-    <p:sldId id="269" r:id="rId3"/>
-    <p:sldId id="266" r:id="rId4"/>
-    <p:sldId id="271" r:id="rId5"/>
-    <p:sldId id="270" r:id="rId6"/>
-    <p:sldId id="267" r:id="rId7"/>
-    <p:sldId id="262" r:id="rId8"/>
-    <p:sldId id="268" r:id="rId9"/>
-    <p:sldId id="265" r:id="rId10"/>
-    <p:sldId id="263" r:id="rId11"/>
-    <p:sldId id="264" r:id="rId12"/>
+    <p:sldId id="273" r:id="rId3"/>
+    <p:sldId id="272" r:id="rId4"/>
+    <p:sldId id="269" r:id="rId5"/>
+    <p:sldId id="266" r:id="rId6"/>
+    <p:sldId id="271" r:id="rId7"/>
+    <p:sldId id="275" r:id="rId8"/>
+    <p:sldId id="270" r:id="rId9"/>
+    <p:sldId id="267" r:id="rId10"/>
+    <p:sldId id="262" r:id="rId11"/>
+    <p:sldId id="268" r:id="rId12"/>
+    <p:sldId id="265" r:id="rId13"/>
+    <p:sldId id="263" r:id="rId14"/>
+    <p:sldId id="264" r:id="rId15"/>
   </p:sldIdLst>
   <p:sldSz cx="12192000" cy="6858000"/>
   <p:notesSz cx="6858000" cy="9144000"/>
@@ -271,7 +274,7 @@
           <a:p>
             <a:fld id="{F7EB7AD6-F7F4-4A3B-9140-B8481AFC5E85}" type="datetimeFigureOut">
               <a:rPr lang="es-CO" smtClean="0"/>
-              <a:t>26/01/2024</a:t>
+              <a:t>28/04/2024</a:t>
             </a:fld>
             <a:endParaRPr lang="es-CO"/>
           </a:p>
@@ -471,7 +474,7 @@
           <a:p>
             <a:fld id="{F7EB7AD6-F7F4-4A3B-9140-B8481AFC5E85}" type="datetimeFigureOut">
               <a:rPr lang="es-CO" smtClean="0"/>
-              <a:t>26/01/2024</a:t>
+              <a:t>28/04/2024</a:t>
             </a:fld>
             <a:endParaRPr lang="es-CO"/>
           </a:p>
@@ -681,7 +684,7 @@
           <a:p>
             <a:fld id="{F7EB7AD6-F7F4-4A3B-9140-B8481AFC5E85}" type="datetimeFigureOut">
               <a:rPr lang="es-CO" smtClean="0"/>
-              <a:t>26/01/2024</a:t>
+              <a:t>28/04/2024</a:t>
             </a:fld>
             <a:endParaRPr lang="es-CO"/>
           </a:p>
@@ -881,7 +884,7 @@
           <a:p>
             <a:fld id="{F7EB7AD6-F7F4-4A3B-9140-B8481AFC5E85}" type="datetimeFigureOut">
               <a:rPr lang="es-CO" smtClean="0"/>
-              <a:t>26/01/2024</a:t>
+              <a:t>28/04/2024</a:t>
             </a:fld>
             <a:endParaRPr lang="es-CO"/>
           </a:p>
@@ -1157,7 +1160,7 @@
           <a:p>
             <a:fld id="{F7EB7AD6-F7F4-4A3B-9140-B8481AFC5E85}" type="datetimeFigureOut">
               <a:rPr lang="es-CO" smtClean="0"/>
-              <a:t>26/01/2024</a:t>
+              <a:t>28/04/2024</a:t>
             </a:fld>
             <a:endParaRPr lang="es-CO"/>
           </a:p>
@@ -1425,7 +1428,7 @@
           <a:p>
             <a:fld id="{F7EB7AD6-F7F4-4A3B-9140-B8481AFC5E85}" type="datetimeFigureOut">
               <a:rPr lang="es-CO" smtClean="0"/>
-              <a:t>26/01/2024</a:t>
+              <a:t>28/04/2024</a:t>
             </a:fld>
             <a:endParaRPr lang="es-CO"/>
           </a:p>
@@ -1840,7 +1843,7 @@
           <a:p>
             <a:fld id="{F7EB7AD6-F7F4-4A3B-9140-B8481AFC5E85}" type="datetimeFigureOut">
               <a:rPr lang="es-CO" smtClean="0"/>
-              <a:t>26/01/2024</a:t>
+              <a:t>28/04/2024</a:t>
             </a:fld>
             <a:endParaRPr lang="es-CO"/>
           </a:p>
@@ -1982,7 +1985,7 @@
           <a:p>
             <a:fld id="{F7EB7AD6-F7F4-4A3B-9140-B8481AFC5E85}" type="datetimeFigureOut">
               <a:rPr lang="es-CO" smtClean="0"/>
-              <a:t>26/01/2024</a:t>
+              <a:t>28/04/2024</a:t>
             </a:fld>
             <a:endParaRPr lang="es-CO"/>
           </a:p>
@@ -2095,7 +2098,7 @@
           <a:p>
             <a:fld id="{F7EB7AD6-F7F4-4A3B-9140-B8481AFC5E85}" type="datetimeFigureOut">
               <a:rPr lang="es-CO" smtClean="0"/>
-              <a:t>26/01/2024</a:t>
+              <a:t>28/04/2024</a:t>
             </a:fld>
             <a:endParaRPr lang="es-CO"/>
           </a:p>
@@ -2408,7 +2411,7 @@
           <a:p>
             <a:fld id="{F7EB7AD6-F7F4-4A3B-9140-B8481AFC5E85}" type="datetimeFigureOut">
               <a:rPr lang="es-CO" smtClean="0"/>
-              <a:t>26/01/2024</a:t>
+              <a:t>28/04/2024</a:t>
             </a:fld>
             <a:endParaRPr lang="es-CO"/>
           </a:p>
@@ -2697,7 +2700,7 @@
           <a:p>
             <a:fld id="{F7EB7AD6-F7F4-4A3B-9140-B8481AFC5E85}" type="datetimeFigureOut">
               <a:rPr lang="es-CO" smtClean="0"/>
-              <a:t>26/01/2024</a:t>
+              <a:t>28/04/2024</a:t>
             </a:fld>
             <a:endParaRPr lang="es-CO"/>
           </a:p>
@@ -2940,7 +2943,7 @@
           <a:p>
             <a:fld id="{F7EB7AD6-F7F4-4A3B-9140-B8481AFC5E85}" type="datetimeFigureOut">
               <a:rPr lang="es-CO" smtClean="0"/>
-              <a:t>26/01/2024</a:t>
+              <a:t>28/04/2024</a:t>
             </a:fld>
             <a:endParaRPr lang="es-CO"/>
           </a:p>
@@ -3036,6 +3039,78 @@
           </a:p>
         </p:txBody>
       </p:sp>
+      <p:pic>
+        <p:nvPicPr>
+          <p:cNvPr id="8" name="Imagen 7">
+            <a:extLst>
+              <a:ext uri="{FF2B5EF4-FFF2-40B4-BE49-F238E27FC236}">
+                <a16:creationId xmlns:a16="http://schemas.microsoft.com/office/drawing/2014/main" id="{A3AB5A69-08DC-0FCD-3B67-4B908C1EEBAB}"/>
+              </a:ext>
+            </a:extLst>
+          </p:cNvPr>
+          <p:cNvPicPr>
+            <a:picLocks noChangeAspect="1"/>
+          </p:cNvPicPr>
+          <p:nvPr userDrawn="1"/>
+        </p:nvPicPr>
+        <p:blipFill>
+          <a:blip r:embed="rId13">
+            <a:extLst>
+              <a:ext uri="{28A0092B-C50C-407E-A947-70E740481C1C}">
+                <a14:useLocalDpi xmlns:a14="http://schemas.microsoft.com/office/drawing/2010/main" val="0"/>
+              </a:ext>
+            </a:extLst>
+          </a:blip>
+          <a:stretch>
+            <a:fillRect/>
+          </a:stretch>
+        </p:blipFill>
+        <p:spPr>
+          <a:xfrm>
+            <a:off x="84580" y="84137"/>
+            <a:ext cx="540000" cy="607220"/>
+          </a:xfrm>
+          <a:prstGeom prst="rect">
+            <a:avLst/>
+          </a:prstGeom>
+        </p:spPr>
+      </p:pic>
+      <p:pic>
+        <p:nvPicPr>
+          <p:cNvPr id="9" name="Imagen 8">
+            <a:extLst>
+              <a:ext uri="{FF2B5EF4-FFF2-40B4-BE49-F238E27FC236}">
+                <a16:creationId xmlns:a16="http://schemas.microsoft.com/office/drawing/2014/main" id="{2D7D48E2-CEFF-1B62-7532-786A325AC742}"/>
+              </a:ext>
+            </a:extLst>
+          </p:cNvPr>
+          <p:cNvPicPr>
+            <a:picLocks noChangeAspect="1"/>
+          </p:cNvPicPr>
+          <p:nvPr userDrawn="1"/>
+        </p:nvPicPr>
+        <p:blipFill>
+          <a:blip r:embed="rId14">
+            <a:extLst>
+              <a:ext uri="{28A0092B-C50C-407E-A947-70E740481C1C}">
+                <a14:useLocalDpi xmlns:a14="http://schemas.microsoft.com/office/drawing/2010/main" val="0"/>
+              </a:ext>
+            </a:extLst>
+          </a:blip>
+          <a:stretch>
+            <a:fillRect/>
+          </a:stretch>
+        </p:blipFill>
+        <p:spPr>
+          <a:xfrm>
+            <a:off x="11587731" y="6176963"/>
+            <a:ext cx="591818" cy="600893"/>
+          </a:xfrm>
+          <a:prstGeom prst="rect">
+            <a:avLst/>
+          </a:prstGeom>
+        </p:spPr>
+      </p:pic>
     </p:spTree>
     <p:extLst>
       <p:ext uri="{BB962C8B-B14F-4D97-AF65-F5344CB8AC3E}">
@@ -3509,7 +3584,7 @@
                   </a:schemeClr>
                 </a:solidFill>
               </a:rPr>
-              <a:t>Dar de baja </a:t>
+              <a:t>EVALUAR </a:t>
             </a:r>
             <a:r>
               <a:rPr lang="es-MX" sz="3600" dirty="0">
@@ -3783,6 +3858,886 @@
         <p:spPr>
           <a:xfrm>
             <a:off x="318426" y="445008"/>
+            <a:ext cx="11268635" cy="7048083"/>
+          </a:xfrm>
+          <a:prstGeom prst="rect">
+            <a:avLst/>
+          </a:prstGeom>
+          <a:noFill/>
+        </p:spPr>
+        <p:txBody>
+          <a:bodyPr wrap="square" rtlCol="0">
+            <a:spAutoFit/>
+          </a:bodyPr>
+          <a:lstStyle/>
+          <a:p>
+            <a:pPr algn="ctr"/>
+            <a:endParaRPr lang="es-MX" sz="3600" dirty="0">
+              <a:solidFill>
+                <a:schemeClr val="bg1"/>
+              </a:solidFill>
+            </a:endParaRPr>
+          </a:p>
+          <a:p>
+            <a:pPr algn="ctr"/>
+            <a:r>
+              <a:rPr lang="es-MX" sz="3600" dirty="0">
+                <a:solidFill>
+                  <a:schemeClr val="bg1"/>
+                </a:solidFill>
+              </a:rPr>
+              <a:t>Para poner en </a:t>
+            </a:r>
+            <a:r>
+              <a:rPr lang="es-MX" sz="3600" b="1" dirty="0">
+                <a:solidFill>
+                  <a:schemeClr val="accent4">
+                    <a:lumMod val="60000"/>
+                    <a:lumOff val="40000"/>
+                  </a:schemeClr>
+                </a:solidFill>
+              </a:rPr>
+              <a:t>Revisión</a:t>
+            </a:r>
+            <a:r>
+              <a:rPr lang="es-MX" sz="3600" dirty="0">
+                <a:solidFill>
+                  <a:schemeClr val="bg1"/>
+                </a:solidFill>
+              </a:rPr>
+              <a:t> en cierre de caso de clic en el botón </a:t>
+            </a:r>
+            <a:r>
+              <a:rPr lang="es-MX" sz="3600" b="1" i="1" dirty="0">
+                <a:solidFill>
+                  <a:schemeClr val="bg1"/>
+                </a:solidFill>
+              </a:rPr>
+              <a:t>Pasar a </a:t>
+            </a:r>
+            <a:r>
+              <a:rPr lang="es-MX" sz="3600" b="1" i="1" dirty="0" err="1">
+                <a:solidFill>
+                  <a:schemeClr val="bg1"/>
+                </a:solidFill>
+              </a:rPr>
+              <a:t>revisón</a:t>
+            </a:r>
+            <a:endParaRPr lang="es-MX" sz="3600" b="1" i="1" dirty="0">
+              <a:solidFill>
+                <a:schemeClr val="bg1"/>
+              </a:solidFill>
+            </a:endParaRPr>
+          </a:p>
+          <a:p>
+            <a:pPr algn="ctr"/>
+            <a:endParaRPr lang="es-MX" sz="3600" dirty="0">
+              <a:solidFill>
+                <a:schemeClr val="bg1"/>
+              </a:solidFill>
+            </a:endParaRPr>
+          </a:p>
+          <a:p>
+            <a:pPr algn="ctr"/>
+            <a:endParaRPr lang="es-MX" sz="3600" dirty="0">
+              <a:solidFill>
+                <a:schemeClr val="bg1"/>
+              </a:solidFill>
+            </a:endParaRPr>
+          </a:p>
+          <a:p>
+            <a:pPr algn="ctr"/>
+            <a:endParaRPr lang="es-MX" sz="3600" dirty="0">
+              <a:solidFill>
+                <a:schemeClr val="bg1"/>
+              </a:solidFill>
+            </a:endParaRPr>
+          </a:p>
+          <a:p>
+            <a:pPr algn="ctr"/>
+            <a:endParaRPr lang="es-MX" sz="3600" dirty="0">
+              <a:solidFill>
+                <a:schemeClr val="bg1"/>
+              </a:solidFill>
+            </a:endParaRPr>
+          </a:p>
+          <a:p>
+            <a:pPr algn="ctr"/>
+            <a:endParaRPr lang="es-MX" sz="3600" dirty="0">
+              <a:solidFill>
+                <a:schemeClr val="bg1"/>
+              </a:solidFill>
+            </a:endParaRPr>
+          </a:p>
+          <a:p>
+            <a:pPr algn="ctr"/>
+            <a:endParaRPr lang="es-MX" sz="3600" dirty="0">
+              <a:solidFill>
+                <a:schemeClr val="bg1"/>
+              </a:solidFill>
+            </a:endParaRPr>
+          </a:p>
+          <a:p>
+            <a:pPr algn="ctr"/>
+            <a:endParaRPr lang="es-MX" sz="3600" dirty="0">
+              <a:solidFill>
+                <a:schemeClr val="bg1"/>
+              </a:solidFill>
+            </a:endParaRPr>
+          </a:p>
+          <a:p>
+            <a:pPr algn="ctr"/>
+            <a:endParaRPr lang="es-MX" sz="3600" dirty="0">
+              <a:solidFill>
+                <a:schemeClr val="bg1"/>
+              </a:solidFill>
+            </a:endParaRPr>
+          </a:p>
+          <a:p>
+            <a:pPr algn="ctr"/>
+            <a:endParaRPr lang="es-MX" sz="3600" dirty="0">
+              <a:solidFill>
+                <a:schemeClr val="bg1"/>
+              </a:solidFill>
+            </a:endParaRPr>
+          </a:p>
+          <a:p>
+            <a:r>
+              <a:rPr lang="es-CO" sz="2000" dirty="0" err="1">
+                <a:solidFill>
+                  <a:schemeClr val="bg1"/>
+                </a:solidFill>
+              </a:rPr>
+              <a:t>Amatai</a:t>
+            </a:r>
+            <a:r>
+              <a:rPr lang="es-CO" sz="2000" dirty="0">
+                <a:solidFill>
+                  <a:schemeClr val="bg1"/>
+                </a:solidFill>
+              </a:rPr>
+              <a:t> SAS</a:t>
+            </a:r>
+          </a:p>
+        </p:txBody>
+      </p:sp>
+      <p:pic>
+        <p:nvPicPr>
+          <p:cNvPr id="11" name="Imagen 10">
+            <a:extLst>
+              <a:ext uri="{FF2B5EF4-FFF2-40B4-BE49-F238E27FC236}">
+                <a16:creationId xmlns:a16="http://schemas.microsoft.com/office/drawing/2014/main" id="{5B1CAB16-AAFF-0020-E3FE-85BE9C43733E}"/>
+              </a:ext>
+            </a:extLst>
+          </p:cNvPr>
+          <p:cNvPicPr>
+            <a:picLocks noChangeAspect="1"/>
+          </p:cNvPicPr>
+          <p:nvPr/>
+        </p:nvPicPr>
+        <p:blipFill>
+          <a:blip r:embed="rId3"/>
+          <a:stretch>
+            <a:fillRect/>
+          </a:stretch>
+        </p:blipFill>
+        <p:spPr>
+          <a:xfrm>
+            <a:off x="239522" y="2903174"/>
+            <a:ext cx="11712955" cy="1051651"/>
+          </a:xfrm>
+          <a:prstGeom prst="rect">
+            <a:avLst/>
+          </a:prstGeom>
+        </p:spPr>
+      </p:pic>
+      <p:sp>
+        <p:nvSpPr>
+          <p:cNvPr id="9" name="Rectángulo 8">
+            <a:extLst>
+              <a:ext uri="{FF2B5EF4-FFF2-40B4-BE49-F238E27FC236}">
+                <a16:creationId xmlns:a16="http://schemas.microsoft.com/office/drawing/2014/main" id="{19CE3575-09A8-0984-60D0-CDEE01EEEB27}"/>
+              </a:ext>
+            </a:extLst>
+          </p:cNvPr>
+          <p:cNvSpPr/>
+          <p:nvPr/>
+        </p:nvSpPr>
+        <p:spPr>
+          <a:xfrm>
+            <a:off x="239522" y="3452565"/>
+            <a:ext cx="11712954" cy="661164"/>
+          </a:xfrm>
+          <a:prstGeom prst="rect">
+            <a:avLst/>
+          </a:prstGeom>
+          <a:ln>
+            <a:noFill/>
+          </a:ln>
+        </p:spPr>
+        <p:style>
+          <a:lnRef idx="2">
+            <a:schemeClr val="accent6"/>
+          </a:lnRef>
+          <a:fillRef idx="1">
+            <a:schemeClr val="lt1"/>
+          </a:fillRef>
+          <a:effectRef idx="0">
+            <a:schemeClr val="accent6"/>
+          </a:effectRef>
+          <a:fontRef idx="minor">
+            <a:schemeClr val="dk1"/>
+          </a:fontRef>
+        </p:style>
+        <p:txBody>
+          <a:bodyPr rtlCol="0" anchor="ctr"/>
+          <a:lstStyle/>
+          <a:p>
+            <a:pPr algn="ctr"/>
+            <a:endParaRPr lang="es-CO"/>
+          </a:p>
+        </p:txBody>
+      </p:sp>
+      <p:pic>
+        <p:nvPicPr>
+          <p:cNvPr id="6" name="Imagen 5">
+            <a:extLst>
+              <a:ext uri="{FF2B5EF4-FFF2-40B4-BE49-F238E27FC236}">
+                <a16:creationId xmlns:a16="http://schemas.microsoft.com/office/drawing/2014/main" id="{64A37F9C-3281-B95E-E2B7-E03DE749C2AA}"/>
+              </a:ext>
+            </a:extLst>
+          </p:cNvPr>
+          <p:cNvPicPr>
+            <a:picLocks noChangeAspect="1"/>
+          </p:cNvPicPr>
+          <p:nvPr/>
+        </p:nvPicPr>
+        <p:blipFill>
+          <a:blip r:embed="rId4"/>
+          <a:stretch>
+            <a:fillRect/>
+          </a:stretch>
+        </p:blipFill>
+        <p:spPr>
+          <a:xfrm>
+            <a:off x="8717173" y="3433863"/>
+            <a:ext cx="2140377" cy="661164"/>
+          </a:xfrm>
+          <a:prstGeom prst="rect">
+            <a:avLst/>
+          </a:prstGeom>
+        </p:spPr>
+      </p:pic>
+      <p:pic>
+        <p:nvPicPr>
+          <p:cNvPr id="8" name="Gráfico 7" descr="Lupa">
+            <a:extLst>
+              <a:ext uri="{FF2B5EF4-FFF2-40B4-BE49-F238E27FC236}">
+                <a16:creationId xmlns:a16="http://schemas.microsoft.com/office/drawing/2014/main" id="{70287BDA-E56B-9DF6-26A8-A0F53C4766DE}"/>
+              </a:ext>
+            </a:extLst>
+          </p:cNvPr>
+          <p:cNvPicPr>
+            <a:picLocks noChangeAspect="1"/>
+          </p:cNvPicPr>
+          <p:nvPr/>
+        </p:nvPicPr>
+        <p:blipFill>
+          <a:blip r:embed="rId5">
+            <a:extLst>
+              <a:ext uri="{28A0092B-C50C-407E-A947-70E740481C1C}">
+                <a14:useLocalDpi xmlns:a14="http://schemas.microsoft.com/office/drawing/2010/main" val="0"/>
+              </a:ext>
+              <a:ext uri="{96DAC541-7B7A-43D3-8B79-37D633B846F1}">
+                <asvg:svgBlip xmlns:asvg="http://schemas.microsoft.com/office/drawing/2016/SVG/main" r:embed="rId6"/>
+              </a:ext>
+            </a:extLst>
+          </a:blip>
+          <a:stretch>
+            <a:fillRect/>
+          </a:stretch>
+        </p:blipFill>
+        <p:spPr>
+          <a:xfrm rot="5181362">
+            <a:off x="7319456" y="2349657"/>
+            <a:ext cx="4092798" cy="4018677"/>
+          </a:xfrm>
+          <a:prstGeom prst="rect">
+            <a:avLst/>
+          </a:prstGeom>
+        </p:spPr>
+      </p:pic>
+    </p:spTree>
+    <p:extLst>
+      <p:ext uri="{BB962C8B-B14F-4D97-AF65-F5344CB8AC3E}">
+        <p14:creationId xmlns:p14="http://schemas.microsoft.com/office/powerpoint/2010/main" val="5733342"/>
+      </p:ext>
+    </p:extLst>
+  </p:cSld>
+  <p:clrMapOvr>
+    <a:masterClrMapping/>
+  </p:clrMapOvr>
+</p:sld>
+</file>
+
+<file path=ppt/slides/slide11.xml><?xml version="1.0" encoding="utf-8"?>
+<p:sld xmlns:a="http://schemas.openxmlformats.org/drawingml/2006/main" xmlns:r="http://schemas.openxmlformats.org/officeDocument/2006/relationships" xmlns:p="http://schemas.openxmlformats.org/presentationml/2006/main">
+  <p:cSld>
+    <p:spTree>
+      <p:nvGrpSpPr>
+        <p:cNvPr id="1" name=""/>
+        <p:cNvGrpSpPr/>
+        <p:nvPr/>
+      </p:nvGrpSpPr>
+      <p:grpSpPr>
+        <a:xfrm>
+          <a:off x="0" y="0"/>
+          <a:ext cx="0" cy="0"/>
+          <a:chOff x="0" y="0"/>
+          <a:chExt cx="0" cy="0"/>
+        </a:xfrm>
+      </p:grpSpPr>
+      <p:pic>
+        <p:nvPicPr>
+          <p:cNvPr id="3" name="logo">
+            <a:extLst>
+              <a:ext uri="{FF2B5EF4-FFF2-40B4-BE49-F238E27FC236}">
+                <a16:creationId xmlns:a16="http://schemas.microsoft.com/office/drawing/2014/main" id="{CB7069CB-A915-E9BA-0362-5B269561515F}"/>
+              </a:ext>
+            </a:extLst>
+          </p:cNvPr>
+          <p:cNvPicPr>
+            <a:picLocks noChangeAspect="1"/>
+          </p:cNvPicPr>
+          <p:nvPr/>
+        </p:nvPicPr>
+        <p:blipFill>
+          <a:blip r:embed="rId2">
+            <a:extLst>
+              <a:ext uri="{28A0092B-C50C-407E-A947-70E740481C1C}">
+                <a14:useLocalDpi xmlns:a14="http://schemas.microsoft.com/office/drawing/2010/main" val="0"/>
+              </a:ext>
+            </a:extLst>
+          </a:blip>
+          <a:stretch>
+            <a:fillRect/>
+          </a:stretch>
+        </p:blipFill>
+        <p:spPr>
+          <a:xfrm>
+            <a:off x="8765519" y="3350269"/>
+            <a:ext cx="3426481" cy="3473976"/>
+          </a:xfrm>
+          <a:prstGeom prst="rect">
+            <a:avLst/>
+          </a:prstGeom>
+        </p:spPr>
+      </p:pic>
+      <p:sp>
+        <p:nvSpPr>
+          <p:cNvPr id="17" name="Rectángulo 16">
+            <a:extLst>
+              <a:ext uri="{FF2B5EF4-FFF2-40B4-BE49-F238E27FC236}">
+                <a16:creationId xmlns:a16="http://schemas.microsoft.com/office/drawing/2014/main" id="{A8B8087A-F01D-7BF2-7B9B-803D42A31868}"/>
+              </a:ext>
+            </a:extLst>
+          </p:cNvPr>
+          <p:cNvSpPr/>
+          <p:nvPr/>
+        </p:nvSpPr>
+        <p:spPr>
+          <a:xfrm>
+            <a:off x="0" y="0"/>
+            <a:ext cx="12192000" cy="6858000"/>
+          </a:xfrm>
+          <a:prstGeom prst="rect">
+            <a:avLst/>
+          </a:prstGeom>
+          <a:solidFill>
+            <a:schemeClr val="tx1">
+              <a:alpha val="70000"/>
+            </a:schemeClr>
+          </a:solidFill>
+          <a:ln>
+            <a:noFill/>
+          </a:ln>
+        </p:spPr>
+        <p:style>
+          <a:lnRef idx="2">
+            <a:schemeClr val="accent1">
+              <a:shade val="50000"/>
+            </a:schemeClr>
+          </a:lnRef>
+          <a:fillRef idx="1">
+            <a:schemeClr val="accent1"/>
+          </a:fillRef>
+          <a:effectRef idx="0">
+            <a:schemeClr val="accent1"/>
+          </a:effectRef>
+          <a:fontRef idx="minor">
+            <a:schemeClr val="lt1"/>
+          </a:fontRef>
+        </p:style>
+        <p:txBody>
+          <a:bodyPr rtlCol="0" anchor="ctr"/>
+          <a:lstStyle/>
+          <a:p>
+            <a:pPr algn="ctr"/>
+            <a:endParaRPr lang="es-CO">
+              <a:ln>
+                <a:solidFill>
+                  <a:schemeClr val="accent1"/>
+                </a:solidFill>
+              </a:ln>
+            </a:endParaRPr>
+          </a:p>
+        </p:txBody>
+      </p:sp>
+      <p:sp>
+        <p:nvSpPr>
+          <p:cNvPr id="10" name="CuadroTexto 9">
+            <a:extLst>
+              <a:ext uri="{FF2B5EF4-FFF2-40B4-BE49-F238E27FC236}">
+                <a16:creationId xmlns:a16="http://schemas.microsoft.com/office/drawing/2014/main" id="{C69317F1-3BC8-CC98-94BA-756E40E92416}"/>
+              </a:ext>
+            </a:extLst>
+          </p:cNvPr>
+          <p:cNvSpPr txBox="1"/>
+          <p:nvPr/>
+        </p:nvSpPr>
+        <p:spPr>
+          <a:xfrm>
+            <a:off x="1280159" y="5503453"/>
+            <a:ext cx="9924288" cy="1200329"/>
+          </a:xfrm>
+          <a:prstGeom prst="rect">
+            <a:avLst/>
+          </a:prstGeom>
+          <a:noFill/>
+        </p:spPr>
+        <p:txBody>
+          <a:bodyPr wrap="square">
+            <a:spAutoFit/>
+          </a:bodyPr>
+          <a:lstStyle/>
+          <a:p>
+            <a:pPr algn="ctr"/>
+            <a:r>
+              <a:rPr lang="es-MX" sz="3600" dirty="0">
+                <a:solidFill>
+                  <a:schemeClr val="bg1"/>
+                </a:solidFill>
+              </a:rPr>
+              <a:t>Ingrese una descripción y de clic en botón </a:t>
+            </a:r>
+          </a:p>
+          <a:p>
+            <a:pPr algn="ctr"/>
+            <a:r>
+              <a:rPr lang="es-MX" sz="3600" b="1" i="1" dirty="0">
+                <a:solidFill>
+                  <a:schemeClr val="accent4">
+                    <a:lumMod val="60000"/>
+                    <a:lumOff val="40000"/>
+                  </a:schemeClr>
+                </a:solidFill>
+              </a:rPr>
+              <a:t>Pasar a revisión</a:t>
+            </a:r>
+          </a:p>
+        </p:txBody>
+      </p:sp>
+      <p:pic>
+        <p:nvPicPr>
+          <p:cNvPr id="4" name="Imagen 3">
+            <a:extLst>
+              <a:ext uri="{FF2B5EF4-FFF2-40B4-BE49-F238E27FC236}">
+                <a16:creationId xmlns:a16="http://schemas.microsoft.com/office/drawing/2014/main" id="{9D70D671-5EC9-54B1-0582-072BDD2C4351}"/>
+              </a:ext>
+            </a:extLst>
+          </p:cNvPr>
+          <p:cNvPicPr>
+            <a:picLocks noChangeAspect="1"/>
+          </p:cNvPicPr>
+          <p:nvPr/>
+        </p:nvPicPr>
+        <p:blipFill>
+          <a:blip r:embed="rId3"/>
+          <a:stretch>
+            <a:fillRect/>
+          </a:stretch>
+        </p:blipFill>
+        <p:spPr>
+          <a:xfrm>
+            <a:off x="3592613" y="1748644"/>
+            <a:ext cx="5006774" cy="3360711"/>
+          </a:xfrm>
+          <a:prstGeom prst="rect">
+            <a:avLst/>
+          </a:prstGeom>
+        </p:spPr>
+      </p:pic>
+    </p:spTree>
+    <p:extLst>
+      <p:ext uri="{BB962C8B-B14F-4D97-AF65-F5344CB8AC3E}">
+        <p14:creationId xmlns:p14="http://schemas.microsoft.com/office/powerpoint/2010/main" val="2790284056"/>
+      </p:ext>
+    </p:extLst>
+  </p:cSld>
+  <p:clrMapOvr>
+    <a:masterClrMapping/>
+  </p:clrMapOvr>
+</p:sld>
+</file>
+
+<file path=ppt/slides/slide12.xml><?xml version="1.0" encoding="utf-8"?>
+<p:sld xmlns:a="http://schemas.openxmlformats.org/drawingml/2006/main" xmlns:r="http://schemas.openxmlformats.org/officeDocument/2006/relationships" xmlns:p="http://schemas.openxmlformats.org/presentationml/2006/main">
+  <p:cSld>
+    <p:spTree>
+      <p:nvGrpSpPr>
+        <p:cNvPr id="1" name=""/>
+        <p:cNvGrpSpPr/>
+        <p:nvPr/>
+      </p:nvGrpSpPr>
+      <p:grpSpPr>
+        <a:xfrm>
+          <a:off x="0" y="0"/>
+          <a:ext cx="0" cy="0"/>
+          <a:chOff x="0" y="0"/>
+          <a:chExt cx="0" cy="0"/>
+        </a:xfrm>
+      </p:grpSpPr>
+      <p:pic>
+        <p:nvPicPr>
+          <p:cNvPr id="3" name="logo">
+            <a:extLst>
+              <a:ext uri="{FF2B5EF4-FFF2-40B4-BE49-F238E27FC236}">
+                <a16:creationId xmlns:a16="http://schemas.microsoft.com/office/drawing/2014/main" id="{CB7069CB-A915-E9BA-0362-5B269561515F}"/>
+              </a:ext>
+            </a:extLst>
+          </p:cNvPr>
+          <p:cNvPicPr>
+            <a:picLocks noChangeAspect="1"/>
+          </p:cNvPicPr>
+          <p:nvPr/>
+        </p:nvPicPr>
+        <p:blipFill>
+          <a:blip r:embed="rId2">
+            <a:extLst>
+              <a:ext uri="{28A0092B-C50C-407E-A947-70E740481C1C}">
+                <a14:useLocalDpi xmlns:a14="http://schemas.microsoft.com/office/drawing/2010/main" val="0"/>
+              </a:ext>
+            </a:extLst>
+          </a:blip>
+          <a:stretch>
+            <a:fillRect/>
+          </a:stretch>
+        </p:blipFill>
+        <p:spPr>
+          <a:xfrm>
+            <a:off x="8765519" y="3350269"/>
+            <a:ext cx="3426481" cy="3473976"/>
+          </a:xfrm>
+          <a:prstGeom prst="rect">
+            <a:avLst/>
+          </a:prstGeom>
+        </p:spPr>
+      </p:pic>
+      <p:sp>
+        <p:nvSpPr>
+          <p:cNvPr id="17" name="Rectángulo 16">
+            <a:extLst>
+              <a:ext uri="{FF2B5EF4-FFF2-40B4-BE49-F238E27FC236}">
+                <a16:creationId xmlns:a16="http://schemas.microsoft.com/office/drawing/2014/main" id="{A8B8087A-F01D-7BF2-7B9B-803D42A31868}"/>
+              </a:ext>
+            </a:extLst>
+          </p:cNvPr>
+          <p:cNvSpPr/>
+          <p:nvPr/>
+        </p:nvSpPr>
+        <p:spPr>
+          <a:xfrm>
+            <a:off x="0" y="0"/>
+            <a:ext cx="12192000" cy="6858000"/>
+          </a:xfrm>
+          <a:prstGeom prst="rect">
+            <a:avLst/>
+          </a:prstGeom>
+          <a:solidFill>
+            <a:schemeClr val="tx1">
+              <a:alpha val="70000"/>
+            </a:schemeClr>
+          </a:solidFill>
+          <a:ln>
+            <a:noFill/>
+          </a:ln>
+        </p:spPr>
+        <p:style>
+          <a:lnRef idx="2">
+            <a:schemeClr val="accent1">
+              <a:shade val="50000"/>
+            </a:schemeClr>
+          </a:lnRef>
+          <a:fillRef idx="1">
+            <a:schemeClr val="accent1"/>
+          </a:fillRef>
+          <a:effectRef idx="0">
+            <a:schemeClr val="accent1"/>
+          </a:effectRef>
+          <a:fontRef idx="minor">
+            <a:schemeClr val="lt1"/>
+          </a:fontRef>
+        </p:style>
+        <p:txBody>
+          <a:bodyPr rtlCol="0" anchor="ctr"/>
+          <a:lstStyle/>
+          <a:p>
+            <a:pPr algn="ctr"/>
+            <a:endParaRPr lang="es-CO">
+              <a:ln>
+                <a:solidFill>
+                  <a:schemeClr val="accent1"/>
+                </a:solidFill>
+              </a:ln>
+            </a:endParaRPr>
+          </a:p>
+        </p:txBody>
+      </p:sp>
+      <p:sp>
+        <p:nvSpPr>
+          <p:cNvPr id="2" name="CuadroTexto 1">
+            <a:extLst>
+              <a:ext uri="{FF2B5EF4-FFF2-40B4-BE49-F238E27FC236}">
+                <a16:creationId xmlns:a16="http://schemas.microsoft.com/office/drawing/2014/main" id="{4BE15536-8584-618A-A38B-56A2C9028692}"/>
+              </a:ext>
+            </a:extLst>
+          </p:cNvPr>
+          <p:cNvSpPr txBox="1"/>
+          <p:nvPr/>
+        </p:nvSpPr>
+        <p:spPr>
+          <a:xfrm>
+            <a:off x="318426" y="445008"/>
+            <a:ext cx="11268635" cy="6494085"/>
+          </a:xfrm>
+          <a:prstGeom prst="rect">
+            <a:avLst/>
+          </a:prstGeom>
+          <a:noFill/>
+        </p:spPr>
+        <p:txBody>
+          <a:bodyPr wrap="square" rtlCol="0">
+            <a:spAutoFit/>
+          </a:bodyPr>
+          <a:lstStyle/>
+          <a:p>
+            <a:pPr algn="ctr"/>
+            <a:r>
+              <a:rPr lang="es-MX" sz="3600" dirty="0">
+                <a:solidFill>
+                  <a:schemeClr val="bg1"/>
+                </a:solidFill>
+              </a:rPr>
+              <a:t>Ahora IURIS le permite pausar los expedientes!</a:t>
+            </a:r>
+          </a:p>
+          <a:p>
+            <a:endParaRPr lang="es-MX" sz="3600" dirty="0">
+              <a:solidFill>
+                <a:schemeClr val="bg1"/>
+              </a:solidFill>
+            </a:endParaRPr>
+          </a:p>
+          <a:p>
+            <a:pPr algn="just"/>
+            <a:r>
+              <a:rPr lang="es-MX" sz="3600" dirty="0">
+                <a:solidFill>
+                  <a:schemeClr val="bg1"/>
+                </a:solidFill>
+              </a:rPr>
+              <a:t>Esta funcionalidad pone en pausa el tiempo de evaluación de actuaciones en aquellos expedientes abiertos que no tendrán actuaciones en un lapso determinado de tiempo.</a:t>
+            </a:r>
+          </a:p>
+          <a:p>
+            <a:endParaRPr lang="es-MX" sz="3600" dirty="0"/>
+          </a:p>
+          <a:p>
+            <a:endParaRPr lang="es-MX" sz="3600" dirty="0"/>
+          </a:p>
+          <a:p>
+            <a:endParaRPr lang="es-MX" sz="3600" dirty="0"/>
+          </a:p>
+          <a:p>
+            <a:endParaRPr lang="es-MX" sz="3600" dirty="0"/>
+          </a:p>
+          <a:p>
+            <a:endParaRPr lang="es-MX" sz="3600" dirty="0"/>
+          </a:p>
+          <a:p>
+            <a:endParaRPr lang="es-MX" sz="3600" dirty="0"/>
+          </a:p>
+          <a:p>
+            <a:r>
+              <a:rPr lang="es-CO" sz="2000" dirty="0" err="1">
+                <a:solidFill>
+                  <a:schemeClr val="bg1"/>
+                </a:solidFill>
+              </a:rPr>
+              <a:t>Amatai</a:t>
+            </a:r>
+            <a:r>
+              <a:rPr lang="es-CO" sz="2000" dirty="0">
+                <a:solidFill>
+                  <a:schemeClr val="bg1"/>
+                </a:solidFill>
+              </a:rPr>
+              <a:t> SAS</a:t>
+            </a:r>
+          </a:p>
+        </p:txBody>
+      </p:sp>
+    </p:spTree>
+    <p:extLst>
+      <p:ext uri="{BB962C8B-B14F-4D97-AF65-F5344CB8AC3E}">
+        <p14:creationId xmlns:p14="http://schemas.microsoft.com/office/powerpoint/2010/main" val="3888979096"/>
+      </p:ext>
+    </p:extLst>
+  </p:cSld>
+  <p:clrMapOvr>
+    <a:masterClrMapping/>
+  </p:clrMapOvr>
+</p:sld>
+</file>
+
+<file path=ppt/slides/slide13.xml><?xml version="1.0" encoding="utf-8"?>
+<p:sld xmlns:a="http://schemas.openxmlformats.org/drawingml/2006/main" xmlns:r="http://schemas.openxmlformats.org/officeDocument/2006/relationships" xmlns:p="http://schemas.openxmlformats.org/presentationml/2006/main">
+  <p:cSld>
+    <p:spTree>
+      <p:nvGrpSpPr>
+        <p:cNvPr id="1" name=""/>
+        <p:cNvGrpSpPr/>
+        <p:nvPr/>
+      </p:nvGrpSpPr>
+      <p:grpSpPr>
+        <a:xfrm>
+          <a:off x="0" y="0"/>
+          <a:ext cx="0" cy="0"/>
+          <a:chOff x="0" y="0"/>
+          <a:chExt cx="0" cy="0"/>
+        </a:xfrm>
+      </p:grpSpPr>
+      <p:pic>
+        <p:nvPicPr>
+          <p:cNvPr id="3" name="logo">
+            <a:extLst>
+              <a:ext uri="{FF2B5EF4-FFF2-40B4-BE49-F238E27FC236}">
+                <a16:creationId xmlns:a16="http://schemas.microsoft.com/office/drawing/2014/main" id="{CB7069CB-A915-E9BA-0362-5B269561515F}"/>
+              </a:ext>
+            </a:extLst>
+          </p:cNvPr>
+          <p:cNvPicPr>
+            <a:picLocks noChangeAspect="1"/>
+          </p:cNvPicPr>
+          <p:nvPr/>
+        </p:nvPicPr>
+        <p:blipFill>
+          <a:blip r:embed="rId2">
+            <a:extLst>
+              <a:ext uri="{28A0092B-C50C-407E-A947-70E740481C1C}">
+                <a14:useLocalDpi xmlns:a14="http://schemas.microsoft.com/office/drawing/2010/main" val="0"/>
+              </a:ext>
+            </a:extLst>
+          </a:blip>
+          <a:stretch>
+            <a:fillRect/>
+          </a:stretch>
+        </p:blipFill>
+        <p:spPr>
+          <a:xfrm>
+            <a:off x="8765519" y="3350269"/>
+            <a:ext cx="3426481" cy="3473976"/>
+          </a:xfrm>
+          <a:prstGeom prst="rect">
+            <a:avLst/>
+          </a:prstGeom>
+        </p:spPr>
+      </p:pic>
+      <p:sp>
+        <p:nvSpPr>
+          <p:cNvPr id="17" name="Rectángulo 16">
+            <a:extLst>
+              <a:ext uri="{FF2B5EF4-FFF2-40B4-BE49-F238E27FC236}">
+                <a16:creationId xmlns:a16="http://schemas.microsoft.com/office/drawing/2014/main" id="{A8B8087A-F01D-7BF2-7B9B-803D42A31868}"/>
+              </a:ext>
+            </a:extLst>
+          </p:cNvPr>
+          <p:cNvSpPr/>
+          <p:nvPr/>
+        </p:nvSpPr>
+        <p:spPr>
+          <a:xfrm>
+            <a:off x="0" y="0"/>
+            <a:ext cx="12192000" cy="6858000"/>
+          </a:xfrm>
+          <a:prstGeom prst="rect">
+            <a:avLst/>
+          </a:prstGeom>
+          <a:solidFill>
+            <a:schemeClr val="tx1">
+              <a:alpha val="70000"/>
+            </a:schemeClr>
+          </a:solidFill>
+          <a:ln>
+            <a:noFill/>
+          </a:ln>
+        </p:spPr>
+        <p:style>
+          <a:lnRef idx="2">
+            <a:schemeClr val="accent1">
+              <a:shade val="50000"/>
+            </a:schemeClr>
+          </a:lnRef>
+          <a:fillRef idx="1">
+            <a:schemeClr val="accent1"/>
+          </a:fillRef>
+          <a:effectRef idx="0">
+            <a:schemeClr val="accent1"/>
+          </a:effectRef>
+          <a:fontRef idx="minor">
+            <a:schemeClr val="lt1"/>
+          </a:fontRef>
+        </p:style>
+        <p:txBody>
+          <a:bodyPr rtlCol="0" anchor="ctr"/>
+          <a:lstStyle/>
+          <a:p>
+            <a:pPr algn="ctr"/>
+            <a:endParaRPr lang="es-CO">
+              <a:ln>
+                <a:solidFill>
+                  <a:schemeClr val="accent1"/>
+                </a:solidFill>
+              </a:ln>
+            </a:endParaRPr>
+          </a:p>
+        </p:txBody>
+      </p:sp>
+      <p:sp>
+        <p:nvSpPr>
+          <p:cNvPr id="2" name="CuadroTexto 1">
+            <a:extLst>
+              <a:ext uri="{FF2B5EF4-FFF2-40B4-BE49-F238E27FC236}">
+                <a16:creationId xmlns:a16="http://schemas.microsoft.com/office/drawing/2014/main" id="{4BE15536-8584-618A-A38B-56A2C9028692}"/>
+              </a:ext>
+            </a:extLst>
+          </p:cNvPr>
+          <p:cNvSpPr txBox="1"/>
+          <p:nvPr/>
+        </p:nvSpPr>
+        <p:spPr>
+          <a:xfrm>
+            <a:off x="318426" y="445008"/>
             <a:ext cx="11268635" cy="6494085"/>
           </a:xfrm>
           <a:prstGeom prst="rect">
@@ -3940,7 +4895,7 @@
 </p:sld>
 </file>
 
-<file path=ppt/slides/slide11.xml><?xml version="1.0" encoding="utf-8"?>
+<file path=ppt/slides/slide14.xml><?xml version="1.0" encoding="utf-8"?>
 <p:sld xmlns:a="http://schemas.openxmlformats.org/drawingml/2006/main" xmlns:r="http://schemas.openxmlformats.org/officeDocument/2006/relationships" xmlns:p="http://schemas.openxmlformats.org/presentationml/2006/main">
   <p:cSld>
     <p:spTree>
@@ -4256,8 +5211,8 @@
         </p:nvSpPr>
         <p:spPr>
           <a:xfrm>
-            <a:off x="0" y="0"/>
-            <a:ext cx="12192000" cy="6858000"/>
+            <a:off x="0" y="-193580"/>
+            <a:ext cx="12192000" cy="7051579"/>
           </a:xfrm>
           <a:prstGeom prst="rect">
             <a:avLst/>
@@ -4317,7 +5272,7 @@
         <p:spPr>
           <a:xfrm>
             <a:off x="318426" y="445008"/>
-            <a:ext cx="11268635" cy="6494085"/>
+            <a:ext cx="11268635" cy="5940088"/>
           </a:xfrm>
           <a:prstGeom prst="rect">
             <a:avLst/>
@@ -4336,7 +5291,7 @@
                   <a:schemeClr val="bg1"/>
                 </a:solidFill>
               </a:rPr>
-              <a:t>Ahora IURIS permite </a:t>
+              <a:t>Si el caso esta </a:t>
             </a:r>
             <a:r>
               <a:rPr lang="es-MX" sz="3600" b="1" dirty="0">
@@ -4347,7 +5302,7 @@
                   </a:schemeClr>
                 </a:solidFill>
               </a:rPr>
-              <a:t>Evaluar </a:t>
+              <a:t>Cerrado - sistema</a:t>
             </a:r>
             <a:r>
               <a:rPr lang="es-MX" sz="3600" dirty="0">
@@ -4355,46 +5310,10 @@
                   <a:schemeClr val="bg1"/>
                 </a:solidFill>
               </a:rPr>
-              <a:t>y </a:t>
-            </a:r>
-            <a:r>
-              <a:rPr lang="es-MX" sz="3600" b="1" dirty="0">
-                <a:solidFill>
-                  <a:schemeClr val="accent4">
-                    <a:lumMod val="60000"/>
-                    <a:lumOff val="40000"/>
-                  </a:schemeClr>
-                </a:solidFill>
-              </a:rPr>
-              <a:t>Cerrar</a:t>
-            </a:r>
-            <a:r>
-              <a:rPr lang="es-MX" sz="3600" dirty="0">
-                <a:solidFill>
-                  <a:schemeClr val="bg1"/>
-                </a:solidFill>
-              </a:rPr>
-              <a:t> los casos de asesoría que estén en estado </a:t>
-            </a:r>
-            <a:r>
-              <a:rPr lang="es-MX" sz="3600" b="1" dirty="0">
-                <a:solidFill>
-                  <a:schemeClr val="accent4">
-                    <a:lumMod val="60000"/>
-                    <a:lumOff val="40000"/>
-                  </a:schemeClr>
-                </a:solidFill>
-              </a:rPr>
-              <a:t>Cerrado (sistema) </a:t>
-            </a:r>
-            <a:r>
-              <a:rPr lang="es-MX" sz="3600" b="1" dirty="0">
-                <a:solidFill>
-                  <a:schemeClr val="bg1"/>
-                </a:solidFill>
-              </a:rPr>
-              <a:t>durante el periodo activo.</a:t>
-            </a:r>
+              <a:t> y se evalúa en un corte diferente en el que fue asignado podrá asignar una nota de 0 a 5. La nota se asignará al corte activo.</a:t>
+            </a:r>
+          </a:p>
+          <a:p>
             <a:endParaRPr lang="es-MX" sz="3600" dirty="0">
               <a:solidFill>
                 <a:schemeClr val="bg1"/>
@@ -4402,7 +5321,6 @@
             </a:endParaRPr>
           </a:p>
           <a:p>
-            <a:pPr algn="just"/>
             <a:endParaRPr lang="es-MX" sz="3600" dirty="0">
               <a:solidFill>
                 <a:schemeClr val="bg1"/>
@@ -4410,29 +5328,39 @@
             </a:endParaRPr>
           </a:p>
           <a:p>
-            <a:r>
-              <a:rPr lang="es-MX" sz="3600" dirty="0">
-                <a:solidFill>
-                  <a:schemeClr val="bg1"/>
-                </a:solidFill>
-              </a:rPr>
-              <a:t>Anteriormente esta funcionalidad estaba disponible solo durante el corte activo.</a:t>
-            </a:r>
-          </a:p>
-          <a:p>
-            <a:endParaRPr lang="es-MX" sz="3600" dirty="0"/>
-          </a:p>
-          <a:p>
-            <a:endParaRPr lang="es-MX" sz="3600" dirty="0"/>
-          </a:p>
-          <a:p>
-            <a:endParaRPr lang="es-MX" sz="3600" dirty="0"/>
-          </a:p>
-          <a:p>
-            <a:endParaRPr lang="es-MX" sz="3600" dirty="0"/>
-          </a:p>
-          <a:p>
-            <a:endParaRPr lang="es-MX" sz="3600" dirty="0"/>
+            <a:endParaRPr lang="es-MX" sz="3600" dirty="0">
+              <a:solidFill>
+                <a:schemeClr val="bg1"/>
+              </a:solidFill>
+            </a:endParaRPr>
+          </a:p>
+          <a:p>
+            <a:endParaRPr lang="es-MX" sz="3600" dirty="0">
+              <a:solidFill>
+                <a:schemeClr val="bg1"/>
+              </a:solidFill>
+            </a:endParaRPr>
+          </a:p>
+          <a:p>
+            <a:endParaRPr lang="es-MX" sz="3600" dirty="0">
+              <a:solidFill>
+                <a:schemeClr val="bg1"/>
+              </a:solidFill>
+            </a:endParaRPr>
+          </a:p>
+          <a:p>
+            <a:endParaRPr lang="es-MX" sz="3600" dirty="0">
+              <a:solidFill>
+                <a:schemeClr val="bg1"/>
+              </a:solidFill>
+            </a:endParaRPr>
+          </a:p>
+          <a:p>
+            <a:endParaRPr lang="es-MX" sz="3600" dirty="0">
+              <a:solidFill>
+                <a:schemeClr val="bg1"/>
+              </a:solidFill>
+            </a:endParaRPr>
           </a:p>
           <a:p>
             <a:r>
@@ -4457,7 +5385,7 @@
     </p:spTree>
     <p:extLst>
       <p:ext uri="{BB962C8B-B14F-4D97-AF65-F5344CB8AC3E}">
-        <p14:creationId xmlns:p14="http://schemas.microsoft.com/office/powerpoint/2010/main" val="482223614"/>
+        <p14:creationId xmlns:p14="http://schemas.microsoft.com/office/powerpoint/2010/main" val="1049771496"/>
       </p:ext>
     </p:extLst>
   </p:cSld>
@@ -4542,7 +5470,7 @@
           </a:prstGeom>
           <a:solidFill>
             <a:schemeClr val="tx1">
-              <a:alpha val="70000"/>
+              <a:alpha val="60000"/>
             </a:schemeClr>
           </a:solidFill>
           <a:ln>
@@ -4595,7 +5523,7 @@
         <p:spPr>
           <a:xfrm>
             <a:off x="318426" y="445008"/>
-            <a:ext cx="11268635" cy="7602081"/>
+            <a:ext cx="11268635" cy="6494085"/>
           </a:xfrm>
           <a:prstGeom prst="rect">
             <a:avLst/>
@@ -4608,7 +5536,71 @@
           </a:bodyPr>
           <a:lstStyle/>
           <a:p>
-            <a:pPr algn="ctr"/>
+            <a:r>
+              <a:rPr lang="es-MX" sz="3600" dirty="0">
+                <a:solidFill>
+                  <a:schemeClr val="bg1"/>
+                </a:solidFill>
+              </a:rPr>
+              <a:t>Ahora IURIS permite a los docentes </a:t>
+            </a:r>
+            <a:r>
+              <a:rPr lang="es-MX" sz="3600" b="1" dirty="0">
+                <a:solidFill>
+                  <a:schemeClr val="accent4">
+                    <a:lumMod val="60000"/>
+                    <a:lumOff val="40000"/>
+                  </a:schemeClr>
+                </a:solidFill>
+              </a:rPr>
+              <a:t>Evaluar </a:t>
+            </a:r>
+            <a:r>
+              <a:rPr lang="es-MX" sz="3600" dirty="0">
+                <a:solidFill>
+                  <a:schemeClr val="bg1"/>
+                </a:solidFill>
+              </a:rPr>
+              <a:t>y </a:t>
+            </a:r>
+            <a:r>
+              <a:rPr lang="es-MX" sz="3600" b="1" dirty="0">
+                <a:solidFill>
+                  <a:schemeClr val="accent4">
+                    <a:lumMod val="60000"/>
+                    <a:lumOff val="40000"/>
+                  </a:schemeClr>
+                </a:solidFill>
+              </a:rPr>
+              <a:t>Cerrar</a:t>
+            </a:r>
+            <a:r>
+              <a:rPr lang="es-MX" sz="3600" dirty="0">
+                <a:solidFill>
+                  <a:schemeClr val="bg1"/>
+                </a:solidFill>
+              </a:rPr>
+              <a:t> los casos de asesoría que hayan sido asignados durante el periodo activo y que estén en estado </a:t>
+            </a:r>
+            <a:r>
+              <a:rPr lang="es-MX" sz="3600" b="1" dirty="0">
+                <a:solidFill>
+                  <a:schemeClr val="accent4">
+                    <a:lumMod val="60000"/>
+                    <a:lumOff val="40000"/>
+                  </a:schemeClr>
+                </a:solidFill>
+              </a:rPr>
+              <a:t>Cerrado (sistema)</a:t>
+            </a:r>
+            <a:r>
+              <a:rPr lang="es-MX" sz="3600" b="1" dirty="0">
+                <a:solidFill>
+                  <a:schemeClr val="bg1"/>
+                </a:solidFill>
+              </a:rPr>
+              <a:t>.</a:t>
+            </a:r>
             <a:endParaRPr lang="es-MX" sz="3600" dirty="0">
               <a:solidFill>
                 <a:schemeClr val="bg1"/>
@@ -4616,61 +5608,7 @@
             </a:endParaRPr>
           </a:p>
           <a:p>
-            <a:pPr algn="ctr"/>
-            <a:r>
-              <a:rPr lang="es-MX" sz="3600" dirty="0">
-                <a:solidFill>
-                  <a:schemeClr val="bg1"/>
-                </a:solidFill>
-              </a:rPr>
-              <a:t>Para </a:t>
-            </a:r>
-            <a:r>
-              <a:rPr lang="es-MX" sz="3600" b="1" dirty="0">
-                <a:solidFill>
-                  <a:schemeClr val="accent4">
-                    <a:lumMod val="60000"/>
-                    <a:lumOff val="40000"/>
-                  </a:schemeClr>
-                </a:solidFill>
-              </a:rPr>
-              <a:t>Evaluar y cerrar caso </a:t>
-            </a:r>
-            <a:r>
-              <a:rPr lang="es-MX" sz="3600" dirty="0">
-                <a:solidFill>
-                  <a:schemeClr val="bg1"/>
-                </a:solidFill>
-              </a:rPr>
-              <a:t>en administración del caso, pestaña </a:t>
-            </a:r>
-            <a:r>
-              <a:rPr lang="es-MX" sz="3600" b="1" i="1" dirty="0">
-                <a:solidFill>
-                  <a:schemeClr val="bg1"/>
-                </a:solidFill>
-              </a:rPr>
-              <a:t>Cierre de caso </a:t>
-            </a:r>
-            <a:r>
-              <a:rPr lang="es-MX" sz="3600" dirty="0">
-                <a:solidFill>
-                  <a:schemeClr val="bg1"/>
-                </a:solidFill>
-              </a:rPr>
-              <a:t>de clic en el botón </a:t>
-            </a:r>
-            <a:r>
-              <a:rPr lang="es-MX" sz="3600" b="1" i="1" dirty="0">
-                <a:solidFill>
-                  <a:schemeClr val="bg1"/>
-                </a:solidFill>
-              </a:rPr>
-              <a:t>Volver a evaluar y cerrar caso</a:t>
-            </a:r>
-          </a:p>
-          <a:p>
-            <a:pPr algn="ctr"/>
+            <a:pPr algn="just"/>
             <a:endParaRPr lang="es-MX" sz="3600" dirty="0">
               <a:solidFill>
                 <a:schemeClr val="bg1"/>
@@ -4678,68 +5616,29 @@
             </a:endParaRPr>
           </a:p>
           <a:p>
-            <a:pPr algn="ctr"/>
-            <a:endParaRPr lang="es-MX" sz="3600" dirty="0">
-              <a:solidFill>
-                <a:schemeClr val="bg1"/>
-              </a:solidFill>
-            </a:endParaRPr>
-          </a:p>
-          <a:p>
-            <a:pPr algn="ctr"/>
-            <a:endParaRPr lang="es-MX" sz="3600" dirty="0">
-              <a:solidFill>
-                <a:schemeClr val="bg1"/>
-              </a:solidFill>
-            </a:endParaRPr>
-          </a:p>
-          <a:p>
-            <a:pPr algn="ctr"/>
-            <a:endParaRPr lang="es-MX" sz="3600" dirty="0">
-              <a:solidFill>
-                <a:schemeClr val="bg1"/>
-              </a:solidFill>
-            </a:endParaRPr>
-          </a:p>
-          <a:p>
-            <a:pPr algn="ctr"/>
-            <a:endParaRPr lang="es-MX" sz="3600" dirty="0">
-              <a:solidFill>
-                <a:schemeClr val="bg1"/>
-              </a:solidFill>
-            </a:endParaRPr>
-          </a:p>
-          <a:p>
-            <a:pPr algn="ctr"/>
-            <a:endParaRPr lang="es-MX" sz="3600" dirty="0">
-              <a:solidFill>
-                <a:schemeClr val="bg1"/>
-              </a:solidFill>
-            </a:endParaRPr>
-          </a:p>
-          <a:p>
-            <a:pPr algn="ctr"/>
-            <a:endParaRPr lang="es-MX" sz="3600" dirty="0">
-              <a:solidFill>
-                <a:schemeClr val="bg1"/>
-              </a:solidFill>
-            </a:endParaRPr>
-          </a:p>
-          <a:p>
-            <a:pPr algn="ctr"/>
-            <a:endParaRPr lang="es-MX" sz="3600" dirty="0">
-              <a:solidFill>
-                <a:schemeClr val="bg1"/>
-              </a:solidFill>
-            </a:endParaRPr>
-          </a:p>
-          <a:p>
-            <a:pPr algn="ctr"/>
-            <a:endParaRPr lang="es-MX" sz="3600" dirty="0">
-              <a:solidFill>
-                <a:schemeClr val="bg1"/>
-              </a:solidFill>
-            </a:endParaRPr>
+            <a:r>
+              <a:rPr lang="es-MX" sz="3600" dirty="0">
+                <a:solidFill>
+                  <a:schemeClr val="bg1"/>
+                </a:solidFill>
+              </a:rPr>
+              <a:t>Anteriormente esta funcionalidad estaba disponible solo durante el corte activo.</a:t>
+            </a:r>
+          </a:p>
+          <a:p>
+            <a:endParaRPr lang="es-MX" sz="3600" dirty="0"/>
+          </a:p>
+          <a:p>
+            <a:endParaRPr lang="es-MX" sz="3600" dirty="0"/>
+          </a:p>
+          <a:p>
+            <a:endParaRPr lang="es-MX" sz="3600" dirty="0"/>
+          </a:p>
+          <a:p>
+            <a:endParaRPr lang="es-MX" sz="3600" dirty="0"/>
+          </a:p>
+          <a:p>
+            <a:endParaRPr lang="es-MX" sz="3600" dirty="0"/>
           </a:p>
           <a:p>
             <a:r>
@@ -4761,156 +5660,10 @@
           </a:p>
         </p:txBody>
       </p:sp>
-      <p:pic>
-        <p:nvPicPr>
-          <p:cNvPr id="5" name="Imagen 4">
-            <a:extLst>
-              <a:ext uri="{FF2B5EF4-FFF2-40B4-BE49-F238E27FC236}">
-                <a16:creationId xmlns:a16="http://schemas.microsoft.com/office/drawing/2014/main" id="{0AFBDE35-35CA-75AC-DD52-27FE1D7052A7}"/>
-              </a:ext>
-            </a:extLst>
-          </p:cNvPr>
-          <p:cNvPicPr>
-            <a:picLocks noChangeAspect="1"/>
-          </p:cNvPicPr>
-          <p:nvPr/>
-        </p:nvPicPr>
-        <p:blipFill>
-          <a:blip r:embed="rId3"/>
-          <a:stretch>
-            <a:fillRect/>
-          </a:stretch>
-        </p:blipFill>
-        <p:spPr>
-          <a:xfrm>
-            <a:off x="220471" y="2926036"/>
-            <a:ext cx="11751058" cy="1320012"/>
-          </a:xfrm>
-          <a:prstGeom prst="rect">
-            <a:avLst/>
-          </a:prstGeom>
-        </p:spPr>
-      </p:pic>
-      <p:sp>
-        <p:nvSpPr>
-          <p:cNvPr id="9" name="Rectángulo 8">
-            <a:extLst>
-              <a:ext uri="{FF2B5EF4-FFF2-40B4-BE49-F238E27FC236}">
-                <a16:creationId xmlns:a16="http://schemas.microsoft.com/office/drawing/2014/main" id="{19CE3575-09A8-0984-60D0-CDEE01EEEB27}"/>
-              </a:ext>
-            </a:extLst>
-          </p:cNvPr>
-          <p:cNvSpPr/>
-          <p:nvPr/>
-        </p:nvSpPr>
-        <p:spPr>
-          <a:xfrm>
-            <a:off x="8023412" y="3756212"/>
-            <a:ext cx="3882075" cy="489836"/>
-          </a:xfrm>
-          <a:prstGeom prst="rect">
-            <a:avLst/>
-          </a:prstGeom>
-          <a:ln>
-            <a:noFill/>
-          </a:ln>
-        </p:spPr>
-        <p:style>
-          <a:lnRef idx="2">
-            <a:schemeClr val="accent6"/>
-          </a:lnRef>
-          <a:fillRef idx="1">
-            <a:schemeClr val="lt1"/>
-          </a:fillRef>
-          <a:effectRef idx="0">
-            <a:schemeClr val="accent6"/>
-          </a:effectRef>
-          <a:fontRef idx="minor">
-            <a:schemeClr val="dk1"/>
-          </a:fontRef>
-        </p:style>
-        <p:txBody>
-          <a:bodyPr rtlCol="0" anchor="ctr"/>
-          <a:lstStyle/>
-          <a:p>
-            <a:pPr algn="ctr"/>
-            <a:endParaRPr lang="es-CO" dirty="0"/>
-          </a:p>
-        </p:txBody>
-      </p:sp>
-      <p:pic>
-        <p:nvPicPr>
-          <p:cNvPr id="10" name="Imagen 9">
-            <a:extLst>
-              <a:ext uri="{FF2B5EF4-FFF2-40B4-BE49-F238E27FC236}">
-                <a16:creationId xmlns:a16="http://schemas.microsoft.com/office/drawing/2014/main" id="{53A2EAAA-5EE2-C05E-D295-9FF8055A8272}"/>
-              </a:ext>
-            </a:extLst>
-          </p:cNvPr>
-          <p:cNvPicPr>
-            <a:picLocks noChangeAspect="1"/>
-          </p:cNvPicPr>
-          <p:nvPr/>
-        </p:nvPicPr>
-        <p:blipFill>
-          <a:blip r:embed="rId4"/>
-          <a:stretch>
-            <a:fillRect/>
-          </a:stretch>
-        </p:blipFill>
-        <p:spPr>
-          <a:xfrm>
-            <a:off x="9054249" y="3657600"/>
-            <a:ext cx="2453953" cy="510988"/>
-          </a:xfrm>
-          <a:prstGeom prst="rect">
-            <a:avLst/>
-          </a:prstGeom>
-        </p:spPr>
-      </p:pic>
-      <p:pic>
-        <p:nvPicPr>
-          <p:cNvPr id="8" name="Gráfico 7" descr="Lupa">
-            <a:extLst>
-              <a:ext uri="{FF2B5EF4-FFF2-40B4-BE49-F238E27FC236}">
-                <a16:creationId xmlns:a16="http://schemas.microsoft.com/office/drawing/2014/main" id="{70287BDA-E56B-9DF6-26A8-A0F53C4766DE}"/>
-              </a:ext>
-            </a:extLst>
-          </p:cNvPr>
-          <p:cNvPicPr>
-            <a:picLocks noChangeAspect="1"/>
-          </p:cNvPicPr>
-          <p:nvPr/>
-        </p:nvPicPr>
-        <p:blipFill>
-          <a:blip r:embed="rId5">
-            <a:extLst>
-              <a:ext uri="{28A0092B-C50C-407E-A947-70E740481C1C}">
-                <a14:useLocalDpi xmlns:a14="http://schemas.microsoft.com/office/drawing/2010/main" val="0"/>
-              </a:ext>
-              <a:ext uri="{96DAC541-7B7A-43D3-8B79-37D633B846F1}">
-                <asvg:svgBlip xmlns:asvg="http://schemas.microsoft.com/office/drawing/2016/SVG/main" r:embed="rId6"/>
-              </a:ext>
-            </a:extLst>
-          </a:blip>
-          <a:stretch>
-            <a:fillRect/>
-          </a:stretch>
-        </p:blipFill>
-        <p:spPr>
-          <a:xfrm rot="5689775">
-            <a:off x="7618904" y="2159922"/>
-            <a:ext cx="4373944" cy="4584270"/>
-          </a:xfrm>
-          <a:prstGeom prst="rect">
-            <a:avLst/>
-          </a:prstGeom>
-        </p:spPr>
-      </p:pic>
     </p:spTree>
     <p:extLst>
       <p:ext uri="{BB962C8B-B14F-4D97-AF65-F5344CB8AC3E}">
-        <p14:creationId xmlns:p14="http://schemas.microsoft.com/office/powerpoint/2010/main" val="2129238174"/>
+        <p14:creationId xmlns:p14="http://schemas.microsoft.com/office/powerpoint/2010/main" val="114040660"/>
       </p:ext>
     </p:extLst>
   </p:cSld>
@@ -4937,108 +5690,12 @@
           <a:chExt cx="0" cy="0"/>
         </a:xfrm>
       </p:grpSpPr>
-      <p:pic>
-        <p:nvPicPr>
-          <p:cNvPr id="3" name="logo">
-            <a:extLst>
-              <a:ext uri="{FF2B5EF4-FFF2-40B4-BE49-F238E27FC236}">
-                <a16:creationId xmlns:a16="http://schemas.microsoft.com/office/drawing/2014/main" id="{CB7069CB-A915-E9BA-0362-5B269561515F}"/>
-              </a:ext>
-            </a:extLst>
-          </p:cNvPr>
-          <p:cNvPicPr>
-            <a:picLocks noChangeAspect="1"/>
-          </p:cNvPicPr>
-          <p:nvPr/>
-        </p:nvPicPr>
-        <p:blipFill>
-          <a:blip r:embed="rId2">
-            <a:extLst>
-              <a:ext uri="{28A0092B-C50C-407E-A947-70E740481C1C}">
-                <a14:useLocalDpi xmlns:a14="http://schemas.microsoft.com/office/drawing/2010/main" val="0"/>
-              </a:ext>
-            </a:extLst>
-          </a:blip>
-          <a:stretch>
-            <a:fillRect/>
-          </a:stretch>
-        </p:blipFill>
-        <p:spPr>
-          <a:xfrm>
-            <a:off x="8765519" y="3350269"/>
-            <a:ext cx="3426481" cy="3473976"/>
-          </a:xfrm>
-          <a:prstGeom prst="rect">
-            <a:avLst/>
-          </a:prstGeom>
-        </p:spPr>
-      </p:pic>
-      <p:sp>
-        <p:nvSpPr>
-          <p:cNvPr id="17" name="Rectángulo 16">
-            <a:extLst>
-              <a:ext uri="{FF2B5EF4-FFF2-40B4-BE49-F238E27FC236}">
-                <a16:creationId xmlns:a16="http://schemas.microsoft.com/office/drawing/2014/main" id="{A8B8087A-F01D-7BF2-7B9B-803D42A31868}"/>
-              </a:ext>
-            </a:extLst>
-          </p:cNvPr>
-          <p:cNvSpPr/>
-          <p:nvPr/>
-        </p:nvSpPr>
-        <p:spPr>
-          <a:xfrm>
-            <a:off x="0" y="0"/>
-            <a:ext cx="12192000" cy="6858000"/>
-          </a:xfrm>
-          <a:prstGeom prst="rect">
-            <a:avLst/>
-          </a:prstGeom>
-          <a:solidFill>
-            <a:schemeClr val="tx1">
-              <a:alpha val="70000"/>
-            </a:schemeClr>
-          </a:solidFill>
-          <a:ln>
-            <a:noFill/>
-          </a:ln>
-        </p:spPr>
-        <p:style>
-          <a:lnRef idx="2">
-            <a:schemeClr val="accent1">
-              <a:shade val="50000"/>
-            </a:schemeClr>
-          </a:lnRef>
-          <a:fillRef idx="1">
-            <a:schemeClr val="accent1"/>
-          </a:fillRef>
-          <a:effectRef idx="0">
-            <a:schemeClr val="accent1"/>
-          </a:effectRef>
-          <a:fontRef idx="minor">
-            <a:schemeClr val="lt1"/>
-          </a:fontRef>
-        </p:style>
-        <p:txBody>
-          <a:bodyPr rtlCol="0" anchor="ctr"/>
-          <a:lstStyle/>
-          <a:p>
-            <a:pPr algn="ctr"/>
-            <a:endParaRPr lang="es-CO">
-              <a:ln>
-                <a:solidFill>
-                  <a:schemeClr val="accent1"/>
-                </a:solidFill>
-              </a:ln>
-            </a:endParaRPr>
-          </a:p>
-        </p:txBody>
-      </p:sp>
-      <p:sp>
-        <p:nvSpPr>
-          <p:cNvPr id="10" name="CuadroTexto 9">
-            <a:extLst>
-              <a:ext uri="{FF2B5EF4-FFF2-40B4-BE49-F238E27FC236}">
-                <a16:creationId xmlns:a16="http://schemas.microsoft.com/office/drawing/2014/main" id="{C69317F1-3BC8-CC98-94BA-756E40E92416}"/>
+      <p:sp>
+        <p:nvSpPr>
+          <p:cNvPr id="2" name="CuadroTexto 1">
+            <a:extLst>
+              <a:ext uri="{FF2B5EF4-FFF2-40B4-BE49-F238E27FC236}">
+                <a16:creationId xmlns:a16="http://schemas.microsoft.com/office/drawing/2014/main" id="{4BE15536-8584-618A-A38B-56A2C9028692}"/>
               </a:ext>
             </a:extLst>
           </p:cNvPr>
@@ -5047,8 +5704,8 @@
         </p:nvSpPr>
         <p:spPr>
           <a:xfrm>
-            <a:off x="1280159" y="5503453"/>
-            <a:ext cx="9924288" cy="1200329"/>
+            <a:off x="638175" y="900469"/>
+            <a:ext cx="11168342" cy="5262979"/>
           </a:xfrm>
           <a:prstGeom prst="rect">
             <a:avLst/>
@@ -5056,76 +5713,142 @@
           <a:noFill/>
         </p:spPr>
         <p:txBody>
-          <a:bodyPr wrap="square">
+          <a:bodyPr wrap="square" rtlCol="0">
             <a:spAutoFit/>
           </a:bodyPr>
           <a:lstStyle/>
           <a:p>
-            <a:pPr algn="ctr"/>
-            <a:r>
-              <a:rPr lang="es-MX" sz="3600" dirty="0">
-                <a:solidFill>
-                  <a:schemeClr val="bg1"/>
+            <a:pPr algn="just"/>
+            <a:r>
+              <a:rPr lang="es-MX" sz="2800" dirty="0"/>
+              <a:t>Teniendo en cuenta la necesidad de brindar alternativas que permitan la gestión de casos de asesoría vencidos que se evalúan por el sistema (</a:t>
+            </a:r>
+            <a:r>
+              <a:rPr lang="es-MX" sz="2800" b="1" dirty="0">
+                <a:solidFill>
+                  <a:srgbClr val="D68843"/>
                 </a:solidFill>
               </a:rPr>
-              <a:t>Rellene los campo con las notas correspondientes y el debido concepto y presione </a:t>
-            </a:r>
-            <a:r>
-              <a:rPr lang="es-MX" sz="3600" b="1" dirty="0">
-                <a:solidFill>
-                  <a:schemeClr val="accent4">
-                    <a:lumMod val="60000"/>
-                    <a:lumOff val="40000"/>
-                  </a:schemeClr>
+              <a:t>Cerrado - sistema</a:t>
+            </a:r>
+            <a:r>
+              <a:rPr lang="es-MX" sz="2800" dirty="0"/>
+              <a:t>) ahora IURIS permite a los docentes, director general y director administrativo volver a </a:t>
+            </a:r>
+            <a:r>
+              <a:rPr lang="es-MX" sz="2800" b="1" dirty="0">
+                <a:solidFill>
+                  <a:srgbClr val="D68843"/>
                 </a:solidFill>
               </a:rPr>
-              <a:t>Enviar</a:t>
-            </a:r>
-            <a:endParaRPr lang="es-MX" sz="3600" b="1" i="1" dirty="0">
-              <a:solidFill>
-                <a:schemeClr val="accent4">
-                  <a:lumMod val="60000"/>
-                  <a:lumOff val="40000"/>
-                </a:schemeClr>
-              </a:solidFill>
-            </a:endParaRPr>
-          </a:p>
-        </p:txBody>
-      </p:sp>
-      <p:pic>
-        <p:nvPicPr>
-          <p:cNvPr id="9" name="Imagen 8">
-            <a:extLst>
-              <a:ext uri="{FF2B5EF4-FFF2-40B4-BE49-F238E27FC236}">
-                <a16:creationId xmlns:a16="http://schemas.microsoft.com/office/drawing/2014/main" id="{148AB8EB-5199-7878-EFD1-0403F7A0D122}"/>
-              </a:ext>
-            </a:extLst>
-          </p:cNvPr>
-          <p:cNvPicPr>
-            <a:picLocks noChangeAspect="1"/>
-          </p:cNvPicPr>
-          <p:nvPr/>
-        </p:nvPicPr>
-        <p:blipFill>
-          <a:blip r:embed="rId3"/>
-          <a:stretch>
-            <a:fillRect/>
-          </a:stretch>
-        </p:blipFill>
-        <p:spPr>
-          <a:xfrm>
-            <a:off x="2954613" y="855968"/>
-            <a:ext cx="5810906" cy="4613730"/>
-          </a:xfrm>
-          <a:prstGeom prst="rect">
-            <a:avLst/>
-          </a:prstGeom>
-        </p:spPr>
-      </p:pic>
+              <a:t>Evaluar </a:t>
+            </a:r>
+            <a:r>
+              <a:rPr lang="es-MX" sz="2800" dirty="0">
+                <a:solidFill>
+                  <a:srgbClr val="D68843"/>
+                </a:solidFill>
+              </a:rPr>
+              <a:t>y </a:t>
+            </a:r>
+            <a:r>
+              <a:rPr lang="es-MX" sz="2800" b="1" dirty="0">
+                <a:solidFill>
+                  <a:srgbClr val="D68843"/>
+                </a:solidFill>
+              </a:rPr>
+              <a:t>Cerrar</a:t>
+            </a:r>
+            <a:r>
+              <a:rPr lang="es-MX" sz="2800" dirty="0">
+                <a:solidFill>
+                  <a:srgbClr val="D68843"/>
+                </a:solidFill>
+              </a:rPr>
+              <a:t> </a:t>
+            </a:r>
+            <a:r>
+              <a:rPr lang="es-MX" sz="2800" dirty="0"/>
+              <a:t>estos casos teniendo en cuenta los siguientes parámetros</a:t>
+            </a:r>
+            <a:r>
+              <a:rPr lang="es-MX" sz="2800" b="1" dirty="0"/>
+              <a:t>.</a:t>
+            </a:r>
+          </a:p>
+          <a:p>
+            <a:pPr marL="514350" indent="-514350" algn="just">
+              <a:buFont typeface="+mj-lt"/>
+              <a:buAutoNum type="arabicPeriod"/>
+            </a:pPr>
+            <a:r>
+              <a:rPr lang="es-MX" sz="2800" dirty="0"/>
+              <a:t>Si el caso está </a:t>
+            </a:r>
+            <a:r>
+              <a:rPr lang="es-MX" sz="2800" b="1" dirty="0">
+                <a:solidFill>
+                  <a:srgbClr val="D68843"/>
+                </a:solidFill>
+              </a:rPr>
+              <a:t>Cerrado - sistema </a:t>
+            </a:r>
+            <a:r>
+              <a:rPr lang="es-MX" sz="2800" dirty="0"/>
+              <a:t>y </a:t>
+            </a:r>
+            <a:r>
+              <a:rPr lang="es-MX" sz="2800" b="1" dirty="0">
+                <a:solidFill>
+                  <a:srgbClr val="D68843"/>
+                </a:solidFill>
+              </a:rPr>
+              <a:t>NO</a:t>
+            </a:r>
+            <a:r>
+              <a:rPr lang="es-MX" sz="2800" dirty="0"/>
+              <a:t> fue enviado a solicitud de cierre podrá asignar una nota de 0 a 3. </a:t>
+            </a:r>
+          </a:p>
+          <a:p>
+            <a:pPr marL="514350" indent="-514350" algn="just">
+              <a:buFont typeface="+mj-lt"/>
+              <a:buAutoNum type="arabicPeriod"/>
+            </a:pPr>
+            <a:r>
+              <a:rPr lang="es-MX" sz="2800" dirty="0"/>
+              <a:t>Si el caso está </a:t>
+            </a:r>
+            <a:r>
+              <a:rPr lang="es-MX" sz="2800" b="1" dirty="0">
+                <a:solidFill>
+                  <a:srgbClr val="D68843"/>
+                </a:solidFill>
+              </a:rPr>
+              <a:t>Cerrado - sistema </a:t>
+            </a:r>
+            <a:r>
+              <a:rPr lang="es-MX" sz="2800" dirty="0"/>
+              <a:t>y fue enviado a solicitud de cierre podrá asignar una nota de 0 a 5. </a:t>
+            </a:r>
+          </a:p>
+          <a:p>
+            <a:pPr algn="just"/>
+            <a:endParaRPr lang="es-MX" sz="2800" dirty="0"/>
+          </a:p>
+          <a:p>
+            <a:pPr algn="just"/>
+            <a:r>
+              <a:rPr lang="es-MX" sz="2800" dirty="0"/>
+              <a:t>Tenga en cuenta que la nueva nota se asignará al corte en el cual se venció el caso.</a:t>
+            </a:r>
+          </a:p>
+        </p:txBody>
+      </p:sp>
     </p:spTree>
     <p:extLst>
       <p:ext uri="{BB962C8B-B14F-4D97-AF65-F5344CB8AC3E}">
-        <p14:creationId xmlns:p14="http://schemas.microsoft.com/office/powerpoint/2010/main" val="1720992572"/>
+        <p14:creationId xmlns:p14="http://schemas.microsoft.com/office/powerpoint/2010/main" val="482223614"/>
       </p:ext>
     </p:extLst>
   </p:cSld>
@@ -5152,12 +5875,69 @@
           <a:chExt cx="0" cy="0"/>
         </a:xfrm>
       </p:grpSpPr>
+      <p:sp>
+        <p:nvSpPr>
+          <p:cNvPr id="2" name="CuadroTexto 1">
+            <a:extLst>
+              <a:ext uri="{FF2B5EF4-FFF2-40B4-BE49-F238E27FC236}">
+                <a16:creationId xmlns:a16="http://schemas.microsoft.com/office/drawing/2014/main" id="{4BE15536-8584-618A-A38B-56A2C9028692}"/>
+              </a:ext>
+            </a:extLst>
+          </p:cNvPr>
+          <p:cNvSpPr txBox="1"/>
+          <p:nvPr/>
+        </p:nvSpPr>
+        <p:spPr>
+          <a:xfrm>
+            <a:off x="461682" y="300852"/>
+            <a:ext cx="11268635" cy="1754326"/>
+          </a:xfrm>
+          <a:prstGeom prst="rect">
+            <a:avLst/>
+          </a:prstGeom>
+          <a:noFill/>
+        </p:spPr>
+        <p:txBody>
+          <a:bodyPr wrap="square" rtlCol="0">
+            <a:spAutoFit/>
+          </a:bodyPr>
+          <a:lstStyle/>
+          <a:p>
+            <a:pPr algn="ctr"/>
+            <a:r>
+              <a:rPr lang="es-MX" sz="3600" dirty="0"/>
+              <a:t>Para </a:t>
+            </a:r>
+            <a:r>
+              <a:rPr lang="es-MX" sz="3600" b="1" dirty="0"/>
+              <a:t>Evaluar y cerrar caso </a:t>
+            </a:r>
+            <a:r>
+              <a:rPr lang="es-MX" sz="3600" dirty="0"/>
+              <a:t>en administración del caso, pestaña </a:t>
+            </a:r>
+            <a:r>
+              <a:rPr lang="es-MX" sz="3600" b="1" i="1" dirty="0"/>
+              <a:t>Cierre de caso </a:t>
+            </a:r>
+            <a:r>
+              <a:rPr lang="es-MX" sz="3600" dirty="0"/>
+              <a:t>de clic en el botón </a:t>
+            </a:r>
+            <a:r>
+              <a:rPr lang="es-MX" sz="3600" b="1" i="1" dirty="0"/>
+              <a:t>Volver a evaluar y cerrar caso</a:t>
+            </a:r>
+            <a:endParaRPr lang="es-CO" sz="2000" dirty="0"/>
+          </a:p>
+        </p:txBody>
+      </p:sp>
       <p:pic>
         <p:nvPicPr>
-          <p:cNvPr id="3" name="logo">
-            <a:extLst>
-              <a:ext uri="{FF2B5EF4-FFF2-40B4-BE49-F238E27FC236}">
-                <a16:creationId xmlns:a16="http://schemas.microsoft.com/office/drawing/2014/main" id="{CB7069CB-A915-E9BA-0362-5B269561515F}"/>
+          <p:cNvPr id="5" name="Imagen 4">
+            <a:extLst>
+              <a:ext uri="{FF2B5EF4-FFF2-40B4-BE49-F238E27FC236}">
+                <a16:creationId xmlns:a16="http://schemas.microsoft.com/office/drawing/2014/main" id="{0AFBDE35-35CA-75AC-DD52-27FE1D7052A7}"/>
               </a:ext>
             </a:extLst>
           </p:cNvPr>
@@ -5167,21 +5947,15 @@
           <p:nvPr/>
         </p:nvPicPr>
         <p:blipFill>
-          <a:blip r:embed="rId2">
-            <a:extLst>
-              <a:ext uri="{28A0092B-C50C-407E-A947-70E740481C1C}">
-                <a14:useLocalDpi xmlns:a14="http://schemas.microsoft.com/office/drawing/2010/main" val="0"/>
-              </a:ext>
-            </a:extLst>
-          </a:blip>
+          <a:blip r:embed="rId2"/>
           <a:stretch>
             <a:fillRect/>
           </a:stretch>
         </p:blipFill>
         <p:spPr>
           <a:xfrm>
-            <a:off x="8765519" y="3350269"/>
-            <a:ext cx="3426481" cy="3473976"/>
+            <a:off x="220471" y="2926036"/>
+            <a:ext cx="11751058" cy="1320012"/>
           </a:xfrm>
           <a:prstGeom prst="rect">
             <a:avLst/>
@@ -5190,10 +5964,10 @@
       </p:pic>
       <p:sp>
         <p:nvSpPr>
-          <p:cNvPr id="17" name="Rectángulo 16">
-            <a:extLst>
-              <a:ext uri="{FF2B5EF4-FFF2-40B4-BE49-F238E27FC236}">
-                <a16:creationId xmlns:a16="http://schemas.microsoft.com/office/drawing/2014/main" id="{A8B8087A-F01D-7BF2-7B9B-803D42A31868}"/>
+          <p:cNvPr id="9" name="Rectángulo 8">
+            <a:extLst>
+              <a:ext uri="{FF2B5EF4-FFF2-40B4-BE49-F238E27FC236}">
+                <a16:creationId xmlns:a16="http://schemas.microsoft.com/office/drawing/2014/main" id="{19CE3575-09A8-0984-60D0-CDEE01EEEB27}"/>
               </a:ext>
             </a:extLst>
           </p:cNvPr>
@@ -5202,263 +5976,8 @@
         </p:nvSpPr>
         <p:spPr>
           <a:xfrm>
-            <a:off x="0" y="0"/>
-            <a:ext cx="12192000" cy="6858000"/>
-          </a:xfrm>
-          <a:prstGeom prst="rect">
-            <a:avLst/>
-          </a:prstGeom>
-          <a:solidFill>
-            <a:schemeClr val="tx1">
-              <a:alpha val="70000"/>
-            </a:schemeClr>
-          </a:solidFill>
-          <a:ln>
-            <a:noFill/>
-          </a:ln>
-        </p:spPr>
-        <p:style>
-          <a:lnRef idx="2">
-            <a:schemeClr val="accent1">
-              <a:shade val="50000"/>
-            </a:schemeClr>
-          </a:lnRef>
-          <a:fillRef idx="1">
-            <a:schemeClr val="accent1"/>
-          </a:fillRef>
-          <a:effectRef idx="0">
-            <a:schemeClr val="accent1"/>
-          </a:effectRef>
-          <a:fontRef idx="minor">
-            <a:schemeClr val="lt1"/>
-          </a:fontRef>
-        </p:style>
-        <p:txBody>
-          <a:bodyPr rtlCol="0" anchor="ctr"/>
-          <a:lstStyle/>
-          <a:p>
-            <a:pPr algn="ctr"/>
-            <a:endParaRPr lang="es-CO">
-              <a:ln>
-                <a:solidFill>
-                  <a:schemeClr val="accent1"/>
-                </a:solidFill>
-              </a:ln>
-            </a:endParaRPr>
-          </a:p>
-        </p:txBody>
-      </p:sp>
-      <p:pic>
-        <p:nvPicPr>
-          <p:cNvPr id="6" name="Imagen 5">
-            <a:extLst>
-              <a:ext uri="{FF2B5EF4-FFF2-40B4-BE49-F238E27FC236}">
-                <a16:creationId xmlns:a16="http://schemas.microsoft.com/office/drawing/2014/main" id="{E88D09ED-200D-E71D-7D1B-4F0CB9EB1154}"/>
-              </a:ext>
-            </a:extLst>
-          </p:cNvPr>
-          <p:cNvPicPr>
-            <a:picLocks noChangeAspect="1"/>
-          </p:cNvPicPr>
-          <p:nvPr/>
-        </p:nvPicPr>
-        <p:blipFill>
-          <a:blip r:embed="rId3"/>
-          <a:stretch>
-            <a:fillRect/>
-          </a:stretch>
-        </p:blipFill>
-        <p:spPr>
-          <a:xfrm>
-            <a:off x="49006" y="2373538"/>
-            <a:ext cx="12093988" cy="2110923"/>
-          </a:xfrm>
-          <a:prstGeom prst="rect">
-            <a:avLst/>
-          </a:prstGeom>
-        </p:spPr>
-      </p:pic>
-      <p:sp>
-        <p:nvSpPr>
-          <p:cNvPr id="2" name="CuadroTexto 1">
-            <a:extLst>
-              <a:ext uri="{FF2B5EF4-FFF2-40B4-BE49-F238E27FC236}">
-                <a16:creationId xmlns:a16="http://schemas.microsoft.com/office/drawing/2014/main" id="{4BE15536-8584-618A-A38B-56A2C9028692}"/>
-              </a:ext>
-            </a:extLst>
-          </p:cNvPr>
-          <p:cNvSpPr txBox="1"/>
-          <p:nvPr/>
-        </p:nvSpPr>
-        <p:spPr>
-          <a:xfrm>
-            <a:off x="318426" y="445008"/>
-            <a:ext cx="11268635" cy="7048083"/>
-          </a:xfrm>
-          <a:prstGeom prst="rect">
-            <a:avLst/>
-          </a:prstGeom>
-          <a:noFill/>
-        </p:spPr>
-        <p:txBody>
-          <a:bodyPr wrap="square" rtlCol="0">
-            <a:spAutoFit/>
-          </a:bodyPr>
-          <a:lstStyle/>
-          <a:p>
-            <a:pPr algn="ctr"/>
-            <a:endParaRPr lang="es-MX" sz="3600" dirty="0">
-              <a:solidFill>
-                <a:schemeClr val="bg1"/>
-              </a:solidFill>
-            </a:endParaRPr>
-          </a:p>
-          <a:p>
-            <a:pPr algn="ctr"/>
-            <a:r>
-              <a:rPr lang="es-MX" sz="3600" dirty="0">
-                <a:solidFill>
-                  <a:schemeClr val="bg1"/>
-                </a:solidFill>
-              </a:rPr>
-              <a:t>Para </a:t>
-            </a:r>
-            <a:r>
-              <a:rPr lang="es-MX" sz="3600" b="1" dirty="0">
-                <a:solidFill>
-                  <a:schemeClr val="accent4">
-                    <a:lumMod val="60000"/>
-                    <a:lumOff val="40000"/>
-                  </a:schemeClr>
-                </a:solidFill>
-              </a:rPr>
-              <a:t>Dar de baja</a:t>
-            </a:r>
-            <a:r>
-              <a:rPr lang="es-MX" sz="3600" dirty="0">
-                <a:solidFill>
-                  <a:schemeClr val="bg1"/>
-                </a:solidFill>
-              </a:rPr>
-              <a:t> en administración del caso de clic en el botón </a:t>
-            </a:r>
-            <a:r>
-              <a:rPr lang="es-MX" sz="3600" b="1" i="1" dirty="0">
-                <a:solidFill>
-                  <a:schemeClr val="bg1"/>
-                </a:solidFill>
-              </a:rPr>
-              <a:t>Dar de baja</a:t>
-            </a:r>
-          </a:p>
-          <a:p>
-            <a:pPr algn="ctr"/>
-            <a:endParaRPr lang="es-MX" sz="3600" dirty="0">
-              <a:solidFill>
-                <a:schemeClr val="bg1"/>
-              </a:solidFill>
-            </a:endParaRPr>
-          </a:p>
-          <a:p>
-            <a:pPr algn="ctr"/>
-            <a:endParaRPr lang="es-MX" sz="3600" dirty="0">
-              <a:solidFill>
-                <a:schemeClr val="bg1"/>
-              </a:solidFill>
-            </a:endParaRPr>
-          </a:p>
-          <a:p>
-            <a:pPr algn="ctr"/>
-            <a:endParaRPr lang="es-MX" sz="3600" dirty="0">
-              <a:solidFill>
-                <a:schemeClr val="bg1"/>
-              </a:solidFill>
-            </a:endParaRPr>
-          </a:p>
-          <a:p>
-            <a:pPr algn="ctr"/>
-            <a:endParaRPr lang="es-MX" sz="3600" dirty="0">
-              <a:solidFill>
-                <a:schemeClr val="bg1"/>
-              </a:solidFill>
-            </a:endParaRPr>
-          </a:p>
-          <a:p>
-            <a:pPr algn="ctr"/>
-            <a:endParaRPr lang="es-MX" sz="3600" dirty="0">
-              <a:solidFill>
-                <a:schemeClr val="bg1"/>
-              </a:solidFill>
-            </a:endParaRPr>
-          </a:p>
-          <a:p>
-            <a:pPr algn="ctr"/>
-            <a:endParaRPr lang="es-MX" sz="3600" dirty="0">
-              <a:solidFill>
-                <a:schemeClr val="bg1"/>
-              </a:solidFill>
-            </a:endParaRPr>
-          </a:p>
-          <a:p>
-            <a:pPr algn="ctr"/>
-            <a:endParaRPr lang="es-MX" sz="3600" dirty="0">
-              <a:solidFill>
-                <a:schemeClr val="bg1"/>
-              </a:solidFill>
-            </a:endParaRPr>
-          </a:p>
-          <a:p>
-            <a:pPr algn="ctr"/>
-            <a:endParaRPr lang="es-MX" sz="3600" dirty="0">
-              <a:solidFill>
-                <a:schemeClr val="bg1"/>
-              </a:solidFill>
-            </a:endParaRPr>
-          </a:p>
-          <a:p>
-            <a:pPr algn="ctr"/>
-            <a:endParaRPr lang="es-MX" sz="3600" dirty="0">
-              <a:solidFill>
-                <a:schemeClr val="bg1"/>
-              </a:solidFill>
-            </a:endParaRPr>
-          </a:p>
-          <a:p>
-            <a:r>
-              <a:rPr lang="es-CO" sz="2000" dirty="0" err="1">
-                <a:solidFill>
-                  <a:schemeClr val="bg1"/>
-                </a:solidFill>
-              </a:rPr>
-              <a:t>Amatai</a:t>
-            </a:r>
-            <a:r>
-              <a:rPr lang="es-CO" sz="2000" dirty="0">
-                <a:solidFill>
-                  <a:schemeClr val="bg1"/>
-                </a:solidFill>
-              </a:rPr>
-              <a:t> SAS</a:t>
-            </a:r>
-          </a:p>
-        </p:txBody>
-      </p:sp>
-      <p:sp>
-        <p:nvSpPr>
-          <p:cNvPr id="9" name="Rectángulo 8">
-            <a:extLst>
-              <a:ext uri="{FF2B5EF4-FFF2-40B4-BE49-F238E27FC236}">
-                <a16:creationId xmlns:a16="http://schemas.microsoft.com/office/drawing/2014/main" id="{19CE3575-09A8-0984-60D0-CDEE01EEEB27}"/>
-              </a:ext>
-            </a:extLst>
-          </p:cNvPr>
-          <p:cNvSpPr/>
-          <p:nvPr/>
-        </p:nvSpPr>
-        <p:spPr>
-          <a:xfrm>
-            <a:off x="87005" y="3007481"/>
-            <a:ext cx="3338947" cy="696160"/>
+            <a:off x="8023412" y="3756212"/>
+            <a:ext cx="3882075" cy="489836"/>
           </a:xfrm>
           <a:prstGeom prst="rect">
             <a:avLst/>
@@ -5486,45 +6005,16 @@
           <a:lstStyle/>
           <a:p>
             <a:pPr algn="ctr"/>
-            <a:endParaRPr lang="es-CO"/>
+            <a:endParaRPr lang="es-CO" dirty="0"/>
           </a:p>
         </p:txBody>
       </p:sp>
       <p:pic>
         <p:nvPicPr>
-          <p:cNvPr id="11" name="Imagen 10">
-            <a:extLst>
-              <a:ext uri="{FF2B5EF4-FFF2-40B4-BE49-F238E27FC236}">
-                <a16:creationId xmlns:a16="http://schemas.microsoft.com/office/drawing/2014/main" id="{A19EB478-5B09-1BEA-819C-157C47F50696}"/>
-              </a:ext>
-            </a:extLst>
-          </p:cNvPr>
-          <p:cNvPicPr>
-            <a:picLocks noChangeAspect="1"/>
-          </p:cNvPicPr>
-          <p:nvPr/>
-        </p:nvPicPr>
-        <p:blipFill rotWithShape="1">
-          <a:blip r:embed="rId4"/>
-          <a:srcRect t="34649"/>
-          <a:stretch/>
-        </p:blipFill>
-        <p:spPr>
-          <a:xfrm>
-            <a:off x="318425" y="3007059"/>
-            <a:ext cx="2130959" cy="732442"/>
-          </a:xfrm>
-          <a:prstGeom prst="rect">
-            <a:avLst/>
-          </a:prstGeom>
-        </p:spPr>
-      </p:pic>
-      <p:pic>
-        <p:nvPicPr>
-          <p:cNvPr id="8" name="Gráfico 7" descr="Lupa">
-            <a:extLst>
-              <a:ext uri="{FF2B5EF4-FFF2-40B4-BE49-F238E27FC236}">
-                <a16:creationId xmlns:a16="http://schemas.microsoft.com/office/drawing/2014/main" id="{70287BDA-E56B-9DF6-26A8-A0F53C4766DE}"/>
+          <p:cNvPr id="10" name="Imagen 9">
+            <a:extLst>
+              <a:ext uri="{FF2B5EF4-FFF2-40B4-BE49-F238E27FC236}">
+                <a16:creationId xmlns:a16="http://schemas.microsoft.com/office/drawing/2014/main" id="{53A2EAAA-5EE2-C05E-D295-9FF8055A8272}"/>
               </a:ext>
             </a:extLst>
           </p:cNvPr>
@@ -5534,13 +6024,43 @@
           <p:nvPr/>
         </p:nvPicPr>
         <p:blipFill>
-          <a:blip r:embed="rId5">
+          <a:blip r:embed="rId3"/>
+          <a:stretch>
+            <a:fillRect/>
+          </a:stretch>
+        </p:blipFill>
+        <p:spPr>
+          <a:xfrm>
+            <a:off x="9054249" y="3657600"/>
+            <a:ext cx="2453953" cy="510988"/>
+          </a:xfrm>
+          <a:prstGeom prst="rect">
+            <a:avLst/>
+          </a:prstGeom>
+        </p:spPr>
+      </p:pic>
+      <p:pic>
+        <p:nvPicPr>
+          <p:cNvPr id="8" name="Gráfico 7" descr="Lupa">
+            <a:extLst>
+              <a:ext uri="{FF2B5EF4-FFF2-40B4-BE49-F238E27FC236}">
+                <a16:creationId xmlns:a16="http://schemas.microsoft.com/office/drawing/2014/main" id="{70287BDA-E56B-9DF6-26A8-A0F53C4766DE}"/>
+              </a:ext>
+            </a:extLst>
+          </p:cNvPr>
+          <p:cNvPicPr>
+            <a:picLocks noChangeAspect="1"/>
+          </p:cNvPicPr>
+          <p:nvPr/>
+        </p:nvPicPr>
+        <p:blipFill>
+          <a:blip r:embed="rId4">
             <a:extLst>
               <a:ext uri="{28A0092B-C50C-407E-A947-70E740481C1C}">
                 <a14:useLocalDpi xmlns:a14="http://schemas.microsoft.com/office/drawing/2010/main" val="0"/>
               </a:ext>
               <a:ext uri="{96DAC541-7B7A-43D3-8B79-37D633B846F1}">
-                <asvg:svgBlip xmlns:asvg="http://schemas.microsoft.com/office/drawing/2016/SVG/main" r:embed="rId6"/>
+                <asvg:svgBlip xmlns:asvg="http://schemas.microsoft.com/office/drawing/2016/SVG/main" r:embed="rId5"/>
               </a:ext>
             </a:extLst>
           </a:blip>
@@ -5549,9 +6069,9 @@
           </a:stretch>
         </p:blipFill>
         <p:spPr>
-          <a:xfrm rot="1121602">
-            <a:off x="-379857" y="1674076"/>
-            <a:ext cx="3882034" cy="3952767"/>
+          <a:xfrm rot="5689775">
+            <a:off x="7618904" y="2159922"/>
+            <a:ext cx="4373944" cy="4584270"/>
           </a:xfrm>
           <a:prstGeom prst="rect">
             <a:avLst/>
@@ -5561,7 +6081,7 @@
     </p:spTree>
     <p:extLst>
       <p:ext uri="{BB962C8B-B14F-4D97-AF65-F5344CB8AC3E}">
-        <p14:creationId xmlns:p14="http://schemas.microsoft.com/office/powerpoint/2010/main" val="1830992768"/>
+        <p14:creationId xmlns:p14="http://schemas.microsoft.com/office/powerpoint/2010/main" val="2129238174"/>
       </p:ext>
     </p:extLst>
   </p:cSld>
@@ -5588,42 +6108,6 @@
           <a:chExt cx="0" cy="0"/>
         </a:xfrm>
       </p:grpSpPr>
-      <p:pic>
-        <p:nvPicPr>
-          <p:cNvPr id="3" name="logo">
-            <a:extLst>
-              <a:ext uri="{FF2B5EF4-FFF2-40B4-BE49-F238E27FC236}">
-                <a16:creationId xmlns:a16="http://schemas.microsoft.com/office/drawing/2014/main" id="{CB7069CB-A915-E9BA-0362-5B269561515F}"/>
-              </a:ext>
-            </a:extLst>
-          </p:cNvPr>
-          <p:cNvPicPr>
-            <a:picLocks noChangeAspect="1"/>
-          </p:cNvPicPr>
-          <p:nvPr/>
-        </p:nvPicPr>
-        <p:blipFill>
-          <a:blip r:embed="rId2">
-            <a:extLst>
-              <a:ext uri="{28A0092B-C50C-407E-A947-70E740481C1C}">
-                <a14:useLocalDpi xmlns:a14="http://schemas.microsoft.com/office/drawing/2010/main" val="0"/>
-              </a:ext>
-            </a:extLst>
-          </a:blip>
-          <a:stretch>
-            <a:fillRect/>
-          </a:stretch>
-        </p:blipFill>
-        <p:spPr>
-          <a:xfrm>
-            <a:off x="8765519" y="3350269"/>
-            <a:ext cx="3426481" cy="3473976"/>
-          </a:xfrm>
-          <a:prstGeom prst="rect">
-            <a:avLst/>
-          </a:prstGeom>
-        </p:spPr>
-      </p:pic>
       <p:sp>
         <p:nvSpPr>
           <p:cNvPr id="17" name="Rectángulo 16">
@@ -5638,15 +6122,15 @@
         </p:nvSpPr>
         <p:spPr>
           <a:xfrm>
-            <a:off x="0" y="0"/>
-            <a:ext cx="12192000" cy="6858000"/>
+            <a:off x="0" y="5095874"/>
+            <a:ext cx="8943975" cy="1762125"/>
           </a:xfrm>
           <a:prstGeom prst="rect">
             <a:avLst/>
           </a:prstGeom>
           <a:solidFill>
             <a:schemeClr val="tx1">
-              <a:alpha val="70000"/>
+              <a:alpha val="0"/>
             </a:schemeClr>
           </a:solidFill>
           <a:ln>
@@ -5674,7 +6158,7 @@
           <a:lstStyle/>
           <a:p>
             <a:pPr algn="ctr"/>
-            <a:endParaRPr lang="es-CO">
+            <a:endParaRPr lang="es-CO" dirty="0">
               <a:ln>
                 <a:solidFill>
                   <a:schemeClr val="accent1"/>
@@ -5684,12 +6168,53 @@
           </a:p>
         </p:txBody>
       </p:sp>
+      <p:sp>
+        <p:nvSpPr>
+          <p:cNvPr id="10" name="CuadroTexto 9">
+            <a:extLst>
+              <a:ext uri="{FF2B5EF4-FFF2-40B4-BE49-F238E27FC236}">
+                <a16:creationId xmlns:a16="http://schemas.microsoft.com/office/drawing/2014/main" id="{C69317F1-3BC8-CC98-94BA-756E40E92416}"/>
+              </a:ext>
+            </a:extLst>
+          </p:cNvPr>
+          <p:cNvSpPr txBox="1"/>
+          <p:nvPr/>
+        </p:nvSpPr>
+        <p:spPr>
+          <a:xfrm>
+            <a:off x="861059" y="5399755"/>
+            <a:ext cx="9924288" cy="1200329"/>
+          </a:xfrm>
+          <a:prstGeom prst="rect">
+            <a:avLst/>
+          </a:prstGeom>
+          <a:noFill/>
+        </p:spPr>
+        <p:txBody>
+          <a:bodyPr wrap="square">
+            <a:spAutoFit/>
+          </a:bodyPr>
+          <a:lstStyle/>
+          <a:p>
+            <a:pPr algn="ctr"/>
+            <a:r>
+              <a:rPr lang="es-MX" sz="3600" dirty="0"/>
+              <a:t>Rellene los campo con las notas correspondientes y el debido concepto y presione </a:t>
+            </a:r>
+            <a:r>
+              <a:rPr lang="es-MX" sz="3600" b="1" dirty="0"/>
+              <a:t>Enviar</a:t>
+            </a:r>
+            <a:endParaRPr lang="es-MX" sz="3600" b="1" i="1" dirty="0"/>
+          </a:p>
+        </p:txBody>
+      </p:sp>
       <p:pic>
         <p:nvPicPr>
-          <p:cNvPr id="5" name="Imagen 4">
-            <a:extLst>
-              <a:ext uri="{FF2B5EF4-FFF2-40B4-BE49-F238E27FC236}">
-                <a16:creationId xmlns:a16="http://schemas.microsoft.com/office/drawing/2014/main" id="{BA4C5974-D310-4C4E-4C92-272A535AA142}"/>
+          <p:cNvPr id="9" name="Imagen 8">
+            <a:extLst>
+              <a:ext uri="{FF2B5EF4-FFF2-40B4-BE49-F238E27FC236}">
+                <a16:creationId xmlns:a16="http://schemas.microsoft.com/office/drawing/2014/main" id="{148AB8EB-5199-7878-EFD1-0403F7A0D122}"/>
               </a:ext>
             </a:extLst>
           </p:cNvPr>
@@ -5699,15 +6224,15 @@
           <p:nvPr/>
         </p:nvPicPr>
         <p:blipFill>
-          <a:blip r:embed="rId3"/>
+          <a:blip r:embed="rId2"/>
           <a:stretch>
             <a:fillRect/>
           </a:stretch>
         </p:blipFill>
         <p:spPr>
           <a:xfrm>
-            <a:off x="3605555" y="231425"/>
-            <a:ext cx="5273497" cy="5151566"/>
+            <a:off x="1577932" y="1549711"/>
+            <a:ext cx="4657691" cy="3698103"/>
           </a:xfrm>
           <a:prstGeom prst="rect">
             <a:avLst/>
@@ -5716,10 +6241,10 @@
       </p:pic>
       <p:sp>
         <p:nvSpPr>
-          <p:cNvPr id="10" name="CuadroTexto 9">
-            <a:extLst>
-              <a:ext uri="{FF2B5EF4-FFF2-40B4-BE49-F238E27FC236}">
-                <a16:creationId xmlns:a16="http://schemas.microsoft.com/office/drawing/2014/main" id="{C69317F1-3BC8-CC98-94BA-756E40E92416}"/>
+          <p:cNvPr id="2" name="CuadroTexto 1">
+            <a:extLst>
+              <a:ext uri="{FF2B5EF4-FFF2-40B4-BE49-F238E27FC236}">
+                <a16:creationId xmlns:a16="http://schemas.microsoft.com/office/drawing/2014/main" id="{AF724902-20D6-3D3C-6AAC-C2E7C4E58A8C}"/>
               </a:ext>
             </a:extLst>
           </p:cNvPr>
@@ -5728,7 +6253,7 @@
         </p:nvSpPr>
         <p:spPr>
           <a:xfrm>
-            <a:off x="1280159" y="5503453"/>
+            <a:off x="1273479" y="170900"/>
             <a:ext cx="9924288" cy="1200329"/>
           </a:xfrm>
           <a:prstGeom prst="rect">
@@ -5744,42 +6269,108 @@
           <a:p>
             <a:pPr algn="ctr"/>
             <a:r>
-              <a:rPr lang="es-MX" sz="3600" dirty="0">
-                <a:solidFill>
-                  <a:schemeClr val="bg1"/>
-                </a:solidFill>
-              </a:rPr>
-              <a:t>Ingrese una descripción y de clic en botón </a:t>
-            </a:r>
-          </a:p>
+              <a:rPr lang="es-MX" sz="3600" dirty="0"/>
+              <a:t>Si el expediente fue enviado a cierre el sistema le mostrará el siguiente formulario</a:t>
+            </a:r>
+            <a:endParaRPr lang="es-MX" sz="3600" b="1" i="1" dirty="0"/>
+          </a:p>
+        </p:txBody>
+      </p:sp>
+      <p:sp>
+        <p:nvSpPr>
+          <p:cNvPr id="11" name="Flecha: hacia la izquierda 10">
+            <a:extLst>
+              <a:ext uri="{FF2B5EF4-FFF2-40B4-BE49-F238E27FC236}">
+                <a16:creationId xmlns:a16="http://schemas.microsoft.com/office/drawing/2014/main" id="{E1E1555B-E540-70DD-68BF-D433A13A7A76}"/>
+              </a:ext>
+            </a:extLst>
+          </p:cNvPr>
+          <p:cNvSpPr/>
+          <p:nvPr/>
+        </p:nvSpPr>
+        <p:spPr>
+          <a:xfrm>
+            <a:off x="4934401" y="1559934"/>
+            <a:ext cx="2043953" cy="598756"/>
+          </a:xfrm>
+          <a:prstGeom prst="leftArrow">
+            <a:avLst/>
+          </a:prstGeom>
+          <a:solidFill>
+            <a:srgbClr val="268C91"/>
+          </a:solidFill>
+          <a:ln>
+            <a:solidFill>
+              <a:srgbClr val="268C91"/>
+            </a:solidFill>
+          </a:ln>
+        </p:spPr>
+        <p:style>
+          <a:lnRef idx="2">
+            <a:schemeClr val="accent1">
+              <a:shade val="15000"/>
+            </a:schemeClr>
+          </a:lnRef>
+          <a:fillRef idx="1">
+            <a:schemeClr val="accent1"/>
+          </a:fillRef>
+          <a:effectRef idx="0">
+            <a:schemeClr val="accent1"/>
+          </a:effectRef>
+          <a:fontRef idx="minor">
+            <a:schemeClr val="lt1"/>
+          </a:fontRef>
+        </p:style>
+        <p:txBody>
+          <a:bodyPr rtlCol="0" anchor="ctr"/>
+          <a:lstStyle/>
           <a:p>
             <a:pPr algn="ctr"/>
-            <a:r>
-              <a:rPr lang="es-MX" sz="3600" dirty="0">
-                <a:solidFill>
-                  <a:schemeClr val="accent4">
-                    <a:lumMod val="60000"/>
-                    <a:lumOff val="40000"/>
-                  </a:schemeClr>
-                </a:solidFill>
-              </a:rPr>
-              <a:t>Si, dar de baja</a:t>
-            </a:r>
-            <a:endParaRPr lang="es-MX" sz="3600" b="1" i="1" dirty="0">
-              <a:solidFill>
-                <a:schemeClr val="accent4">
-                  <a:lumMod val="60000"/>
-                  <a:lumOff val="40000"/>
-                </a:schemeClr>
-              </a:solidFill>
-            </a:endParaRPr>
+            <a:endParaRPr lang="es-CO"/>
+          </a:p>
+        </p:txBody>
+      </p:sp>
+      <p:sp>
+        <p:nvSpPr>
+          <p:cNvPr id="12" name="CuadroTexto 11">
+            <a:extLst>
+              <a:ext uri="{FF2B5EF4-FFF2-40B4-BE49-F238E27FC236}">
+                <a16:creationId xmlns:a16="http://schemas.microsoft.com/office/drawing/2014/main" id="{9D0BEF1D-198B-D1FF-1876-470AB6F5E43E}"/>
+              </a:ext>
+            </a:extLst>
+          </p:cNvPr>
+          <p:cNvSpPr txBox="1"/>
+          <p:nvPr/>
+        </p:nvSpPr>
+        <p:spPr>
+          <a:xfrm>
+            <a:off x="6453187" y="1954331"/>
+            <a:ext cx="4981575" cy="954107"/>
+          </a:xfrm>
+          <a:prstGeom prst="rect">
+            <a:avLst/>
+          </a:prstGeom>
+          <a:noFill/>
+        </p:spPr>
+        <p:txBody>
+          <a:bodyPr wrap="square">
+            <a:spAutoFit/>
+          </a:bodyPr>
+          <a:lstStyle/>
+          <a:p>
+            <a:pPr algn="ctr"/>
+            <a:r>
+              <a:rPr lang="es-MX" sz="2800" dirty="0"/>
+              <a:t>Indica el corte al que se asignará la nota</a:t>
+            </a:r>
+            <a:endParaRPr lang="es-MX" sz="2800" b="1" i="1" dirty="0"/>
           </a:p>
         </p:txBody>
       </p:sp>
     </p:spTree>
     <p:extLst>
       <p:ext uri="{BB962C8B-B14F-4D97-AF65-F5344CB8AC3E}">
-        <p14:creationId xmlns:p14="http://schemas.microsoft.com/office/powerpoint/2010/main" val="1612107509"/>
+        <p14:creationId xmlns:p14="http://schemas.microsoft.com/office/powerpoint/2010/main" val="1720992572"/>
       </p:ext>
     </p:extLst>
   </p:cSld>
@@ -5806,42 +6397,6 @@
           <a:chExt cx="0" cy="0"/>
         </a:xfrm>
       </p:grpSpPr>
-      <p:pic>
-        <p:nvPicPr>
-          <p:cNvPr id="3" name="logo">
-            <a:extLst>
-              <a:ext uri="{FF2B5EF4-FFF2-40B4-BE49-F238E27FC236}">
-                <a16:creationId xmlns:a16="http://schemas.microsoft.com/office/drawing/2014/main" id="{CB7069CB-A915-E9BA-0362-5B269561515F}"/>
-              </a:ext>
-            </a:extLst>
-          </p:cNvPr>
-          <p:cNvPicPr>
-            <a:picLocks noChangeAspect="1"/>
-          </p:cNvPicPr>
-          <p:nvPr/>
-        </p:nvPicPr>
-        <p:blipFill>
-          <a:blip r:embed="rId2">
-            <a:extLst>
-              <a:ext uri="{28A0092B-C50C-407E-A947-70E740481C1C}">
-                <a14:useLocalDpi xmlns:a14="http://schemas.microsoft.com/office/drawing/2010/main" val="0"/>
-              </a:ext>
-            </a:extLst>
-          </a:blip>
-          <a:stretch>
-            <a:fillRect/>
-          </a:stretch>
-        </p:blipFill>
-        <p:spPr>
-          <a:xfrm>
-            <a:off x="8765519" y="3350269"/>
-            <a:ext cx="3426481" cy="3473976"/>
-          </a:xfrm>
-          <a:prstGeom prst="rect">
-            <a:avLst/>
-          </a:prstGeom>
-        </p:spPr>
-      </p:pic>
       <p:sp>
         <p:nvSpPr>
           <p:cNvPr id="17" name="Rectángulo 16">
@@ -5856,15 +6411,15 @@
         </p:nvSpPr>
         <p:spPr>
           <a:xfrm>
-            <a:off x="0" y="0"/>
-            <a:ext cx="12192000" cy="6858000"/>
+            <a:off x="0" y="5095874"/>
+            <a:ext cx="8943975" cy="1762125"/>
           </a:xfrm>
           <a:prstGeom prst="rect">
             <a:avLst/>
           </a:prstGeom>
           <a:solidFill>
             <a:schemeClr val="tx1">
-              <a:alpha val="70000"/>
+              <a:alpha val="0"/>
             </a:schemeClr>
           </a:solidFill>
           <a:ln>
@@ -5892,7 +6447,7 @@
           <a:lstStyle/>
           <a:p>
             <a:pPr algn="ctr"/>
-            <a:endParaRPr lang="es-CO">
+            <a:endParaRPr lang="es-CO" dirty="0">
               <a:ln>
                 <a:solidFill>
                   <a:schemeClr val="accent1"/>
@@ -5904,10 +6459,10 @@
       </p:sp>
       <p:sp>
         <p:nvSpPr>
-          <p:cNvPr id="2" name="CuadroTexto 1">
-            <a:extLst>
-              <a:ext uri="{FF2B5EF4-FFF2-40B4-BE49-F238E27FC236}">
-                <a16:creationId xmlns:a16="http://schemas.microsoft.com/office/drawing/2014/main" id="{4BE15536-8584-618A-A38B-56A2C9028692}"/>
+          <p:cNvPr id="10" name="CuadroTexto 9">
+            <a:extLst>
+              <a:ext uri="{FF2B5EF4-FFF2-40B4-BE49-F238E27FC236}">
+                <a16:creationId xmlns:a16="http://schemas.microsoft.com/office/drawing/2014/main" id="{C69317F1-3BC8-CC98-94BA-756E40E92416}"/>
               </a:ext>
             </a:extLst>
           </p:cNvPr>
@@ -5916,8 +6471,8 @@
         </p:nvSpPr>
         <p:spPr>
           <a:xfrm>
-            <a:off x="318426" y="445008"/>
-            <a:ext cx="11268635" cy="7048083"/>
+            <a:off x="5754220" y="4263625"/>
+            <a:ext cx="6315075" cy="1754326"/>
           </a:xfrm>
           <a:prstGeom prst="rect">
             <a:avLst/>
@@ -5925,167 +6480,78 @@
           <a:noFill/>
         </p:spPr>
         <p:txBody>
-          <a:bodyPr wrap="square" rtlCol="0">
+          <a:bodyPr wrap="square">
             <a:spAutoFit/>
           </a:bodyPr>
           <a:lstStyle/>
           <a:p>
+            <a:r>
+              <a:rPr lang="es-MX" sz="3600" dirty="0"/>
+              <a:t>Rellene los campos con las notas correspondientes y el debido concepto y presione </a:t>
+            </a:r>
+            <a:r>
+              <a:rPr lang="es-MX" sz="3600" b="1" dirty="0"/>
+              <a:t>Enviar</a:t>
+            </a:r>
+            <a:endParaRPr lang="es-MX" sz="3600" b="1" i="1" dirty="0"/>
+          </a:p>
+        </p:txBody>
+      </p:sp>
+      <p:sp>
+        <p:nvSpPr>
+          <p:cNvPr id="2" name="CuadroTexto 1">
+            <a:extLst>
+              <a:ext uri="{FF2B5EF4-FFF2-40B4-BE49-F238E27FC236}">
+                <a16:creationId xmlns:a16="http://schemas.microsoft.com/office/drawing/2014/main" id="{AF724902-20D6-3D3C-6AAC-C2E7C4E58A8C}"/>
+              </a:ext>
+            </a:extLst>
+          </p:cNvPr>
+          <p:cNvSpPr txBox="1"/>
+          <p:nvPr/>
+        </p:nvSpPr>
+        <p:spPr>
+          <a:xfrm>
+            <a:off x="1273479" y="170900"/>
+            <a:ext cx="9924288" cy="1200329"/>
+          </a:xfrm>
+          <a:prstGeom prst="rect">
+            <a:avLst/>
+          </a:prstGeom>
+          <a:noFill/>
+        </p:spPr>
+        <p:txBody>
+          <a:bodyPr wrap="square">
+            <a:spAutoFit/>
+          </a:bodyPr>
+          <a:lstStyle/>
+          <a:p>
             <a:pPr algn="ctr"/>
-            <a:endParaRPr lang="es-MX" sz="3600" dirty="0">
-              <a:solidFill>
-                <a:schemeClr val="bg1"/>
-              </a:solidFill>
-            </a:endParaRPr>
-          </a:p>
-          <a:p>
-            <a:pPr algn="ctr"/>
-            <a:r>
-              <a:rPr lang="es-MX" sz="3600" dirty="0">
-                <a:solidFill>
-                  <a:schemeClr val="bg1"/>
+            <a:r>
+              <a:rPr lang="es-MX" sz="3600" dirty="0"/>
+              <a:t>Si el expediente </a:t>
+            </a:r>
+            <a:r>
+              <a:rPr lang="es-MX" sz="3600" b="1" dirty="0">
+                <a:solidFill>
+                  <a:srgbClr val="D68843"/>
                 </a:solidFill>
               </a:rPr>
-              <a:t>Para poner en </a:t>
-            </a:r>
-            <a:r>
-              <a:rPr lang="es-MX" sz="3600" b="1" dirty="0">
-                <a:solidFill>
-                  <a:schemeClr val="accent4">
-                    <a:lumMod val="60000"/>
-                    <a:lumOff val="40000"/>
-                  </a:schemeClr>
-                </a:solidFill>
-              </a:rPr>
-              <a:t>Revisión</a:t>
-            </a:r>
-            <a:r>
-              <a:rPr lang="es-MX" sz="3600" dirty="0">
-                <a:solidFill>
-                  <a:schemeClr val="bg1"/>
-                </a:solidFill>
-              </a:rPr>
-              <a:t> en cierre de caso de clic en el botón </a:t>
-            </a:r>
-            <a:r>
-              <a:rPr lang="es-MX" sz="3600" b="1" i="1" dirty="0">
-                <a:solidFill>
-                  <a:schemeClr val="bg1"/>
-                </a:solidFill>
-              </a:rPr>
-              <a:t>Pasar a </a:t>
-            </a:r>
-            <a:r>
-              <a:rPr lang="es-MX" sz="3600" b="1" i="1" dirty="0" err="1">
-                <a:solidFill>
-                  <a:schemeClr val="bg1"/>
-                </a:solidFill>
-              </a:rPr>
-              <a:t>revisón</a:t>
-            </a:r>
-            <a:endParaRPr lang="es-MX" sz="3600" b="1" i="1" dirty="0">
-              <a:solidFill>
-                <a:schemeClr val="bg1"/>
-              </a:solidFill>
-            </a:endParaRPr>
-          </a:p>
-          <a:p>
-            <a:pPr algn="ctr"/>
-            <a:endParaRPr lang="es-MX" sz="3600" dirty="0">
-              <a:solidFill>
-                <a:schemeClr val="bg1"/>
-              </a:solidFill>
-            </a:endParaRPr>
-          </a:p>
-          <a:p>
-            <a:pPr algn="ctr"/>
-            <a:endParaRPr lang="es-MX" sz="3600" dirty="0">
-              <a:solidFill>
-                <a:schemeClr val="bg1"/>
-              </a:solidFill>
-            </a:endParaRPr>
-          </a:p>
-          <a:p>
-            <a:pPr algn="ctr"/>
-            <a:endParaRPr lang="es-MX" sz="3600" dirty="0">
-              <a:solidFill>
-                <a:schemeClr val="bg1"/>
-              </a:solidFill>
-            </a:endParaRPr>
-          </a:p>
-          <a:p>
-            <a:pPr algn="ctr"/>
-            <a:endParaRPr lang="es-MX" sz="3600" dirty="0">
-              <a:solidFill>
-                <a:schemeClr val="bg1"/>
-              </a:solidFill>
-            </a:endParaRPr>
-          </a:p>
-          <a:p>
-            <a:pPr algn="ctr"/>
-            <a:endParaRPr lang="es-MX" sz="3600" dirty="0">
-              <a:solidFill>
-                <a:schemeClr val="bg1"/>
-              </a:solidFill>
-            </a:endParaRPr>
-          </a:p>
-          <a:p>
-            <a:pPr algn="ctr"/>
-            <a:endParaRPr lang="es-MX" sz="3600" dirty="0">
-              <a:solidFill>
-                <a:schemeClr val="bg1"/>
-              </a:solidFill>
-            </a:endParaRPr>
-          </a:p>
-          <a:p>
-            <a:pPr algn="ctr"/>
-            <a:endParaRPr lang="es-MX" sz="3600" dirty="0">
-              <a:solidFill>
-                <a:schemeClr val="bg1"/>
-              </a:solidFill>
-            </a:endParaRPr>
-          </a:p>
-          <a:p>
-            <a:pPr algn="ctr"/>
-            <a:endParaRPr lang="es-MX" sz="3600" dirty="0">
-              <a:solidFill>
-                <a:schemeClr val="bg1"/>
-              </a:solidFill>
-            </a:endParaRPr>
-          </a:p>
-          <a:p>
-            <a:pPr algn="ctr"/>
-            <a:endParaRPr lang="es-MX" sz="3600" dirty="0">
-              <a:solidFill>
-                <a:schemeClr val="bg1"/>
-              </a:solidFill>
-            </a:endParaRPr>
-          </a:p>
-          <a:p>
-            <a:r>
-              <a:rPr lang="es-CO" sz="2000" dirty="0" err="1">
-                <a:solidFill>
-                  <a:schemeClr val="bg1"/>
-                </a:solidFill>
-              </a:rPr>
-              <a:t>Amatai</a:t>
-            </a:r>
-            <a:r>
-              <a:rPr lang="es-CO" sz="2000" dirty="0">
-                <a:solidFill>
-                  <a:schemeClr val="bg1"/>
-                </a:solidFill>
-              </a:rPr>
-              <a:t> SAS</a:t>
-            </a:r>
+              <a:t>NO</a:t>
+            </a:r>
+            <a:r>
+              <a:rPr lang="es-MX" sz="3600" dirty="0"/>
+              <a:t> fue enviado a cierre el sistema le mostrará el siguiente formulario</a:t>
+            </a:r>
+            <a:endParaRPr lang="es-MX" sz="3600" b="1" i="1" dirty="0"/>
           </a:p>
         </p:txBody>
       </p:sp>
       <p:pic>
         <p:nvPicPr>
-          <p:cNvPr id="11" name="Imagen 10">
-            <a:extLst>
-              <a:ext uri="{FF2B5EF4-FFF2-40B4-BE49-F238E27FC236}">
-                <a16:creationId xmlns:a16="http://schemas.microsoft.com/office/drawing/2014/main" id="{5B1CAB16-AAFF-0020-E3FE-85BE9C43733E}"/>
+          <p:cNvPr id="5" name="Imagen 4">
+            <a:extLst>
+              <a:ext uri="{FF2B5EF4-FFF2-40B4-BE49-F238E27FC236}">
+                <a16:creationId xmlns:a16="http://schemas.microsoft.com/office/drawing/2014/main" id="{ED2E2905-3E2C-69E2-5A9B-B4466660BADD}"/>
               </a:ext>
             </a:extLst>
           </p:cNvPr>
@@ -6095,15 +6561,15 @@
           <p:nvPr/>
         </p:nvPicPr>
         <p:blipFill>
-          <a:blip r:embed="rId3"/>
+          <a:blip r:embed="rId2"/>
           <a:stretch>
             <a:fillRect/>
           </a:stretch>
         </p:blipFill>
         <p:spPr>
           <a:xfrm>
-            <a:off x="239522" y="2903174"/>
-            <a:ext cx="11712955" cy="1051651"/>
+            <a:off x="495300" y="1488522"/>
+            <a:ext cx="5137336" cy="5057415"/>
           </a:xfrm>
           <a:prstGeom prst="rect">
             <a:avLst/>
@@ -6112,10 +6578,10 @@
       </p:pic>
       <p:sp>
         <p:nvSpPr>
-          <p:cNvPr id="9" name="Rectángulo 8">
-            <a:extLst>
-              <a:ext uri="{FF2B5EF4-FFF2-40B4-BE49-F238E27FC236}">
-                <a16:creationId xmlns:a16="http://schemas.microsoft.com/office/drawing/2014/main" id="{19CE3575-09A8-0984-60D0-CDEE01EEEB27}"/>
+          <p:cNvPr id="6" name="Flecha: hacia la izquierda 5">
+            <a:extLst>
+              <a:ext uri="{FF2B5EF4-FFF2-40B4-BE49-F238E27FC236}">
+                <a16:creationId xmlns:a16="http://schemas.microsoft.com/office/drawing/2014/main" id="{5D20A52D-0436-1D23-9673-F7DCA1BDB1A4}"/>
               </a:ext>
             </a:extLst>
           </p:cNvPr>
@@ -6124,28 +6590,126 @@
         </p:nvSpPr>
         <p:spPr>
           <a:xfrm>
-            <a:off x="239522" y="3452565"/>
-            <a:ext cx="11712954" cy="661164"/>
+            <a:off x="3993636" y="1536431"/>
+            <a:ext cx="2043953" cy="598756"/>
+          </a:xfrm>
+          <a:prstGeom prst="leftArrow">
+            <a:avLst/>
+          </a:prstGeom>
+          <a:solidFill>
+            <a:srgbClr val="268C91"/>
+          </a:solidFill>
+          <a:ln>
+            <a:solidFill>
+              <a:srgbClr val="268C91"/>
+            </a:solidFill>
+          </a:ln>
+        </p:spPr>
+        <p:style>
+          <a:lnRef idx="2">
+            <a:schemeClr val="accent1">
+              <a:shade val="15000"/>
+            </a:schemeClr>
+          </a:lnRef>
+          <a:fillRef idx="1">
+            <a:schemeClr val="accent1"/>
+          </a:fillRef>
+          <a:effectRef idx="0">
+            <a:schemeClr val="accent1"/>
+          </a:effectRef>
+          <a:fontRef idx="minor">
+            <a:schemeClr val="lt1"/>
+          </a:fontRef>
+        </p:style>
+        <p:txBody>
+          <a:bodyPr rtlCol="0" anchor="ctr"/>
+          <a:lstStyle/>
+          <a:p>
+            <a:pPr algn="ctr"/>
+            <a:endParaRPr lang="es-CO"/>
+          </a:p>
+        </p:txBody>
+      </p:sp>
+      <p:sp>
+        <p:nvSpPr>
+          <p:cNvPr id="3" name="CuadroTexto 2">
+            <a:extLst>
+              <a:ext uri="{FF2B5EF4-FFF2-40B4-BE49-F238E27FC236}">
+                <a16:creationId xmlns:a16="http://schemas.microsoft.com/office/drawing/2014/main" id="{B9552762-DFC6-9EDC-1C32-BCC44D072E7F}"/>
+              </a:ext>
+            </a:extLst>
+          </p:cNvPr>
+          <p:cNvSpPr txBox="1"/>
+          <p:nvPr/>
+        </p:nvSpPr>
+        <p:spPr>
+          <a:xfrm>
+            <a:off x="5929872" y="1658133"/>
+            <a:ext cx="4981575" cy="954107"/>
           </a:xfrm>
           <a:prstGeom prst="rect">
             <a:avLst/>
           </a:prstGeom>
+          <a:noFill/>
+        </p:spPr>
+        <p:txBody>
+          <a:bodyPr wrap="square">
+            <a:spAutoFit/>
+          </a:bodyPr>
+          <a:lstStyle/>
+          <a:p>
+            <a:pPr algn="ctr"/>
+            <a:r>
+              <a:rPr lang="es-MX" sz="2800" dirty="0"/>
+              <a:t>Indica el corte al que se asignará la nota</a:t>
+            </a:r>
+            <a:endParaRPr lang="es-MX" sz="2800" b="1" i="1" dirty="0"/>
+          </a:p>
+        </p:txBody>
+      </p:sp>
+      <p:sp>
+        <p:nvSpPr>
+          <p:cNvPr id="4" name="Flecha: hacia la izquierda 3">
+            <a:extLst>
+              <a:ext uri="{FF2B5EF4-FFF2-40B4-BE49-F238E27FC236}">
+                <a16:creationId xmlns:a16="http://schemas.microsoft.com/office/drawing/2014/main" id="{7FF5DA75-80F6-B698-EA66-5A6ED3F43048}"/>
+              </a:ext>
+            </a:extLst>
+          </p:cNvPr>
+          <p:cNvSpPr/>
+          <p:nvPr/>
+        </p:nvSpPr>
+        <p:spPr>
+          <a:xfrm>
+            <a:off x="2800349" y="4136485"/>
+            <a:ext cx="2043953" cy="647327"/>
+          </a:xfrm>
+          <a:prstGeom prst="leftArrow">
+            <a:avLst/>
+          </a:prstGeom>
+          <a:solidFill>
+            <a:srgbClr val="268C91"/>
+          </a:solidFill>
           <a:ln>
-            <a:noFill/>
+            <a:solidFill>
+              <a:srgbClr val="268C91"/>
+            </a:solidFill>
           </a:ln>
         </p:spPr>
         <p:style>
           <a:lnRef idx="2">
-            <a:schemeClr val="accent6"/>
+            <a:schemeClr val="accent1">
+              <a:shade val="15000"/>
+            </a:schemeClr>
           </a:lnRef>
           <a:fillRef idx="1">
-            <a:schemeClr val="lt1"/>
+            <a:schemeClr val="accent1"/>
           </a:fillRef>
           <a:effectRef idx="0">
-            <a:schemeClr val="accent6"/>
+            <a:schemeClr val="accent1"/>
           </a:effectRef>
           <a:fontRef idx="minor">
-            <a:schemeClr val="dk1"/>
+            <a:schemeClr val="lt1"/>
           </a:fontRef>
         </p:style>
         <p:txBody>
@@ -6153,83 +6717,17 @@
           <a:lstStyle/>
           <a:p>
             <a:pPr algn="ctr"/>
-            <a:endParaRPr lang="es-CO"/>
-          </a:p>
-        </p:txBody>
-      </p:sp>
-      <p:pic>
-        <p:nvPicPr>
-          <p:cNvPr id="6" name="Imagen 5">
-            <a:extLst>
-              <a:ext uri="{FF2B5EF4-FFF2-40B4-BE49-F238E27FC236}">
-                <a16:creationId xmlns:a16="http://schemas.microsoft.com/office/drawing/2014/main" id="{64A37F9C-3281-B95E-E2B7-E03DE749C2AA}"/>
-              </a:ext>
-            </a:extLst>
-          </p:cNvPr>
-          <p:cNvPicPr>
-            <a:picLocks noChangeAspect="1"/>
-          </p:cNvPicPr>
-          <p:nvPr/>
-        </p:nvPicPr>
-        <p:blipFill>
-          <a:blip r:embed="rId4"/>
-          <a:stretch>
-            <a:fillRect/>
-          </a:stretch>
-        </p:blipFill>
-        <p:spPr>
-          <a:xfrm>
-            <a:off x="8717173" y="3433863"/>
-            <a:ext cx="2140377" cy="661164"/>
-          </a:xfrm>
-          <a:prstGeom prst="rect">
-            <a:avLst/>
-          </a:prstGeom>
-        </p:spPr>
-      </p:pic>
-      <p:pic>
-        <p:nvPicPr>
-          <p:cNvPr id="8" name="Gráfico 7" descr="Lupa">
-            <a:extLst>
-              <a:ext uri="{FF2B5EF4-FFF2-40B4-BE49-F238E27FC236}">
-                <a16:creationId xmlns:a16="http://schemas.microsoft.com/office/drawing/2014/main" id="{70287BDA-E56B-9DF6-26A8-A0F53C4766DE}"/>
-              </a:ext>
-            </a:extLst>
-          </p:cNvPr>
-          <p:cNvPicPr>
-            <a:picLocks noChangeAspect="1"/>
-          </p:cNvPicPr>
-          <p:nvPr/>
-        </p:nvPicPr>
-        <p:blipFill>
-          <a:blip r:embed="rId5">
-            <a:extLst>
-              <a:ext uri="{28A0092B-C50C-407E-A947-70E740481C1C}">
-                <a14:useLocalDpi xmlns:a14="http://schemas.microsoft.com/office/drawing/2010/main" val="0"/>
-              </a:ext>
-              <a:ext uri="{96DAC541-7B7A-43D3-8B79-37D633B846F1}">
-                <asvg:svgBlip xmlns:asvg="http://schemas.microsoft.com/office/drawing/2016/SVG/main" r:embed="rId6"/>
-              </a:ext>
-            </a:extLst>
-          </a:blip>
-          <a:stretch>
-            <a:fillRect/>
-          </a:stretch>
-        </p:blipFill>
-        <p:spPr>
-          <a:xfrm rot="5181362">
-            <a:off x="7319456" y="2349657"/>
-            <a:ext cx="4092798" cy="4018677"/>
-          </a:xfrm>
-          <a:prstGeom prst="rect">
-            <a:avLst/>
-          </a:prstGeom>
-        </p:spPr>
-      </p:pic>
+            <a:r>
+              <a:rPr lang="es-CO" sz="1200" dirty="0"/>
+              <a:t>Puede cambiar las notas</a:t>
+            </a:r>
+          </a:p>
+        </p:txBody>
+      </p:sp>
     </p:spTree>
     <p:extLst>
       <p:ext uri="{BB962C8B-B14F-4D97-AF65-F5344CB8AC3E}">
-        <p14:creationId xmlns:p14="http://schemas.microsoft.com/office/powerpoint/2010/main" val="5733342"/>
+        <p14:creationId xmlns:p14="http://schemas.microsoft.com/office/powerpoint/2010/main" val="4049931818"/>
       </p:ext>
     </p:extLst>
   </p:cSld>
@@ -6352,66 +6850,12 @@
           </a:p>
         </p:txBody>
       </p:sp>
-      <p:sp>
-        <p:nvSpPr>
-          <p:cNvPr id="10" name="CuadroTexto 9">
-            <a:extLst>
-              <a:ext uri="{FF2B5EF4-FFF2-40B4-BE49-F238E27FC236}">
-                <a16:creationId xmlns:a16="http://schemas.microsoft.com/office/drawing/2014/main" id="{C69317F1-3BC8-CC98-94BA-756E40E92416}"/>
-              </a:ext>
-            </a:extLst>
-          </p:cNvPr>
-          <p:cNvSpPr txBox="1"/>
-          <p:nvPr/>
-        </p:nvSpPr>
-        <p:spPr>
-          <a:xfrm>
-            <a:off x="1280159" y="5503453"/>
-            <a:ext cx="9924288" cy="1200329"/>
-          </a:xfrm>
-          <a:prstGeom prst="rect">
-            <a:avLst/>
-          </a:prstGeom>
-          <a:noFill/>
-        </p:spPr>
-        <p:txBody>
-          <a:bodyPr wrap="square">
-            <a:spAutoFit/>
-          </a:bodyPr>
-          <a:lstStyle/>
-          <a:p>
-            <a:pPr algn="ctr"/>
-            <a:r>
-              <a:rPr lang="es-MX" sz="3600" dirty="0">
-                <a:solidFill>
-                  <a:schemeClr val="bg1"/>
-                </a:solidFill>
-              </a:rPr>
-              <a:t>Ingrese una descripción y de clic en botón </a:t>
-            </a:r>
-          </a:p>
-          <a:p>
-            <a:pPr algn="ctr"/>
-            <a:r>
-              <a:rPr lang="es-MX" sz="3600" b="1" i="1" dirty="0">
-                <a:solidFill>
-                  <a:schemeClr val="accent4">
-                    <a:lumMod val="60000"/>
-                    <a:lumOff val="40000"/>
-                  </a:schemeClr>
-                </a:solidFill>
-              </a:rPr>
-              <a:t>Pasar a revisión</a:t>
-            </a:r>
-          </a:p>
-        </p:txBody>
-      </p:sp>
       <p:pic>
         <p:nvPicPr>
-          <p:cNvPr id="4" name="Imagen 3">
-            <a:extLst>
-              <a:ext uri="{FF2B5EF4-FFF2-40B4-BE49-F238E27FC236}">
-                <a16:creationId xmlns:a16="http://schemas.microsoft.com/office/drawing/2014/main" id="{9D70D671-5EC9-54B1-0582-072BDD2C4351}"/>
+          <p:cNvPr id="6" name="Imagen 5">
+            <a:extLst>
+              <a:ext uri="{FF2B5EF4-FFF2-40B4-BE49-F238E27FC236}">
+                <a16:creationId xmlns:a16="http://schemas.microsoft.com/office/drawing/2014/main" id="{E88D09ED-200D-E71D-7D1B-4F0CB9EB1154}"/>
               </a:ext>
             </a:extLst>
           </p:cNvPr>
@@ -6428,8 +6872,288 @@
         </p:blipFill>
         <p:spPr>
           <a:xfrm>
-            <a:off x="3592613" y="1748644"/>
-            <a:ext cx="5006774" cy="3360711"/>
+            <a:off x="49006" y="2373538"/>
+            <a:ext cx="12093988" cy="2110923"/>
+          </a:xfrm>
+          <a:prstGeom prst="rect">
+            <a:avLst/>
+          </a:prstGeom>
+        </p:spPr>
+      </p:pic>
+      <p:sp>
+        <p:nvSpPr>
+          <p:cNvPr id="2" name="CuadroTexto 1">
+            <a:extLst>
+              <a:ext uri="{FF2B5EF4-FFF2-40B4-BE49-F238E27FC236}">
+                <a16:creationId xmlns:a16="http://schemas.microsoft.com/office/drawing/2014/main" id="{4BE15536-8584-618A-A38B-56A2C9028692}"/>
+              </a:ext>
+            </a:extLst>
+          </p:cNvPr>
+          <p:cNvSpPr txBox="1"/>
+          <p:nvPr/>
+        </p:nvSpPr>
+        <p:spPr>
+          <a:xfrm>
+            <a:off x="318426" y="445008"/>
+            <a:ext cx="11268635" cy="7048083"/>
+          </a:xfrm>
+          <a:prstGeom prst="rect">
+            <a:avLst/>
+          </a:prstGeom>
+          <a:noFill/>
+        </p:spPr>
+        <p:txBody>
+          <a:bodyPr wrap="square" rtlCol="0">
+            <a:spAutoFit/>
+          </a:bodyPr>
+          <a:lstStyle/>
+          <a:p>
+            <a:pPr algn="ctr"/>
+            <a:endParaRPr lang="es-MX" sz="3600" dirty="0">
+              <a:solidFill>
+                <a:schemeClr val="bg1"/>
+              </a:solidFill>
+            </a:endParaRPr>
+          </a:p>
+          <a:p>
+            <a:pPr algn="ctr"/>
+            <a:r>
+              <a:rPr lang="es-MX" sz="3600" dirty="0">
+                <a:solidFill>
+                  <a:schemeClr val="bg1"/>
+                </a:solidFill>
+              </a:rPr>
+              <a:t>Para </a:t>
+            </a:r>
+            <a:r>
+              <a:rPr lang="es-MX" sz="3600" b="1" dirty="0">
+                <a:solidFill>
+                  <a:schemeClr val="accent4">
+                    <a:lumMod val="60000"/>
+                    <a:lumOff val="40000"/>
+                  </a:schemeClr>
+                </a:solidFill>
+              </a:rPr>
+              <a:t>Dar de baja</a:t>
+            </a:r>
+            <a:r>
+              <a:rPr lang="es-MX" sz="3600" dirty="0">
+                <a:solidFill>
+                  <a:schemeClr val="bg1"/>
+                </a:solidFill>
+              </a:rPr>
+              <a:t> en administración del caso de clic en el botón </a:t>
+            </a:r>
+            <a:r>
+              <a:rPr lang="es-MX" sz="3600" b="1" i="1" dirty="0">
+                <a:solidFill>
+                  <a:schemeClr val="bg1"/>
+                </a:solidFill>
+              </a:rPr>
+              <a:t>Dar de baja</a:t>
+            </a:r>
+          </a:p>
+          <a:p>
+            <a:pPr algn="ctr"/>
+            <a:endParaRPr lang="es-MX" sz="3600" dirty="0">
+              <a:solidFill>
+                <a:schemeClr val="bg1"/>
+              </a:solidFill>
+            </a:endParaRPr>
+          </a:p>
+          <a:p>
+            <a:pPr algn="ctr"/>
+            <a:endParaRPr lang="es-MX" sz="3600" dirty="0">
+              <a:solidFill>
+                <a:schemeClr val="bg1"/>
+              </a:solidFill>
+            </a:endParaRPr>
+          </a:p>
+          <a:p>
+            <a:pPr algn="ctr"/>
+            <a:endParaRPr lang="es-MX" sz="3600" dirty="0">
+              <a:solidFill>
+                <a:schemeClr val="bg1"/>
+              </a:solidFill>
+            </a:endParaRPr>
+          </a:p>
+          <a:p>
+            <a:pPr algn="ctr"/>
+            <a:endParaRPr lang="es-MX" sz="3600" dirty="0">
+              <a:solidFill>
+                <a:schemeClr val="bg1"/>
+              </a:solidFill>
+            </a:endParaRPr>
+          </a:p>
+          <a:p>
+            <a:pPr algn="ctr"/>
+            <a:endParaRPr lang="es-MX" sz="3600" dirty="0">
+              <a:solidFill>
+                <a:schemeClr val="bg1"/>
+              </a:solidFill>
+            </a:endParaRPr>
+          </a:p>
+          <a:p>
+            <a:pPr algn="ctr"/>
+            <a:endParaRPr lang="es-MX" sz="3600" dirty="0">
+              <a:solidFill>
+                <a:schemeClr val="bg1"/>
+              </a:solidFill>
+            </a:endParaRPr>
+          </a:p>
+          <a:p>
+            <a:pPr algn="ctr"/>
+            <a:endParaRPr lang="es-MX" sz="3600" dirty="0">
+              <a:solidFill>
+                <a:schemeClr val="bg1"/>
+              </a:solidFill>
+            </a:endParaRPr>
+          </a:p>
+          <a:p>
+            <a:pPr algn="ctr"/>
+            <a:endParaRPr lang="es-MX" sz="3600" dirty="0">
+              <a:solidFill>
+                <a:schemeClr val="bg1"/>
+              </a:solidFill>
+            </a:endParaRPr>
+          </a:p>
+          <a:p>
+            <a:pPr algn="ctr"/>
+            <a:endParaRPr lang="es-MX" sz="3600" dirty="0">
+              <a:solidFill>
+                <a:schemeClr val="bg1"/>
+              </a:solidFill>
+            </a:endParaRPr>
+          </a:p>
+          <a:p>
+            <a:r>
+              <a:rPr lang="es-CO" sz="2000" dirty="0" err="1">
+                <a:solidFill>
+                  <a:schemeClr val="bg1"/>
+                </a:solidFill>
+              </a:rPr>
+              <a:t>Amatai</a:t>
+            </a:r>
+            <a:r>
+              <a:rPr lang="es-CO" sz="2000" dirty="0">
+                <a:solidFill>
+                  <a:schemeClr val="bg1"/>
+                </a:solidFill>
+              </a:rPr>
+              <a:t> SAS</a:t>
+            </a:r>
+          </a:p>
+        </p:txBody>
+      </p:sp>
+      <p:sp>
+        <p:nvSpPr>
+          <p:cNvPr id="9" name="Rectángulo 8">
+            <a:extLst>
+              <a:ext uri="{FF2B5EF4-FFF2-40B4-BE49-F238E27FC236}">
+                <a16:creationId xmlns:a16="http://schemas.microsoft.com/office/drawing/2014/main" id="{19CE3575-09A8-0984-60D0-CDEE01EEEB27}"/>
+              </a:ext>
+            </a:extLst>
+          </p:cNvPr>
+          <p:cNvSpPr/>
+          <p:nvPr/>
+        </p:nvSpPr>
+        <p:spPr>
+          <a:xfrm>
+            <a:off x="87005" y="3007481"/>
+            <a:ext cx="3338947" cy="696160"/>
+          </a:xfrm>
+          <a:prstGeom prst="rect">
+            <a:avLst/>
+          </a:prstGeom>
+          <a:ln>
+            <a:noFill/>
+          </a:ln>
+        </p:spPr>
+        <p:style>
+          <a:lnRef idx="2">
+            <a:schemeClr val="accent6"/>
+          </a:lnRef>
+          <a:fillRef idx="1">
+            <a:schemeClr val="lt1"/>
+          </a:fillRef>
+          <a:effectRef idx="0">
+            <a:schemeClr val="accent6"/>
+          </a:effectRef>
+          <a:fontRef idx="minor">
+            <a:schemeClr val="dk1"/>
+          </a:fontRef>
+        </p:style>
+        <p:txBody>
+          <a:bodyPr rtlCol="0" anchor="ctr"/>
+          <a:lstStyle/>
+          <a:p>
+            <a:pPr algn="ctr"/>
+            <a:endParaRPr lang="es-CO"/>
+          </a:p>
+        </p:txBody>
+      </p:sp>
+      <p:pic>
+        <p:nvPicPr>
+          <p:cNvPr id="11" name="Imagen 10">
+            <a:extLst>
+              <a:ext uri="{FF2B5EF4-FFF2-40B4-BE49-F238E27FC236}">
+                <a16:creationId xmlns:a16="http://schemas.microsoft.com/office/drawing/2014/main" id="{A19EB478-5B09-1BEA-819C-157C47F50696}"/>
+              </a:ext>
+            </a:extLst>
+          </p:cNvPr>
+          <p:cNvPicPr>
+            <a:picLocks noChangeAspect="1"/>
+          </p:cNvPicPr>
+          <p:nvPr/>
+        </p:nvPicPr>
+        <p:blipFill rotWithShape="1">
+          <a:blip r:embed="rId4"/>
+          <a:srcRect t="34649"/>
+          <a:stretch/>
+        </p:blipFill>
+        <p:spPr>
+          <a:xfrm>
+            <a:off x="318425" y="3007059"/>
+            <a:ext cx="2130959" cy="732442"/>
+          </a:xfrm>
+          <a:prstGeom prst="rect">
+            <a:avLst/>
+          </a:prstGeom>
+        </p:spPr>
+      </p:pic>
+      <p:pic>
+        <p:nvPicPr>
+          <p:cNvPr id="8" name="Gráfico 7" descr="Lupa">
+            <a:extLst>
+              <a:ext uri="{FF2B5EF4-FFF2-40B4-BE49-F238E27FC236}">
+                <a16:creationId xmlns:a16="http://schemas.microsoft.com/office/drawing/2014/main" id="{70287BDA-E56B-9DF6-26A8-A0F53C4766DE}"/>
+              </a:ext>
+            </a:extLst>
+          </p:cNvPr>
+          <p:cNvPicPr>
+            <a:picLocks noChangeAspect="1"/>
+          </p:cNvPicPr>
+          <p:nvPr/>
+        </p:nvPicPr>
+        <p:blipFill>
+          <a:blip r:embed="rId5">
+            <a:extLst>
+              <a:ext uri="{28A0092B-C50C-407E-A947-70E740481C1C}">
+                <a14:useLocalDpi xmlns:a14="http://schemas.microsoft.com/office/drawing/2010/main" val="0"/>
+              </a:ext>
+              <a:ext uri="{96DAC541-7B7A-43D3-8B79-37D633B846F1}">
+                <asvg:svgBlip xmlns:asvg="http://schemas.microsoft.com/office/drawing/2016/SVG/main" r:embed="rId6"/>
+              </a:ext>
+            </a:extLst>
+          </a:blip>
+          <a:stretch>
+            <a:fillRect/>
+          </a:stretch>
+        </p:blipFill>
+        <p:spPr>
+          <a:xfrm rot="1121602">
+            <a:off x="-379857" y="1674076"/>
+            <a:ext cx="3882034" cy="3952767"/>
           </a:xfrm>
           <a:prstGeom prst="rect">
             <a:avLst/>
@@ -6439,7 +7163,7 @@
     </p:spTree>
     <p:extLst>
       <p:ext uri="{BB962C8B-B14F-4D97-AF65-F5344CB8AC3E}">
-        <p14:creationId xmlns:p14="http://schemas.microsoft.com/office/powerpoint/2010/main" val="2790284056"/>
+        <p14:creationId xmlns:p14="http://schemas.microsoft.com/office/powerpoint/2010/main" val="1830992768"/>
       </p:ext>
     </p:extLst>
   </p:cSld>
@@ -6562,12 +7286,42 @@
           </a:p>
         </p:txBody>
       </p:sp>
-      <p:sp>
-        <p:nvSpPr>
-          <p:cNvPr id="2" name="CuadroTexto 1">
-            <a:extLst>
-              <a:ext uri="{FF2B5EF4-FFF2-40B4-BE49-F238E27FC236}">
-                <a16:creationId xmlns:a16="http://schemas.microsoft.com/office/drawing/2014/main" id="{4BE15536-8584-618A-A38B-56A2C9028692}"/>
+      <p:pic>
+        <p:nvPicPr>
+          <p:cNvPr id="5" name="Imagen 4">
+            <a:extLst>
+              <a:ext uri="{FF2B5EF4-FFF2-40B4-BE49-F238E27FC236}">
+                <a16:creationId xmlns:a16="http://schemas.microsoft.com/office/drawing/2014/main" id="{BA4C5974-D310-4C4E-4C92-272A535AA142}"/>
+              </a:ext>
+            </a:extLst>
+          </p:cNvPr>
+          <p:cNvPicPr>
+            <a:picLocks noChangeAspect="1"/>
+          </p:cNvPicPr>
+          <p:nvPr/>
+        </p:nvPicPr>
+        <p:blipFill>
+          <a:blip r:embed="rId3"/>
+          <a:stretch>
+            <a:fillRect/>
+          </a:stretch>
+        </p:blipFill>
+        <p:spPr>
+          <a:xfrm>
+            <a:off x="3605555" y="231425"/>
+            <a:ext cx="5273497" cy="5151566"/>
+          </a:xfrm>
+          <a:prstGeom prst="rect">
+            <a:avLst/>
+          </a:prstGeom>
+        </p:spPr>
+      </p:pic>
+      <p:sp>
+        <p:nvSpPr>
+          <p:cNvPr id="10" name="CuadroTexto 9">
+            <a:extLst>
+              <a:ext uri="{FF2B5EF4-FFF2-40B4-BE49-F238E27FC236}">
+                <a16:creationId xmlns:a16="http://schemas.microsoft.com/office/drawing/2014/main" id="{C69317F1-3BC8-CC98-94BA-756E40E92416}"/>
               </a:ext>
             </a:extLst>
           </p:cNvPr>
@@ -6576,8 +7330,8 @@
         </p:nvSpPr>
         <p:spPr>
           <a:xfrm>
-            <a:off x="318426" y="445008"/>
-            <a:ext cx="11268635" cy="6494085"/>
+            <a:off x="1280159" y="5503453"/>
+            <a:ext cx="9924288" cy="1200329"/>
           </a:xfrm>
           <a:prstGeom prst="rect">
             <a:avLst/>
@@ -6585,7 +7339,7 @@
           <a:noFill/>
         </p:spPr>
         <p:txBody>
-          <a:bodyPr wrap="square" rtlCol="0">
+          <a:bodyPr wrap="square">
             <a:spAutoFit/>
           </a:bodyPr>
           <a:lstStyle/>
@@ -6597,69 +7351,37 @@
                   <a:schemeClr val="bg1"/>
                 </a:solidFill>
               </a:rPr>
-              <a:t>Ahora IURIS le permite pausar los expedientes!</a:t>
-            </a:r>
-          </a:p>
-          <a:p>
-            <a:endParaRPr lang="es-MX" sz="3600" dirty="0">
+              <a:t>Ingrese una descripción y de clic en botón </a:t>
+            </a:r>
+          </a:p>
+          <a:p>
+            <a:pPr algn="ctr"/>
+            <a:r>
+              <a:rPr lang="es-MX" sz="3600" dirty="0">
+                <a:solidFill>
+                  <a:schemeClr val="accent4">
+                    <a:lumMod val="60000"/>
+                    <a:lumOff val="40000"/>
+                  </a:schemeClr>
+                </a:solidFill>
+              </a:rPr>
+              <a:t>Si, dar de baja</a:t>
+            </a:r>
+            <a:endParaRPr lang="es-MX" sz="3600" b="1" i="1" dirty="0">
               <a:solidFill>
-                <a:schemeClr val="bg1"/>
+                <a:schemeClr val="accent4">
+                  <a:lumMod val="60000"/>
+                  <a:lumOff val="40000"/>
+                </a:schemeClr>
               </a:solidFill>
             </a:endParaRPr>
-          </a:p>
-          <a:p>
-            <a:pPr algn="just"/>
-            <a:r>
-              <a:rPr lang="es-MX" sz="3600" dirty="0">
-                <a:solidFill>
-                  <a:schemeClr val="bg1"/>
-                </a:solidFill>
-              </a:rPr>
-              <a:t>Esta funcionalidad pone en pausa el tiempo de evaluación de actuaciones en aquellos expedientes abiertos que no tendrán actuaciones en un lapso determinado de tiempo.</a:t>
-            </a:r>
-          </a:p>
-          <a:p>
-            <a:endParaRPr lang="es-MX" sz="3600" dirty="0"/>
-          </a:p>
-          <a:p>
-            <a:endParaRPr lang="es-MX" sz="3600" dirty="0"/>
-          </a:p>
-          <a:p>
-            <a:endParaRPr lang="es-MX" sz="3600" dirty="0"/>
-          </a:p>
-          <a:p>
-            <a:endParaRPr lang="es-MX" sz="3600" dirty="0"/>
-          </a:p>
-          <a:p>
-            <a:endParaRPr lang="es-MX" sz="3600" dirty="0"/>
-          </a:p>
-          <a:p>
-            <a:endParaRPr lang="es-MX" sz="3600" dirty="0"/>
-          </a:p>
-          <a:p>
-            <a:r>
-              <a:rPr lang="es-CO" sz="2000" dirty="0" err="1">
-                <a:solidFill>
-                  <a:schemeClr val="bg1"/>
-                </a:solidFill>
-              </a:rPr>
-              <a:t>Amatai</a:t>
-            </a:r>
-            <a:r>
-              <a:rPr lang="es-CO" sz="2000" dirty="0">
-                <a:solidFill>
-                  <a:schemeClr val="bg1"/>
-                </a:solidFill>
-              </a:rPr>
-              <a:t> SAS</a:t>
-            </a:r>
           </a:p>
         </p:txBody>
       </p:sp>
     </p:spTree>
     <p:extLst>
       <p:ext uri="{BB962C8B-B14F-4D97-AF65-F5344CB8AC3E}">
-        <p14:creationId xmlns:p14="http://schemas.microsoft.com/office/powerpoint/2010/main" val="3888979096"/>
+        <p14:creationId xmlns:p14="http://schemas.microsoft.com/office/powerpoint/2010/main" val="1612107509"/>
       </p:ext>
     </p:extLst>
   </p:cSld>

</xml_diff>